<commit_message>
#remove outdated presentation images and add new visual assets for improved documentation #pbi report development
</commit_message>
<xml_diff>
--- a/powerbi/Presentation1.pptx
+++ b/powerbi/Presentation1.pptx
@@ -4,8 +4,15 @@
   <p:sldMasterIdLst>
     <p:sldMasterId id="2147483648" r:id="rId1"/>
   </p:sldMasterIdLst>
+  <p:notesMasterIdLst>
+    <p:notesMasterId r:id="rId7"/>
+  </p:notesMasterIdLst>
   <p:sldIdLst>
-    <p:sldId id="256" r:id="rId2"/>
+    <p:sldId id="261" r:id="rId2"/>
+    <p:sldId id="262" r:id="rId3"/>
+    <p:sldId id="263" r:id="rId4"/>
+    <p:sldId id="264" r:id="rId5"/>
+    <p:sldId id="265" r:id="rId6"/>
   </p:sldIdLst>
   <p:sldSz cx="12192000" cy="6858000"/>
   <p:notesSz cx="6858000" cy="9144000"/>
@@ -112,6 +119,863 @@
 </p:presentation>
 </file>
 
+<file path=ppt/notesMasters/notesMaster1.xml><?xml version="1.0" encoding="utf-8"?>
+<p:notesMaster xmlns:a="http://schemas.openxmlformats.org/drawingml/2006/main" xmlns:r="http://schemas.openxmlformats.org/officeDocument/2006/relationships" xmlns:p="http://schemas.openxmlformats.org/presentationml/2006/main">
+  <p:cSld>
+    <p:bg>
+      <p:bgRef idx="1001">
+        <a:schemeClr val="bg1"/>
+      </p:bgRef>
+    </p:bg>
+    <p:spTree>
+      <p:nvGrpSpPr>
+        <p:cNvPr id="1" name=""/>
+        <p:cNvGrpSpPr/>
+        <p:nvPr/>
+      </p:nvGrpSpPr>
+      <p:grpSpPr>
+        <a:xfrm>
+          <a:off x="0" y="0"/>
+          <a:ext cx="0" cy="0"/>
+          <a:chOff x="0" y="0"/>
+          <a:chExt cx="0" cy="0"/>
+        </a:xfrm>
+      </p:grpSpPr>
+      <p:sp>
+        <p:nvSpPr>
+          <p:cNvPr id="2" name="Header Placeholder 1"/>
+          <p:cNvSpPr>
+            <a:spLocks noGrp="1"/>
+          </p:cNvSpPr>
+          <p:nvPr>
+            <p:ph type="hdr" sz="quarter"/>
+          </p:nvPr>
+        </p:nvSpPr>
+        <p:spPr>
+          <a:xfrm>
+            <a:off x="0" y="0"/>
+            <a:ext cx="2971800" cy="458788"/>
+          </a:xfrm>
+          <a:prstGeom prst="rect">
+            <a:avLst/>
+          </a:prstGeom>
+        </p:spPr>
+        <p:txBody>
+          <a:bodyPr vert="horz" lIns="91440" tIns="45720" rIns="91440" bIns="45720" rtlCol="0"/>
+          <a:lstStyle>
+            <a:lvl1pPr algn="l">
+              <a:defRPr sz="1200"/>
+            </a:lvl1pPr>
+          </a:lstStyle>
+          <a:p>
+            <a:endParaRPr lang="pl-PL"/>
+          </a:p>
+        </p:txBody>
+      </p:sp>
+      <p:sp>
+        <p:nvSpPr>
+          <p:cNvPr id="3" name="Date Placeholder 2"/>
+          <p:cNvSpPr>
+            <a:spLocks noGrp="1"/>
+          </p:cNvSpPr>
+          <p:nvPr>
+            <p:ph type="dt" idx="1"/>
+          </p:nvPr>
+        </p:nvSpPr>
+        <p:spPr>
+          <a:xfrm>
+            <a:off x="3884613" y="0"/>
+            <a:ext cx="2971800" cy="458788"/>
+          </a:xfrm>
+          <a:prstGeom prst="rect">
+            <a:avLst/>
+          </a:prstGeom>
+        </p:spPr>
+        <p:txBody>
+          <a:bodyPr vert="horz" lIns="91440" tIns="45720" rIns="91440" bIns="45720" rtlCol="0"/>
+          <a:lstStyle>
+            <a:lvl1pPr algn="r">
+              <a:defRPr sz="1200"/>
+            </a:lvl1pPr>
+          </a:lstStyle>
+          <a:p>
+            <a:fld id="{3A46DB9E-BE6D-4245-ACDF-7CCB7B40890D}" type="datetimeFigureOut">
+              <a:rPr lang="pl-PL" smtClean="0"/>
+              <a:t>4.10.2026</a:t>
+            </a:fld>
+            <a:endParaRPr lang="pl-PL"/>
+          </a:p>
+        </p:txBody>
+      </p:sp>
+      <p:sp>
+        <p:nvSpPr>
+          <p:cNvPr id="4" name="Slide Image Placeholder 3"/>
+          <p:cNvSpPr>
+            <a:spLocks noGrp="1" noRot="1" noChangeAspect="1"/>
+          </p:cNvSpPr>
+          <p:nvPr>
+            <p:ph type="sldImg" idx="2"/>
+          </p:nvPr>
+        </p:nvSpPr>
+        <p:spPr>
+          <a:xfrm>
+            <a:off x="685800" y="1143000"/>
+            <a:ext cx="5486400" cy="3086100"/>
+          </a:xfrm>
+          <a:prstGeom prst="rect">
+            <a:avLst/>
+          </a:prstGeom>
+          <a:noFill/>
+          <a:ln w="12700">
+            <a:solidFill>
+              <a:prstClr val="black"/>
+            </a:solidFill>
+          </a:ln>
+        </p:spPr>
+        <p:txBody>
+          <a:bodyPr vert="horz" lIns="91440" tIns="45720" rIns="91440" bIns="45720" rtlCol="0" anchor="ctr"/>
+          <a:lstStyle/>
+          <a:p>
+            <a:endParaRPr lang="pl-PL"/>
+          </a:p>
+        </p:txBody>
+      </p:sp>
+      <p:sp>
+        <p:nvSpPr>
+          <p:cNvPr id="5" name="Notes Placeholder 4"/>
+          <p:cNvSpPr>
+            <a:spLocks noGrp="1"/>
+          </p:cNvSpPr>
+          <p:nvPr>
+            <p:ph type="body" sz="quarter" idx="3"/>
+          </p:nvPr>
+        </p:nvSpPr>
+        <p:spPr>
+          <a:xfrm>
+            <a:off x="685800" y="4400550"/>
+            <a:ext cx="5486400" cy="3600450"/>
+          </a:xfrm>
+          <a:prstGeom prst="rect">
+            <a:avLst/>
+          </a:prstGeom>
+        </p:spPr>
+        <p:txBody>
+          <a:bodyPr vert="horz" lIns="91440" tIns="45720" rIns="91440" bIns="45720" rtlCol="0"/>
+          <a:lstStyle/>
+          <a:p>
+            <a:pPr lvl="0"/>
+            <a:r>
+              <a:rPr lang="en-US"/>
+              <a:t>Click to edit Master text styles</a:t>
+            </a:r>
+          </a:p>
+          <a:p>
+            <a:pPr lvl="1"/>
+            <a:r>
+              <a:rPr lang="en-US"/>
+              <a:t>Second level</a:t>
+            </a:r>
+          </a:p>
+          <a:p>
+            <a:pPr lvl="2"/>
+            <a:r>
+              <a:rPr lang="en-US"/>
+              <a:t>Third level</a:t>
+            </a:r>
+          </a:p>
+          <a:p>
+            <a:pPr lvl="3"/>
+            <a:r>
+              <a:rPr lang="en-US"/>
+              <a:t>Fourth level</a:t>
+            </a:r>
+          </a:p>
+          <a:p>
+            <a:pPr lvl="4"/>
+            <a:r>
+              <a:rPr lang="en-US"/>
+              <a:t>Fifth level</a:t>
+            </a:r>
+            <a:endParaRPr lang="pl-PL"/>
+          </a:p>
+        </p:txBody>
+      </p:sp>
+      <p:sp>
+        <p:nvSpPr>
+          <p:cNvPr id="6" name="Footer Placeholder 5"/>
+          <p:cNvSpPr>
+            <a:spLocks noGrp="1"/>
+          </p:cNvSpPr>
+          <p:nvPr>
+            <p:ph type="ftr" sz="quarter" idx="4"/>
+          </p:nvPr>
+        </p:nvSpPr>
+        <p:spPr>
+          <a:xfrm>
+            <a:off x="0" y="8685213"/>
+            <a:ext cx="2971800" cy="458787"/>
+          </a:xfrm>
+          <a:prstGeom prst="rect">
+            <a:avLst/>
+          </a:prstGeom>
+        </p:spPr>
+        <p:txBody>
+          <a:bodyPr vert="horz" lIns="91440" tIns="45720" rIns="91440" bIns="45720" rtlCol="0" anchor="b"/>
+          <a:lstStyle>
+            <a:lvl1pPr algn="l">
+              <a:defRPr sz="1200"/>
+            </a:lvl1pPr>
+          </a:lstStyle>
+          <a:p>
+            <a:endParaRPr lang="pl-PL"/>
+          </a:p>
+        </p:txBody>
+      </p:sp>
+      <p:sp>
+        <p:nvSpPr>
+          <p:cNvPr id="7" name="Slide Number Placeholder 6"/>
+          <p:cNvSpPr>
+            <a:spLocks noGrp="1"/>
+          </p:cNvSpPr>
+          <p:nvPr>
+            <p:ph type="sldNum" sz="quarter" idx="5"/>
+          </p:nvPr>
+        </p:nvSpPr>
+        <p:spPr>
+          <a:xfrm>
+            <a:off x="3884613" y="8685213"/>
+            <a:ext cx="2971800" cy="458787"/>
+          </a:xfrm>
+          <a:prstGeom prst="rect">
+            <a:avLst/>
+          </a:prstGeom>
+        </p:spPr>
+        <p:txBody>
+          <a:bodyPr vert="horz" lIns="91440" tIns="45720" rIns="91440" bIns="45720" rtlCol="0" anchor="b"/>
+          <a:lstStyle>
+            <a:lvl1pPr algn="r">
+              <a:defRPr sz="1200"/>
+            </a:lvl1pPr>
+          </a:lstStyle>
+          <a:p>
+            <a:fld id="{71B83942-C7F4-4EA4-9A8B-6359B9310C95}" type="slidenum">
+              <a:rPr lang="pl-PL" smtClean="0"/>
+              <a:t>‹#›</a:t>
+            </a:fld>
+            <a:endParaRPr lang="pl-PL"/>
+          </a:p>
+        </p:txBody>
+      </p:sp>
+    </p:spTree>
+    <p:extLst>
+      <p:ext uri="{BB962C8B-B14F-4D97-AF65-F5344CB8AC3E}">
+        <p14:creationId xmlns:p14="http://schemas.microsoft.com/office/powerpoint/2010/main" val="2864271139"/>
+      </p:ext>
+    </p:extLst>
+  </p:cSld>
+  <p:clrMap bg1="lt1" tx1="dk1" bg2="lt2" tx2="dk2" accent1="accent1" accent2="accent2" accent3="accent3" accent4="accent4" accent5="accent5" accent6="accent6" hlink="hlink" folHlink="folHlink"/>
+  <p:notesStyle>
+    <a:lvl1pPr marL="0" algn="l" defTabSz="914400" rtl="0" eaLnBrk="1" latinLnBrk="0" hangingPunct="1">
+      <a:defRPr sz="1200" kern="1200">
+        <a:solidFill>
+          <a:schemeClr val="tx1"/>
+        </a:solidFill>
+        <a:latin typeface="+mn-lt"/>
+        <a:ea typeface="+mn-ea"/>
+        <a:cs typeface="+mn-cs"/>
+      </a:defRPr>
+    </a:lvl1pPr>
+    <a:lvl2pPr marL="457200" algn="l" defTabSz="914400" rtl="0" eaLnBrk="1" latinLnBrk="0" hangingPunct="1">
+      <a:defRPr sz="1200" kern="1200">
+        <a:solidFill>
+          <a:schemeClr val="tx1"/>
+        </a:solidFill>
+        <a:latin typeface="+mn-lt"/>
+        <a:ea typeface="+mn-ea"/>
+        <a:cs typeface="+mn-cs"/>
+      </a:defRPr>
+    </a:lvl2pPr>
+    <a:lvl3pPr marL="914400" algn="l" defTabSz="914400" rtl="0" eaLnBrk="1" latinLnBrk="0" hangingPunct="1">
+      <a:defRPr sz="1200" kern="1200">
+        <a:solidFill>
+          <a:schemeClr val="tx1"/>
+        </a:solidFill>
+        <a:latin typeface="+mn-lt"/>
+        <a:ea typeface="+mn-ea"/>
+        <a:cs typeface="+mn-cs"/>
+      </a:defRPr>
+    </a:lvl3pPr>
+    <a:lvl4pPr marL="1371600" algn="l" defTabSz="914400" rtl="0" eaLnBrk="1" latinLnBrk="0" hangingPunct="1">
+      <a:defRPr sz="1200" kern="1200">
+        <a:solidFill>
+          <a:schemeClr val="tx1"/>
+        </a:solidFill>
+        <a:latin typeface="+mn-lt"/>
+        <a:ea typeface="+mn-ea"/>
+        <a:cs typeface="+mn-cs"/>
+      </a:defRPr>
+    </a:lvl4pPr>
+    <a:lvl5pPr marL="1828800" algn="l" defTabSz="914400" rtl="0" eaLnBrk="1" latinLnBrk="0" hangingPunct="1">
+      <a:defRPr sz="1200" kern="1200">
+        <a:solidFill>
+          <a:schemeClr val="tx1"/>
+        </a:solidFill>
+        <a:latin typeface="+mn-lt"/>
+        <a:ea typeface="+mn-ea"/>
+        <a:cs typeface="+mn-cs"/>
+      </a:defRPr>
+    </a:lvl5pPr>
+    <a:lvl6pPr marL="2286000" algn="l" defTabSz="914400" rtl="0" eaLnBrk="1" latinLnBrk="0" hangingPunct="1">
+      <a:defRPr sz="1200" kern="1200">
+        <a:solidFill>
+          <a:schemeClr val="tx1"/>
+        </a:solidFill>
+        <a:latin typeface="+mn-lt"/>
+        <a:ea typeface="+mn-ea"/>
+        <a:cs typeface="+mn-cs"/>
+      </a:defRPr>
+    </a:lvl6pPr>
+    <a:lvl7pPr marL="2743200" algn="l" defTabSz="914400" rtl="0" eaLnBrk="1" latinLnBrk="0" hangingPunct="1">
+      <a:defRPr sz="1200" kern="1200">
+        <a:solidFill>
+          <a:schemeClr val="tx1"/>
+        </a:solidFill>
+        <a:latin typeface="+mn-lt"/>
+        <a:ea typeface="+mn-ea"/>
+        <a:cs typeface="+mn-cs"/>
+      </a:defRPr>
+    </a:lvl7pPr>
+    <a:lvl8pPr marL="3200400" algn="l" defTabSz="914400" rtl="0" eaLnBrk="1" latinLnBrk="0" hangingPunct="1">
+      <a:defRPr sz="1200" kern="1200">
+        <a:solidFill>
+          <a:schemeClr val="tx1"/>
+        </a:solidFill>
+        <a:latin typeface="+mn-lt"/>
+        <a:ea typeface="+mn-ea"/>
+        <a:cs typeface="+mn-cs"/>
+      </a:defRPr>
+    </a:lvl8pPr>
+    <a:lvl9pPr marL="3657600" algn="l" defTabSz="914400" rtl="0" eaLnBrk="1" latinLnBrk="0" hangingPunct="1">
+      <a:defRPr sz="1200" kern="1200">
+        <a:solidFill>
+          <a:schemeClr val="tx1"/>
+        </a:solidFill>
+        <a:latin typeface="+mn-lt"/>
+        <a:ea typeface="+mn-ea"/>
+        <a:cs typeface="+mn-cs"/>
+      </a:defRPr>
+    </a:lvl9pPr>
+  </p:notesStyle>
+</p:notesMaster>
+</file>
+
+<file path=ppt/notesSlides/notesSlide1.xml><?xml version="1.0" encoding="utf-8"?>
+<p:notes xmlns:a="http://schemas.openxmlformats.org/drawingml/2006/main" xmlns:r="http://schemas.openxmlformats.org/officeDocument/2006/relationships" xmlns:p="http://schemas.openxmlformats.org/presentationml/2006/main">
+  <p:cSld>
+    <p:spTree>
+      <p:nvGrpSpPr>
+        <p:cNvPr id="1" name=""/>
+        <p:cNvGrpSpPr/>
+        <p:nvPr/>
+      </p:nvGrpSpPr>
+      <p:grpSpPr>
+        <a:xfrm>
+          <a:off x="0" y="0"/>
+          <a:ext cx="0" cy="0"/>
+          <a:chOff x="0" y="0"/>
+          <a:chExt cx="0" cy="0"/>
+        </a:xfrm>
+      </p:grpSpPr>
+      <p:sp>
+        <p:nvSpPr>
+          <p:cNvPr id="2" name="Slide Image Placeholder 1"/>
+          <p:cNvSpPr>
+            <a:spLocks noGrp="1" noRot="1" noChangeAspect="1"/>
+          </p:cNvSpPr>
+          <p:nvPr>
+            <p:ph type="sldImg"/>
+          </p:nvPr>
+        </p:nvSpPr>
+        <p:spPr/>
+      </p:sp>
+      <p:sp>
+        <p:nvSpPr>
+          <p:cNvPr id="3" name="Notes Placeholder 2"/>
+          <p:cNvSpPr>
+            <a:spLocks noGrp="1"/>
+          </p:cNvSpPr>
+          <p:nvPr>
+            <p:ph type="body" idx="1"/>
+          </p:nvPr>
+        </p:nvSpPr>
+        <p:spPr/>
+        <p:txBody>
+          <a:bodyPr/>
+          <a:lstStyle/>
+          <a:p>
+            <a:r>
+              <a:rPr lang="pl-PL" dirty="0"/>
+              <a:t>Executive Overview</a:t>
+            </a:r>
+          </a:p>
+        </p:txBody>
+      </p:sp>
+      <p:sp>
+        <p:nvSpPr>
+          <p:cNvPr id="4" name="Slide Number Placeholder 3"/>
+          <p:cNvSpPr>
+            <a:spLocks noGrp="1"/>
+          </p:cNvSpPr>
+          <p:nvPr>
+            <p:ph type="sldNum" sz="quarter" idx="5"/>
+          </p:nvPr>
+        </p:nvSpPr>
+        <p:spPr/>
+        <p:txBody>
+          <a:bodyPr/>
+          <a:lstStyle/>
+          <a:p>
+            <a:fld id="{71B83942-C7F4-4EA4-9A8B-6359B9310C95}" type="slidenum">
+              <a:rPr lang="pl-PL" smtClean="0"/>
+              <a:t>1</a:t>
+            </a:fld>
+            <a:endParaRPr lang="pl-PL"/>
+          </a:p>
+        </p:txBody>
+      </p:sp>
+    </p:spTree>
+    <p:extLst>
+      <p:ext uri="{BB962C8B-B14F-4D97-AF65-F5344CB8AC3E}">
+        <p14:creationId xmlns:p14="http://schemas.microsoft.com/office/powerpoint/2010/main" val="1684378289"/>
+      </p:ext>
+    </p:extLst>
+  </p:cSld>
+  <p:clrMapOvr>
+    <a:masterClrMapping/>
+  </p:clrMapOvr>
+</p:notes>
+</file>
+
+<file path=ppt/notesSlides/notesSlide2.xml><?xml version="1.0" encoding="utf-8"?>
+<p:notes xmlns:a="http://schemas.openxmlformats.org/drawingml/2006/main" xmlns:r="http://schemas.openxmlformats.org/officeDocument/2006/relationships" xmlns:p="http://schemas.openxmlformats.org/presentationml/2006/main">
+  <p:cSld>
+    <p:spTree>
+      <p:nvGrpSpPr>
+        <p:cNvPr id="1" name=""/>
+        <p:cNvGrpSpPr/>
+        <p:nvPr/>
+      </p:nvGrpSpPr>
+      <p:grpSpPr>
+        <a:xfrm>
+          <a:off x="0" y="0"/>
+          <a:ext cx="0" cy="0"/>
+          <a:chOff x="0" y="0"/>
+          <a:chExt cx="0" cy="0"/>
+        </a:xfrm>
+      </p:grpSpPr>
+      <p:sp>
+        <p:nvSpPr>
+          <p:cNvPr id="2" name="Slide Image Placeholder 1"/>
+          <p:cNvSpPr>
+            <a:spLocks noGrp="1" noRot="1" noChangeAspect="1"/>
+          </p:cNvSpPr>
+          <p:nvPr>
+            <p:ph type="sldImg"/>
+          </p:nvPr>
+        </p:nvSpPr>
+        <p:spPr/>
+      </p:sp>
+      <p:sp>
+        <p:nvSpPr>
+          <p:cNvPr id="3" name="Notes Placeholder 2"/>
+          <p:cNvSpPr>
+            <a:spLocks noGrp="1"/>
+          </p:cNvSpPr>
+          <p:nvPr>
+            <p:ph type="body" idx="1"/>
+          </p:nvPr>
+        </p:nvSpPr>
+        <p:spPr/>
+        <p:txBody>
+          <a:bodyPr/>
+          <a:lstStyle/>
+          <a:p>
+            <a:r>
+              <a:rPr lang="pl-PL" dirty="0"/>
+              <a:t>Customer Segments</a:t>
+            </a:r>
+          </a:p>
+        </p:txBody>
+      </p:sp>
+      <p:sp>
+        <p:nvSpPr>
+          <p:cNvPr id="4" name="Slide Number Placeholder 3"/>
+          <p:cNvSpPr>
+            <a:spLocks noGrp="1"/>
+          </p:cNvSpPr>
+          <p:nvPr>
+            <p:ph type="sldNum" sz="quarter" idx="5"/>
+          </p:nvPr>
+        </p:nvSpPr>
+        <p:spPr/>
+        <p:txBody>
+          <a:bodyPr/>
+          <a:lstStyle/>
+          <a:p>
+            <a:fld id="{71B83942-C7F4-4EA4-9A8B-6359B9310C95}" type="slidenum">
+              <a:rPr lang="pl-PL" smtClean="0"/>
+              <a:t>2</a:t>
+            </a:fld>
+            <a:endParaRPr lang="pl-PL"/>
+          </a:p>
+        </p:txBody>
+      </p:sp>
+    </p:spTree>
+    <p:extLst>
+      <p:ext uri="{BB962C8B-B14F-4D97-AF65-F5344CB8AC3E}">
+        <p14:creationId xmlns:p14="http://schemas.microsoft.com/office/powerpoint/2010/main" val="1927127581"/>
+      </p:ext>
+    </p:extLst>
+  </p:cSld>
+  <p:clrMapOvr>
+    <a:masterClrMapping/>
+  </p:clrMapOvr>
+</p:notes>
+</file>
+
+<file path=ppt/notesSlides/notesSlide3.xml><?xml version="1.0" encoding="utf-8"?>
+<p:notes xmlns:a="http://schemas.openxmlformats.org/drawingml/2006/main" xmlns:r="http://schemas.openxmlformats.org/officeDocument/2006/relationships" xmlns:p="http://schemas.openxmlformats.org/presentationml/2006/main">
+  <p:cSld>
+    <p:spTree>
+      <p:nvGrpSpPr>
+        <p:cNvPr id="1" name="">
+          <a:extLst>
+            <a:ext uri="{FF2B5EF4-FFF2-40B4-BE49-F238E27FC236}">
+              <a16:creationId xmlns:a16="http://schemas.microsoft.com/office/drawing/2014/main" id="{07129E4E-2907-5707-0284-25DC405A07E8}"/>
+            </a:ext>
+          </a:extLst>
+        </p:cNvPr>
+        <p:cNvGrpSpPr/>
+        <p:nvPr/>
+      </p:nvGrpSpPr>
+      <p:grpSpPr>
+        <a:xfrm>
+          <a:off x="0" y="0"/>
+          <a:ext cx="0" cy="0"/>
+          <a:chOff x="0" y="0"/>
+          <a:chExt cx="0" cy="0"/>
+        </a:xfrm>
+      </p:grpSpPr>
+      <p:sp>
+        <p:nvSpPr>
+          <p:cNvPr id="2" name="Slide Image Placeholder 1">
+            <a:extLst>
+              <a:ext uri="{FF2B5EF4-FFF2-40B4-BE49-F238E27FC236}">
+                <a16:creationId xmlns:a16="http://schemas.microsoft.com/office/drawing/2014/main" id="{05F9A7A4-82B4-E2AB-3C3E-9DF867A160E9}"/>
+              </a:ext>
+            </a:extLst>
+          </p:cNvPr>
+          <p:cNvSpPr>
+            <a:spLocks noGrp="1" noRot="1" noChangeAspect="1"/>
+          </p:cNvSpPr>
+          <p:nvPr>
+            <p:ph type="sldImg"/>
+          </p:nvPr>
+        </p:nvSpPr>
+        <p:spPr/>
+      </p:sp>
+      <p:sp>
+        <p:nvSpPr>
+          <p:cNvPr id="3" name="Notes Placeholder 2">
+            <a:extLst>
+              <a:ext uri="{FF2B5EF4-FFF2-40B4-BE49-F238E27FC236}">
+                <a16:creationId xmlns:a16="http://schemas.microsoft.com/office/drawing/2014/main" id="{51F12EDE-CC3A-302B-7ED3-8AAEB9CEE768}"/>
+              </a:ext>
+            </a:extLst>
+          </p:cNvPr>
+          <p:cNvSpPr>
+            <a:spLocks noGrp="1"/>
+          </p:cNvSpPr>
+          <p:nvPr>
+            <p:ph type="body" idx="1"/>
+          </p:nvPr>
+        </p:nvSpPr>
+        <p:spPr/>
+        <p:txBody>
+          <a:bodyPr/>
+          <a:lstStyle/>
+          <a:p>
+            <a:r>
+              <a:rPr lang="pl-PL" dirty="0"/>
+              <a:t>Merchant Performance</a:t>
+            </a:r>
+          </a:p>
+        </p:txBody>
+      </p:sp>
+      <p:sp>
+        <p:nvSpPr>
+          <p:cNvPr id="4" name="Slide Number Placeholder 3">
+            <a:extLst>
+              <a:ext uri="{FF2B5EF4-FFF2-40B4-BE49-F238E27FC236}">
+                <a16:creationId xmlns:a16="http://schemas.microsoft.com/office/drawing/2014/main" id="{8EA38DB6-94A3-D45E-7E81-7E18B446F334}"/>
+              </a:ext>
+            </a:extLst>
+          </p:cNvPr>
+          <p:cNvSpPr>
+            <a:spLocks noGrp="1"/>
+          </p:cNvSpPr>
+          <p:nvPr>
+            <p:ph type="sldNum" sz="quarter" idx="5"/>
+          </p:nvPr>
+        </p:nvSpPr>
+        <p:spPr/>
+        <p:txBody>
+          <a:bodyPr/>
+          <a:lstStyle/>
+          <a:p>
+            <a:fld id="{71B83942-C7F4-4EA4-9A8B-6359B9310C95}" type="slidenum">
+              <a:rPr lang="pl-PL" smtClean="0"/>
+              <a:t>3</a:t>
+            </a:fld>
+            <a:endParaRPr lang="pl-PL"/>
+          </a:p>
+        </p:txBody>
+      </p:sp>
+    </p:spTree>
+    <p:extLst>
+      <p:ext uri="{BB962C8B-B14F-4D97-AF65-F5344CB8AC3E}">
+        <p14:creationId xmlns:p14="http://schemas.microsoft.com/office/powerpoint/2010/main" val="2641905035"/>
+      </p:ext>
+    </p:extLst>
+  </p:cSld>
+  <p:clrMapOvr>
+    <a:masterClrMapping/>
+  </p:clrMapOvr>
+</p:notes>
+</file>
+
+<file path=ppt/notesSlides/notesSlide4.xml><?xml version="1.0" encoding="utf-8"?>
+<p:notes xmlns:a="http://schemas.openxmlformats.org/drawingml/2006/main" xmlns:r="http://schemas.openxmlformats.org/officeDocument/2006/relationships" xmlns:p="http://schemas.openxmlformats.org/presentationml/2006/main">
+  <p:cSld>
+    <p:spTree>
+      <p:nvGrpSpPr>
+        <p:cNvPr id="1" name="">
+          <a:extLst>
+            <a:ext uri="{FF2B5EF4-FFF2-40B4-BE49-F238E27FC236}">
+              <a16:creationId xmlns:a16="http://schemas.microsoft.com/office/drawing/2014/main" id="{0DC75FCE-F724-620B-CC57-1CAE983817CB}"/>
+            </a:ext>
+          </a:extLst>
+        </p:cNvPr>
+        <p:cNvGrpSpPr/>
+        <p:nvPr/>
+      </p:nvGrpSpPr>
+      <p:grpSpPr>
+        <a:xfrm>
+          <a:off x="0" y="0"/>
+          <a:ext cx="0" cy="0"/>
+          <a:chOff x="0" y="0"/>
+          <a:chExt cx="0" cy="0"/>
+        </a:xfrm>
+      </p:grpSpPr>
+      <p:sp>
+        <p:nvSpPr>
+          <p:cNvPr id="2" name="Slide Image Placeholder 1">
+            <a:extLst>
+              <a:ext uri="{FF2B5EF4-FFF2-40B4-BE49-F238E27FC236}">
+                <a16:creationId xmlns:a16="http://schemas.microsoft.com/office/drawing/2014/main" id="{420E020B-078D-FB6A-7F36-99D88BE44EA5}"/>
+              </a:ext>
+            </a:extLst>
+          </p:cNvPr>
+          <p:cNvSpPr>
+            <a:spLocks noGrp="1" noRot="1" noChangeAspect="1"/>
+          </p:cNvSpPr>
+          <p:nvPr>
+            <p:ph type="sldImg"/>
+          </p:nvPr>
+        </p:nvSpPr>
+        <p:spPr/>
+      </p:sp>
+      <p:sp>
+        <p:nvSpPr>
+          <p:cNvPr id="3" name="Notes Placeholder 2">
+            <a:extLst>
+              <a:ext uri="{FF2B5EF4-FFF2-40B4-BE49-F238E27FC236}">
+                <a16:creationId xmlns:a16="http://schemas.microsoft.com/office/drawing/2014/main" id="{1EC3D31A-9008-70A9-6C7B-A56216FBB1DE}"/>
+              </a:ext>
+            </a:extLst>
+          </p:cNvPr>
+          <p:cNvSpPr>
+            <a:spLocks noGrp="1"/>
+          </p:cNvSpPr>
+          <p:nvPr>
+            <p:ph type="body" idx="1"/>
+          </p:nvPr>
+        </p:nvSpPr>
+        <p:spPr/>
+        <p:txBody>
+          <a:bodyPr/>
+          <a:lstStyle/>
+          <a:p>
+            <a:r>
+              <a:rPr lang="pl-PL" dirty="0"/>
+              <a:t>Customer Health</a:t>
+            </a:r>
+          </a:p>
+        </p:txBody>
+      </p:sp>
+      <p:sp>
+        <p:nvSpPr>
+          <p:cNvPr id="4" name="Slide Number Placeholder 3">
+            <a:extLst>
+              <a:ext uri="{FF2B5EF4-FFF2-40B4-BE49-F238E27FC236}">
+                <a16:creationId xmlns:a16="http://schemas.microsoft.com/office/drawing/2014/main" id="{6EB724B9-11AC-BA27-0E38-F6CE966A4EAA}"/>
+              </a:ext>
+            </a:extLst>
+          </p:cNvPr>
+          <p:cNvSpPr>
+            <a:spLocks noGrp="1"/>
+          </p:cNvSpPr>
+          <p:nvPr>
+            <p:ph type="sldNum" sz="quarter" idx="5"/>
+          </p:nvPr>
+        </p:nvSpPr>
+        <p:spPr/>
+        <p:txBody>
+          <a:bodyPr/>
+          <a:lstStyle/>
+          <a:p>
+            <a:fld id="{71B83942-C7F4-4EA4-9A8B-6359B9310C95}" type="slidenum">
+              <a:rPr lang="pl-PL" smtClean="0"/>
+              <a:t>4</a:t>
+            </a:fld>
+            <a:endParaRPr lang="pl-PL"/>
+          </a:p>
+        </p:txBody>
+      </p:sp>
+    </p:spTree>
+    <p:extLst>
+      <p:ext uri="{BB962C8B-B14F-4D97-AF65-F5344CB8AC3E}">
+        <p14:creationId xmlns:p14="http://schemas.microsoft.com/office/powerpoint/2010/main" val="1052018426"/>
+      </p:ext>
+    </p:extLst>
+  </p:cSld>
+  <p:clrMapOvr>
+    <a:masterClrMapping/>
+  </p:clrMapOvr>
+</p:notes>
+</file>
+
+<file path=ppt/notesSlides/notesSlide5.xml><?xml version="1.0" encoding="utf-8"?>
+<p:notes xmlns:a="http://schemas.openxmlformats.org/drawingml/2006/main" xmlns:r="http://schemas.openxmlformats.org/officeDocument/2006/relationships" xmlns:p="http://schemas.openxmlformats.org/presentationml/2006/main">
+  <p:cSld>
+    <p:spTree>
+      <p:nvGrpSpPr>
+        <p:cNvPr id="1" name="">
+          <a:extLst>
+            <a:ext uri="{FF2B5EF4-FFF2-40B4-BE49-F238E27FC236}">
+              <a16:creationId xmlns:a16="http://schemas.microsoft.com/office/drawing/2014/main" id="{703F7724-EF77-8C0F-87E4-372319DE5B12}"/>
+            </a:ext>
+          </a:extLst>
+        </p:cNvPr>
+        <p:cNvGrpSpPr/>
+        <p:nvPr/>
+      </p:nvGrpSpPr>
+      <p:grpSpPr>
+        <a:xfrm>
+          <a:off x="0" y="0"/>
+          <a:ext cx="0" cy="0"/>
+          <a:chOff x="0" y="0"/>
+          <a:chExt cx="0" cy="0"/>
+        </a:xfrm>
+      </p:grpSpPr>
+      <p:sp>
+        <p:nvSpPr>
+          <p:cNvPr id="2" name="Slide Image Placeholder 1">
+            <a:extLst>
+              <a:ext uri="{FF2B5EF4-FFF2-40B4-BE49-F238E27FC236}">
+                <a16:creationId xmlns:a16="http://schemas.microsoft.com/office/drawing/2014/main" id="{078875F2-3807-4D01-5A8B-32E1AC135D4B}"/>
+              </a:ext>
+            </a:extLst>
+          </p:cNvPr>
+          <p:cNvSpPr>
+            <a:spLocks noGrp="1" noRot="1" noChangeAspect="1"/>
+          </p:cNvSpPr>
+          <p:nvPr>
+            <p:ph type="sldImg"/>
+          </p:nvPr>
+        </p:nvSpPr>
+        <p:spPr/>
+      </p:sp>
+      <p:sp>
+        <p:nvSpPr>
+          <p:cNvPr id="3" name="Notes Placeholder 2">
+            <a:extLst>
+              <a:ext uri="{FF2B5EF4-FFF2-40B4-BE49-F238E27FC236}">
+                <a16:creationId xmlns:a16="http://schemas.microsoft.com/office/drawing/2014/main" id="{16AAC63B-949F-0F66-3ACF-25629B7C5671}"/>
+              </a:ext>
+            </a:extLst>
+          </p:cNvPr>
+          <p:cNvSpPr>
+            <a:spLocks noGrp="1"/>
+          </p:cNvSpPr>
+          <p:nvPr>
+            <p:ph type="body" idx="1"/>
+          </p:nvPr>
+        </p:nvSpPr>
+        <p:spPr/>
+        <p:txBody>
+          <a:bodyPr/>
+          <a:lstStyle/>
+          <a:p>
+            <a:r>
+              <a:rPr lang="pl-PL" dirty="0"/>
+              <a:t>Customer Health</a:t>
+            </a:r>
+          </a:p>
+        </p:txBody>
+      </p:sp>
+      <p:sp>
+        <p:nvSpPr>
+          <p:cNvPr id="4" name="Slide Number Placeholder 3">
+            <a:extLst>
+              <a:ext uri="{FF2B5EF4-FFF2-40B4-BE49-F238E27FC236}">
+                <a16:creationId xmlns:a16="http://schemas.microsoft.com/office/drawing/2014/main" id="{A5204D62-7961-D581-37E2-9BBD9C2F6A1A}"/>
+              </a:ext>
+            </a:extLst>
+          </p:cNvPr>
+          <p:cNvSpPr>
+            <a:spLocks noGrp="1"/>
+          </p:cNvSpPr>
+          <p:nvPr>
+            <p:ph type="sldNum" sz="quarter" idx="5"/>
+          </p:nvPr>
+        </p:nvSpPr>
+        <p:spPr/>
+        <p:txBody>
+          <a:bodyPr/>
+          <a:lstStyle/>
+          <a:p>
+            <a:fld id="{71B83942-C7F4-4EA4-9A8B-6359B9310C95}" type="slidenum">
+              <a:rPr lang="pl-PL" smtClean="0"/>
+              <a:t>5</a:t>
+            </a:fld>
+            <a:endParaRPr lang="pl-PL"/>
+          </a:p>
+        </p:txBody>
+      </p:sp>
+    </p:spTree>
+    <p:extLst>
+      <p:ext uri="{BB962C8B-B14F-4D97-AF65-F5344CB8AC3E}">
+        <p14:creationId xmlns:p14="http://schemas.microsoft.com/office/powerpoint/2010/main" val="2658745953"/>
+      </p:ext>
+    </p:extLst>
+  </p:cSld>
+  <p:clrMapOvr>
+    <a:masterClrMapping/>
+  </p:clrMapOvr>
+</p:notes>
+</file>
+
 <file path=ppt/slideLayouts/slideLayout1.xml><?xml version="1.0" encoding="utf-8"?>
 <p:sldLayout xmlns:a="http://schemas.openxmlformats.org/drawingml/2006/main" xmlns:r="http://schemas.openxmlformats.org/officeDocument/2006/relationships" xmlns:p="http://schemas.openxmlformats.org/presentationml/2006/main" type="title" preserve="1">
   <p:cSld name="Title Slide">
@@ -261,7 +1125,7 @@
           <a:p>
             <a:fld id="{B6932F68-5057-4F43-9B77-28385F57AE30}" type="datetimeFigureOut">
               <a:rPr lang="pl-PL" smtClean="0"/>
-              <a:t>7.05.2026</a:t>
+              <a:t>4.10.2026</a:t>
             </a:fld>
             <a:endParaRPr lang="pl-PL"/>
           </a:p>
@@ -461,7 +1325,7 @@
           <a:p>
             <a:fld id="{B6932F68-5057-4F43-9B77-28385F57AE30}" type="datetimeFigureOut">
               <a:rPr lang="pl-PL" smtClean="0"/>
-              <a:t>7.05.2026</a:t>
+              <a:t>4.10.2026</a:t>
             </a:fld>
             <a:endParaRPr lang="pl-PL"/>
           </a:p>
@@ -671,7 +1535,7 @@
           <a:p>
             <a:fld id="{B6932F68-5057-4F43-9B77-28385F57AE30}" type="datetimeFigureOut">
               <a:rPr lang="pl-PL" smtClean="0"/>
-              <a:t>7.05.2026</a:t>
+              <a:t>4.10.2026</a:t>
             </a:fld>
             <a:endParaRPr lang="pl-PL"/>
           </a:p>
@@ -871,7 +1735,7 @@
           <a:p>
             <a:fld id="{B6932F68-5057-4F43-9B77-28385F57AE30}" type="datetimeFigureOut">
               <a:rPr lang="pl-PL" smtClean="0"/>
-              <a:t>7.05.2026</a:t>
+              <a:t>4.10.2026</a:t>
             </a:fld>
             <a:endParaRPr lang="pl-PL"/>
           </a:p>
@@ -1147,7 +2011,7 @@
           <a:p>
             <a:fld id="{B6932F68-5057-4F43-9B77-28385F57AE30}" type="datetimeFigureOut">
               <a:rPr lang="pl-PL" smtClean="0"/>
-              <a:t>7.05.2026</a:t>
+              <a:t>4.10.2026</a:t>
             </a:fld>
             <a:endParaRPr lang="pl-PL"/>
           </a:p>
@@ -1415,7 +2279,7 @@
           <a:p>
             <a:fld id="{B6932F68-5057-4F43-9B77-28385F57AE30}" type="datetimeFigureOut">
               <a:rPr lang="pl-PL" smtClean="0"/>
-              <a:t>7.05.2026</a:t>
+              <a:t>4.10.2026</a:t>
             </a:fld>
             <a:endParaRPr lang="pl-PL"/>
           </a:p>
@@ -1830,7 +2694,7 @@
           <a:p>
             <a:fld id="{B6932F68-5057-4F43-9B77-28385F57AE30}" type="datetimeFigureOut">
               <a:rPr lang="pl-PL" smtClean="0"/>
-              <a:t>7.05.2026</a:t>
+              <a:t>4.10.2026</a:t>
             </a:fld>
             <a:endParaRPr lang="pl-PL"/>
           </a:p>
@@ -1972,7 +2836,7 @@
           <a:p>
             <a:fld id="{B6932F68-5057-4F43-9B77-28385F57AE30}" type="datetimeFigureOut">
               <a:rPr lang="pl-PL" smtClean="0"/>
-              <a:t>7.05.2026</a:t>
+              <a:t>4.10.2026</a:t>
             </a:fld>
             <a:endParaRPr lang="pl-PL"/>
           </a:p>
@@ -2085,7 +2949,7 @@
           <a:p>
             <a:fld id="{B6932F68-5057-4F43-9B77-28385F57AE30}" type="datetimeFigureOut">
               <a:rPr lang="pl-PL" smtClean="0"/>
-              <a:t>7.05.2026</a:t>
+              <a:t>4.10.2026</a:t>
             </a:fld>
             <a:endParaRPr lang="pl-PL"/>
           </a:p>
@@ -2398,7 +3262,7 @@
           <a:p>
             <a:fld id="{B6932F68-5057-4F43-9B77-28385F57AE30}" type="datetimeFigureOut">
               <a:rPr lang="pl-PL" smtClean="0"/>
-              <a:t>7.05.2026</a:t>
+              <a:t>4.10.2026</a:t>
             </a:fld>
             <a:endParaRPr lang="pl-PL"/>
           </a:p>
@@ -2687,7 +3551,7 @@
           <a:p>
             <a:fld id="{B6932F68-5057-4F43-9B77-28385F57AE30}" type="datetimeFigureOut">
               <a:rPr lang="pl-PL" smtClean="0"/>
-              <a:t>7.05.2026</a:t>
+              <a:t>4.10.2026</a:t>
             </a:fld>
             <a:endParaRPr lang="pl-PL"/>
           </a:p>
@@ -2930,7 +3794,7 @@
           <a:p>
             <a:fld id="{B6932F68-5057-4F43-9B77-28385F57AE30}" type="datetimeFigureOut">
               <a:rPr lang="pl-PL" smtClean="0"/>
-              <a:t>7.05.2026</a:t>
+              <a:t>4.10.2026</a:t>
             </a:fld>
             <a:endParaRPr lang="pl-PL"/>
           </a:p>
@@ -3333,6 +4197,16 @@
 <file path=ppt/slides/slide1.xml><?xml version="1.0" encoding="utf-8"?>
 <p:sld xmlns:a="http://schemas.openxmlformats.org/drawingml/2006/main" xmlns:r="http://schemas.openxmlformats.org/officeDocument/2006/relationships" xmlns:p="http://schemas.openxmlformats.org/presentationml/2006/main">
   <p:cSld>
+    <p:bg>
+      <p:bgPr>
+        <a:solidFill>
+          <a:srgbClr val="A0A7D8">
+            <a:alpha val="15000"/>
+          </a:srgbClr>
+        </a:solidFill>
+        <a:effectLst/>
+      </p:bgPr>
+    </p:bg>
     <p:spTree>
       <p:nvGrpSpPr>
         <p:cNvPr id="1" name=""/>
@@ -3349,10 +4223,10 @@
       </p:grpSpPr>
       <p:sp>
         <p:nvSpPr>
-          <p:cNvPr id="5" name="Rectangle 4">
-            <a:extLst>
-              <a:ext uri="{FF2B5EF4-FFF2-40B4-BE49-F238E27FC236}">
-                <a16:creationId xmlns:a16="http://schemas.microsoft.com/office/drawing/2014/main" id="{7C0C19C9-7801-05CD-3B26-BFA0070CC416}"/>
+          <p:cNvPr id="4" name="Rectangle: Rounded Corners 9">
+            <a:extLst>
+              <a:ext uri="{FF2B5EF4-FFF2-40B4-BE49-F238E27FC236}">
+                <a16:creationId xmlns:a16="http://schemas.microsoft.com/office/drawing/2014/main" id="{E8E892B8-2148-DB12-F34E-B772C51622B9}"/>
               </a:ext>
             </a:extLst>
           </p:cNvPr>
@@ -3360,21 +4234,211 @@
           <p:nvPr/>
         </p:nvSpPr>
         <p:spPr>
-          <a:xfrm>
-            <a:off x="0" y="0"/>
-            <a:ext cx="12192000" cy="776614"/>
+          <a:xfrm flipV="1">
+            <a:off x="6931694" y="1440179"/>
+            <a:ext cx="5003316" cy="4765125"/>
           </a:xfrm>
-          <a:prstGeom prst="rect">
+          <a:custGeom>
             <a:avLst/>
-          </a:prstGeom>
+            <a:gdLst>
+              <a:gd name="connsiteX0" fmla="*/ 0 w 6513534"/>
+              <a:gd name="connsiteY0" fmla="*/ 736963 h 4421690"/>
+              <a:gd name="connsiteX1" fmla="*/ 736963 w 6513534"/>
+              <a:gd name="connsiteY1" fmla="*/ 0 h 4421690"/>
+              <a:gd name="connsiteX2" fmla="*/ 5776571 w 6513534"/>
+              <a:gd name="connsiteY2" fmla="*/ 0 h 4421690"/>
+              <a:gd name="connsiteX3" fmla="*/ 6513534 w 6513534"/>
+              <a:gd name="connsiteY3" fmla="*/ 736963 h 4421690"/>
+              <a:gd name="connsiteX4" fmla="*/ 6513534 w 6513534"/>
+              <a:gd name="connsiteY4" fmla="*/ 3684727 h 4421690"/>
+              <a:gd name="connsiteX5" fmla="*/ 5776571 w 6513534"/>
+              <a:gd name="connsiteY5" fmla="*/ 4421690 h 4421690"/>
+              <a:gd name="connsiteX6" fmla="*/ 736963 w 6513534"/>
+              <a:gd name="connsiteY6" fmla="*/ 4421690 h 4421690"/>
+              <a:gd name="connsiteX7" fmla="*/ 0 w 6513534"/>
+              <a:gd name="connsiteY7" fmla="*/ 3684727 h 4421690"/>
+              <a:gd name="connsiteX8" fmla="*/ 0 w 6513534"/>
+              <a:gd name="connsiteY8" fmla="*/ 736963 h 4421690"/>
+              <a:gd name="connsiteX0" fmla="*/ 0 w 6513534"/>
+              <a:gd name="connsiteY0" fmla="*/ 736963 h 4434216"/>
+              <a:gd name="connsiteX1" fmla="*/ 736963 w 6513534"/>
+              <a:gd name="connsiteY1" fmla="*/ 0 h 4434216"/>
+              <a:gd name="connsiteX2" fmla="*/ 5776571 w 6513534"/>
+              <a:gd name="connsiteY2" fmla="*/ 0 h 4434216"/>
+              <a:gd name="connsiteX3" fmla="*/ 6513534 w 6513534"/>
+              <a:gd name="connsiteY3" fmla="*/ 736963 h 4434216"/>
+              <a:gd name="connsiteX4" fmla="*/ 6513534 w 6513534"/>
+              <a:gd name="connsiteY4" fmla="*/ 3684727 h 4434216"/>
+              <a:gd name="connsiteX5" fmla="*/ 5776571 w 6513534"/>
+              <a:gd name="connsiteY5" fmla="*/ 4421690 h 4434216"/>
+              <a:gd name="connsiteX6" fmla="*/ 498968 w 6513534"/>
+              <a:gd name="connsiteY6" fmla="*/ 4434216 h 4434216"/>
+              <a:gd name="connsiteX7" fmla="*/ 0 w 6513534"/>
+              <a:gd name="connsiteY7" fmla="*/ 3684727 h 4434216"/>
+              <a:gd name="connsiteX8" fmla="*/ 0 w 6513534"/>
+              <a:gd name="connsiteY8" fmla="*/ 736963 h 4434216"/>
+              <a:gd name="connsiteX0" fmla="*/ 0 w 6513534"/>
+              <a:gd name="connsiteY0" fmla="*/ 736963 h 4434216"/>
+              <a:gd name="connsiteX1" fmla="*/ 736963 w 6513534"/>
+              <a:gd name="connsiteY1" fmla="*/ 0 h 4434216"/>
+              <a:gd name="connsiteX2" fmla="*/ 5776571 w 6513534"/>
+              <a:gd name="connsiteY2" fmla="*/ 0 h 4434216"/>
+              <a:gd name="connsiteX3" fmla="*/ 6513534 w 6513534"/>
+              <a:gd name="connsiteY3" fmla="*/ 736963 h 4434216"/>
+              <a:gd name="connsiteX4" fmla="*/ 6513534 w 6513534"/>
+              <a:gd name="connsiteY4" fmla="*/ 3684727 h 4434216"/>
+              <a:gd name="connsiteX5" fmla="*/ 6108511 w 6513534"/>
+              <a:gd name="connsiteY5" fmla="*/ 4421690 h 4434216"/>
+              <a:gd name="connsiteX6" fmla="*/ 498968 w 6513534"/>
+              <a:gd name="connsiteY6" fmla="*/ 4434216 h 4434216"/>
+              <a:gd name="connsiteX7" fmla="*/ 0 w 6513534"/>
+              <a:gd name="connsiteY7" fmla="*/ 3684727 h 4434216"/>
+              <a:gd name="connsiteX8" fmla="*/ 0 w 6513534"/>
+              <a:gd name="connsiteY8" fmla="*/ 736963 h 4434216"/>
+              <a:gd name="connsiteX0" fmla="*/ 0 w 6513534"/>
+              <a:gd name="connsiteY0" fmla="*/ 736963 h 4434216"/>
+              <a:gd name="connsiteX1" fmla="*/ 736963 w 6513534"/>
+              <a:gd name="connsiteY1" fmla="*/ 0 h 4434216"/>
+              <a:gd name="connsiteX2" fmla="*/ 5776571 w 6513534"/>
+              <a:gd name="connsiteY2" fmla="*/ 0 h 4434216"/>
+              <a:gd name="connsiteX3" fmla="*/ 6507271 w 6513534"/>
+              <a:gd name="connsiteY3" fmla="*/ 473917 h 4434216"/>
+              <a:gd name="connsiteX4" fmla="*/ 6513534 w 6513534"/>
+              <a:gd name="connsiteY4" fmla="*/ 3684727 h 4434216"/>
+              <a:gd name="connsiteX5" fmla="*/ 6108511 w 6513534"/>
+              <a:gd name="connsiteY5" fmla="*/ 4421690 h 4434216"/>
+              <a:gd name="connsiteX6" fmla="*/ 498968 w 6513534"/>
+              <a:gd name="connsiteY6" fmla="*/ 4434216 h 4434216"/>
+              <a:gd name="connsiteX7" fmla="*/ 0 w 6513534"/>
+              <a:gd name="connsiteY7" fmla="*/ 3684727 h 4434216"/>
+              <a:gd name="connsiteX8" fmla="*/ 0 w 6513534"/>
+              <a:gd name="connsiteY8" fmla="*/ 736963 h 4434216"/>
+              <a:gd name="connsiteX0" fmla="*/ 0 w 6526060"/>
+              <a:gd name="connsiteY0" fmla="*/ 467654 h 4434216"/>
+              <a:gd name="connsiteX1" fmla="*/ 749489 w 6526060"/>
+              <a:gd name="connsiteY1" fmla="*/ 0 h 4434216"/>
+              <a:gd name="connsiteX2" fmla="*/ 5789097 w 6526060"/>
+              <a:gd name="connsiteY2" fmla="*/ 0 h 4434216"/>
+              <a:gd name="connsiteX3" fmla="*/ 6519797 w 6526060"/>
+              <a:gd name="connsiteY3" fmla="*/ 473917 h 4434216"/>
+              <a:gd name="connsiteX4" fmla="*/ 6526060 w 6526060"/>
+              <a:gd name="connsiteY4" fmla="*/ 3684727 h 4434216"/>
+              <a:gd name="connsiteX5" fmla="*/ 6121037 w 6526060"/>
+              <a:gd name="connsiteY5" fmla="*/ 4421690 h 4434216"/>
+              <a:gd name="connsiteX6" fmla="*/ 511494 w 6526060"/>
+              <a:gd name="connsiteY6" fmla="*/ 4434216 h 4434216"/>
+              <a:gd name="connsiteX7" fmla="*/ 12526 w 6526060"/>
+              <a:gd name="connsiteY7" fmla="*/ 3684727 h 4434216"/>
+              <a:gd name="connsiteX8" fmla="*/ 0 w 6526060"/>
+              <a:gd name="connsiteY8" fmla="*/ 467654 h 4434216"/>
+              <a:gd name="connsiteX0" fmla="*/ 0 w 6526060"/>
+              <a:gd name="connsiteY0" fmla="*/ 436338 h 4434216"/>
+              <a:gd name="connsiteX1" fmla="*/ 749489 w 6526060"/>
+              <a:gd name="connsiteY1" fmla="*/ 0 h 4434216"/>
+              <a:gd name="connsiteX2" fmla="*/ 5789097 w 6526060"/>
+              <a:gd name="connsiteY2" fmla="*/ 0 h 4434216"/>
+              <a:gd name="connsiteX3" fmla="*/ 6519797 w 6526060"/>
+              <a:gd name="connsiteY3" fmla="*/ 473917 h 4434216"/>
+              <a:gd name="connsiteX4" fmla="*/ 6526060 w 6526060"/>
+              <a:gd name="connsiteY4" fmla="*/ 3684727 h 4434216"/>
+              <a:gd name="connsiteX5" fmla="*/ 6121037 w 6526060"/>
+              <a:gd name="connsiteY5" fmla="*/ 4421690 h 4434216"/>
+              <a:gd name="connsiteX6" fmla="*/ 511494 w 6526060"/>
+              <a:gd name="connsiteY6" fmla="*/ 4434216 h 4434216"/>
+              <a:gd name="connsiteX7" fmla="*/ 12526 w 6526060"/>
+              <a:gd name="connsiteY7" fmla="*/ 3684727 h 4434216"/>
+              <a:gd name="connsiteX8" fmla="*/ 0 w 6526060"/>
+              <a:gd name="connsiteY8" fmla="*/ 436338 h 4434216"/>
+            </a:gdLst>
+            <a:ahLst/>
+            <a:cxnLst>
+              <a:cxn ang="0">
+                <a:pos x="connsiteX0" y="connsiteY0"/>
+              </a:cxn>
+              <a:cxn ang="0">
+                <a:pos x="connsiteX1" y="connsiteY1"/>
+              </a:cxn>
+              <a:cxn ang="0">
+                <a:pos x="connsiteX2" y="connsiteY2"/>
+              </a:cxn>
+              <a:cxn ang="0">
+                <a:pos x="connsiteX3" y="connsiteY3"/>
+              </a:cxn>
+              <a:cxn ang="0">
+                <a:pos x="connsiteX4" y="connsiteY4"/>
+              </a:cxn>
+              <a:cxn ang="0">
+                <a:pos x="connsiteX5" y="connsiteY5"/>
+              </a:cxn>
+              <a:cxn ang="0">
+                <a:pos x="connsiteX6" y="connsiteY6"/>
+              </a:cxn>
+              <a:cxn ang="0">
+                <a:pos x="connsiteX7" y="connsiteY7"/>
+              </a:cxn>
+              <a:cxn ang="0">
+                <a:pos x="connsiteX8" y="connsiteY8"/>
+              </a:cxn>
+            </a:cxnLst>
+            <a:rect l="l" t="t" r="r" b="b"/>
+            <a:pathLst>
+              <a:path w="6526060" h="4434216">
+                <a:moveTo>
+                  <a:pt x="0" y="436338"/>
+                </a:moveTo>
+                <a:cubicBezTo>
+                  <a:pt x="0" y="29325"/>
+                  <a:pt x="342476" y="0"/>
+                  <a:pt x="749489" y="0"/>
+                </a:cubicBezTo>
+                <a:lnTo>
+                  <a:pt x="5789097" y="0"/>
+                </a:lnTo>
+                <a:cubicBezTo>
+                  <a:pt x="6196110" y="0"/>
+                  <a:pt x="6519797" y="66904"/>
+                  <a:pt x="6519797" y="473917"/>
+                </a:cubicBezTo>
+                <a:cubicBezTo>
+                  <a:pt x="6521885" y="1544187"/>
+                  <a:pt x="6523972" y="2614457"/>
+                  <a:pt x="6526060" y="3684727"/>
+                </a:cubicBezTo>
+                <a:cubicBezTo>
+                  <a:pt x="6526060" y="4091740"/>
+                  <a:pt x="6528050" y="4421690"/>
+                  <a:pt x="6121037" y="4421690"/>
+                </a:cubicBezTo>
+                <a:lnTo>
+                  <a:pt x="511494" y="4434216"/>
+                </a:lnTo>
+                <a:cubicBezTo>
+                  <a:pt x="104481" y="4434216"/>
+                  <a:pt x="12526" y="4091740"/>
+                  <a:pt x="12526" y="3684727"/>
+                </a:cubicBezTo>
+                <a:cubicBezTo>
+                  <a:pt x="8351" y="2612369"/>
+                  <a:pt x="4175" y="1508696"/>
+                  <a:pt x="0" y="436338"/>
+                </a:cubicBezTo>
+                <a:close/>
+              </a:path>
+            </a:pathLst>
+          </a:custGeom>
           <a:solidFill>
-            <a:schemeClr val="bg1">
-              <a:lumMod val="75000"/>
-            </a:schemeClr>
+            <a:schemeClr val="bg1"/>
           </a:solidFill>
           <a:ln>
             <a:noFill/>
           </a:ln>
+          <a:effectLst>
+            <a:outerShdw blurRad="50800" dist="38100" dir="2700000" algn="tl" rotWithShape="0">
+              <a:prstClr val="black">
+                <a:alpha val="40000"/>
+              </a:prstClr>
+            </a:outerShdw>
+          </a:effectLst>
         </p:spPr>
         <p:style>
           <a:lnRef idx="2">
@@ -3397,16 +4461,16 @@
           <a:lstStyle/>
           <a:p>
             <a:pPr algn="ctr"/>
-            <a:endParaRPr lang="pl-PL"/>
-          </a:p>
-        </p:txBody>
-      </p:sp>
-      <p:sp>
-        <p:nvSpPr>
-          <p:cNvPr id="6" name="Rectangle 5">
-            <a:extLst>
-              <a:ext uri="{FF2B5EF4-FFF2-40B4-BE49-F238E27FC236}">
-                <a16:creationId xmlns:a16="http://schemas.microsoft.com/office/drawing/2014/main" id="{B9482398-B39A-C1A7-B7AD-EC03DF250BDC}"/>
+            <a:endParaRPr lang="pl-PL" dirty="0"/>
+          </a:p>
+        </p:txBody>
+      </p:sp>
+      <p:sp>
+        <p:nvSpPr>
+          <p:cNvPr id="5" name="Rectangle: Rounded Corners 9">
+            <a:extLst>
+              <a:ext uri="{FF2B5EF4-FFF2-40B4-BE49-F238E27FC236}">
+                <a16:creationId xmlns:a16="http://schemas.microsoft.com/office/drawing/2014/main" id="{2CAD6921-A721-C1E9-8057-31646D78EF13}"/>
               </a:ext>
             </a:extLst>
           </p:cNvPr>
@@ -3414,21 +4478,211 @@
           <p:nvPr/>
         </p:nvSpPr>
         <p:spPr>
-          <a:xfrm>
-            <a:off x="-1" y="0"/>
-            <a:ext cx="1427967" cy="6858000"/>
+          <a:xfrm flipV="1">
+            <a:off x="126124" y="1440180"/>
+            <a:ext cx="6548580" cy="4765124"/>
           </a:xfrm>
-          <a:prstGeom prst="rect">
+          <a:custGeom>
             <a:avLst/>
-          </a:prstGeom>
+            <a:gdLst>
+              <a:gd name="connsiteX0" fmla="*/ 0 w 6513534"/>
+              <a:gd name="connsiteY0" fmla="*/ 736963 h 4421690"/>
+              <a:gd name="connsiteX1" fmla="*/ 736963 w 6513534"/>
+              <a:gd name="connsiteY1" fmla="*/ 0 h 4421690"/>
+              <a:gd name="connsiteX2" fmla="*/ 5776571 w 6513534"/>
+              <a:gd name="connsiteY2" fmla="*/ 0 h 4421690"/>
+              <a:gd name="connsiteX3" fmla="*/ 6513534 w 6513534"/>
+              <a:gd name="connsiteY3" fmla="*/ 736963 h 4421690"/>
+              <a:gd name="connsiteX4" fmla="*/ 6513534 w 6513534"/>
+              <a:gd name="connsiteY4" fmla="*/ 3684727 h 4421690"/>
+              <a:gd name="connsiteX5" fmla="*/ 5776571 w 6513534"/>
+              <a:gd name="connsiteY5" fmla="*/ 4421690 h 4421690"/>
+              <a:gd name="connsiteX6" fmla="*/ 736963 w 6513534"/>
+              <a:gd name="connsiteY6" fmla="*/ 4421690 h 4421690"/>
+              <a:gd name="connsiteX7" fmla="*/ 0 w 6513534"/>
+              <a:gd name="connsiteY7" fmla="*/ 3684727 h 4421690"/>
+              <a:gd name="connsiteX8" fmla="*/ 0 w 6513534"/>
+              <a:gd name="connsiteY8" fmla="*/ 736963 h 4421690"/>
+              <a:gd name="connsiteX0" fmla="*/ 0 w 6513534"/>
+              <a:gd name="connsiteY0" fmla="*/ 736963 h 4434216"/>
+              <a:gd name="connsiteX1" fmla="*/ 736963 w 6513534"/>
+              <a:gd name="connsiteY1" fmla="*/ 0 h 4434216"/>
+              <a:gd name="connsiteX2" fmla="*/ 5776571 w 6513534"/>
+              <a:gd name="connsiteY2" fmla="*/ 0 h 4434216"/>
+              <a:gd name="connsiteX3" fmla="*/ 6513534 w 6513534"/>
+              <a:gd name="connsiteY3" fmla="*/ 736963 h 4434216"/>
+              <a:gd name="connsiteX4" fmla="*/ 6513534 w 6513534"/>
+              <a:gd name="connsiteY4" fmla="*/ 3684727 h 4434216"/>
+              <a:gd name="connsiteX5" fmla="*/ 5776571 w 6513534"/>
+              <a:gd name="connsiteY5" fmla="*/ 4421690 h 4434216"/>
+              <a:gd name="connsiteX6" fmla="*/ 498968 w 6513534"/>
+              <a:gd name="connsiteY6" fmla="*/ 4434216 h 4434216"/>
+              <a:gd name="connsiteX7" fmla="*/ 0 w 6513534"/>
+              <a:gd name="connsiteY7" fmla="*/ 3684727 h 4434216"/>
+              <a:gd name="connsiteX8" fmla="*/ 0 w 6513534"/>
+              <a:gd name="connsiteY8" fmla="*/ 736963 h 4434216"/>
+              <a:gd name="connsiteX0" fmla="*/ 0 w 6513534"/>
+              <a:gd name="connsiteY0" fmla="*/ 736963 h 4434216"/>
+              <a:gd name="connsiteX1" fmla="*/ 736963 w 6513534"/>
+              <a:gd name="connsiteY1" fmla="*/ 0 h 4434216"/>
+              <a:gd name="connsiteX2" fmla="*/ 5776571 w 6513534"/>
+              <a:gd name="connsiteY2" fmla="*/ 0 h 4434216"/>
+              <a:gd name="connsiteX3" fmla="*/ 6513534 w 6513534"/>
+              <a:gd name="connsiteY3" fmla="*/ 736963 h 4434216"/>
+              <a:gd name="connsiteX4" fmla="*/ 6513534 w 6513534"/>
+              <a:gd name="connsiteY4" fmla="*/ 3684727 h 4434216"/>
+              <a:gd name="connsiteX5" fmla="*/ 6108511 w 6513534"/>
+              <a:gd name="connsiteY5" fmla="*/ 4421690 h 4434216"/>
+              <a:gd name="connsiteX6" fmla="*/ 498968 w 6513534"/>
+              <a:gd name="connsiteY6" fmla="*/ 4434216 h 4434216"/>
+              <a:gd name="connsiteX7" fmla="*/ 0 w 6513534"/>
+              <a:gd name="connsiteY7" fmla="*/ 3684727 h 4434216"/>
+              <a:gd name="connsiteX8" fmla="*/ 0 w 6513534"/>
+              <a:gd name="connsiteY8" fmla="*/ 736963 h 4434216"/>
+              <a:gd name="connsiteX0" fmla="*/ 0 w 6513534"/>
+              <a:gd name="connsiteY0" fmla="*/ 736963 h 4434216"/>
+              <a:gd name="connsiteX1" fmla="*/ 736963 w 6513534"/>
+              <a:gd name="connsiteY1" fmla="*/ 0 h 4434216"/>
+              <a:gd name="connsiteX2" fmla="*/ 5776571 w 6513534"/>
+              <a:gd name="connsiteY2" fmla="*/ 0 h 4434216"/>
+              <a:gd name="connsiteX3" fmla="*/ 6507271 w 6513534"/>
+              <a:gd name="connsiteY3" fmla="*/ 473917 h 4434216"/>
+              <a:gd name="connsiteX4" fmla="*/ 6513534 w 6513534"/>
+              <a:gd name="connsiteY4" fmla="*/ 3684727 h 4434216"/>
+              <a:gd name="connsiteX5" fmla="*/ 6108511 w 6513534"/>
+              <a:gd name="connsiteY5" fmla="*/ 4421690 h 4434216"/>
+              <a:gd name="connsiteX6" fmla="*/ 498968 w 6513534"/>
+              <a:gd name="connsiteY6" fmla="*/ 4434216 h 4434216"/>
+              <a:gd name="connsiteX7" fmla="*/ 0 w 6513534"/>
+              <a:gd name="connsiteY7" fmla="*/ 3684727 h 4434216"/>
+              <a:gd name="connsiteX8" fmla="*/ 0 w 6513534"/>
+              <a:gd name="connsiteY8" fmla="*/ 736963 h 4434216"/>
+              <a:gd name="connsiteX0" fmla="*/ 0 w 6526060"/>
+              <a:gd name="connsiteY0" fmla="*/ 467654 h 4434216"/>
+              <a:gd name="connsiteX1" fmla="*/ 749489 w 6526060"/>
+              <a:gd name="connsiteY1" fmla="*/ 0 h 4434216"/>
+              <a:gd name="connsiteX2" fmla="*/ 5789097 w 6526060"/>
+              <a:gd name="connsiteY2" fmla="*/ 0 h 4434216"/>
+              <a:gd name="connsiteX3" fmla="*/ 6519797 w 6526060"/>
+              <a:gd name="connsiteY3" fmla="*/ 473917 h 4434216"/>
+              <a:gd name="connsiteX4" fmla="*/ 6526060 w 6526060"/>
+              <a:gd name="connsiteY4" fmla="*/ 3684727 h 4434216"/>
+              <a:gd name="connsiteX5" fmla="*/ 6121037 w 6526060"/>
+              <a:gd name="connsiteY5" fmla="*/ 4421690 h 4434216"/>
+              <a:gd name="connsiteX6" fmla="*/ 511494 w 6526060"/>
+              <a:gd name="connsiteY6" fmla="*/ 4434216 h 4434216"/>
+              <a:gd name="connsiteX7" fmla="*/ 12526 w 6526060"/>
+              <a:gd name="connsiteY7" fmla="*/ 3684727 h 4434216"/>
+              <a:gd name="connsiteX8" fmla="*/ 0 w 6526060"/>
+              <a:gd name="connsiteY8" fmla="*/ 467654 h 4434216"/>
+              <a:gd name="connsiteX0" fmla="*/ 0 w 6526060"/>
+              <a:gd name="connsiteY0" fmla="*/ 436338 h 4434216"/>
+              <a:gd name="connsiteX1" fmla="*/ 749489 w 6526060"/>
+              <a:gd name="connsiteY1" fmla="*/ 0 h 4434216"/>
+              <a:gd name="connsiteX2" fmla="*/ 5789097 w 6526060"/>
+              <a:gd name="connsiteY2" fmla="*/ 0 h 4434216"/>
+              <a:gd name="connsiteX3" fmla="*/ 6519797 w 6526060"/>
+              <a:gd name="connsiteY3" fmla="*/ 473917 h 4434216"/>
+              <a:gd name="connsiteX4" fmla="*/ 6526060 w 6526060"/>
+              <a:gd name="connsiteY4" fmla="*/ 3684727 h 4434216"/>
+              <a:gd name="connsiteX5" fmla="*/ 6121037 w 6526060"/>
+              <a:gd name="connsiteY5" fmla="*/ 4421690 h 4434216"/>
+              <a:gd name="connsiteX6" fmla="*/ 511494 w 6526060"/>
+              <a:gd name="connsiteY6" fmla="*/ 4434216 h 4434216"/>
+              <a:gd name="connsiteX7" fmla="*/ 12526 w 6526060"/>
+              <a:gd name="connsiteY7" fmla="*/ 3684727 h 4434216"/>
+              <a:gd name="connsiteX8" fmla="*/ 0 w 6526060"/>
+              <a:gd name="connsiteY8" fmla="*/ 436338 h 4434216"/>
+            </a:gdLst>
+            <a:ahLst/>
+            <a:cxnLst>
+              <a:cxn ang="0">
+                <a:pos x="connsiteX0" y="connsiteY0"/>
+              </a:cxn>
+              <a:cxn ang="0">
+                <a:pos x="connsiteX1" y="connsiteY1"/>
+              </a:cxn>
+              <a:cxn ang="0">
+                <a:pos x="connsiteX2" y="connsiteY2"/>
+              </a:cxn>
+              <a:cxn ang="0">
+                <a:pos x="connsiteX3" y="connsiteY3"/>
+              </a:cxn>
+              <a:cxn ang="0">
+                <a:pos x="connsiteX4" y="connsiteY4"/>
+              </a:cxn>
+              <a:cxn ang="0">
+                <a:pos x="connsiteX5" y="connsiteY5"/>
+              </a:cxn>
+              <a:cxn ang="0">
+                <a:pos x="connsiteX6" y="connsiteY6"/>
+              </a:cxn>
+              <a:cxn ang="0">
+                <a:pos x="connsiteX7" y="connsiteY7"/>
+              </a:cxn>
+              <a:cxn ang="0">
+                <a:pos x="connsiteX8" y="connsiteY8"/>
+              </a:cxn>
+            </a:cxnLst>
+            <a:rect l="l" t="t" r="r" b="b"/>
+            <a:pathLst>
+              <a:path w="6526060" h="4434216">
+                <a:moveTo>
+                  <a:pt x="0" y="436338"/>
+                </a:moveTo>
+                <a:cubicBezTo>
+                  <a:pt x="0" y="29325"/>
+                  <a:pt x="342476" y="0"/>
+                  <a:pt x="749489" y="0"/>
+                </a:cubicBezTo>
+                <a:lnTo>
+                  <a:pt x="5789097" y="0"/>
+                </a:lnTo>
+                <a:cubicBezTo>
+                  <a:pt x="6196110" y="0"/>
+                  <a:pt x="6519797" y="66904"/>
+                  <a:pt x="6519797" y="473917"/>
+                </a:cubicBezTo>
+                <a:cubicBezTo>
+                  <a:pt x="6521885" y="1544187"/>
+                  <a:pt x="6523972" y="2614457"/>
+                  <a:pt x="6526060" y="3684727"/>
+                </a:cubicBezTo>
+                <a:cubicBezTo>
+                  <a:pt x="6526060" y="4091740"/>
+                  <a:pt x="6528050" y="4421690"/>
+                  <a:pt x="6121037" y="4421690"/>
+                </a:cubicBezTo>
+                <a:lnTo>
+                  <a:pt x="511494" y="4434216"/>
+                </a:lnTo>
+                <a:cubicBezTo>
+                  <a:pt x="104481" y="4434216"/>
+                  <a:pt x="12526" y="4091740"/>
+                  <a:pt x="12526" y="3684727"/>
+                </a:cubicBezTo>
+                <a:cubicBezTo>
+                  <a:pt x="8351" y="2612369"/>
+                  <a:pt x="4175" y="1508696"/>
+                  <a:pt x="0" y="436338"/>
+                </a:cubicBezTo>
+                <a:close/>
+              </a:path>
+            </a:pathLst>
+          </a:custGeom>
           <a:solidFill>
-            <a:schemeClr val="bg1">
-              <a:lumMod val="75000"/>
-            </a:schemeClr>
+            <a:schemeClr val="bg1"/>
           </a:solidFill>
           <a:ln>
             <a:noFill/>
           </a:ln>
+          <a:effectLst>
+            <a:outerShdw blurRad="50800" dist="38100" dir="2700000" algn="tl" rotWithShape="0">
+              <a:prstClr val="black">
+                <a:alpha val="40000"/>
+              </a:prstClr>
+            </a:outerShdw>
+          </a:effectLst>
         </p:spPr>
         <p:style>
           <a:lnRef idx="2">
@@ -3451,16 +4705,16 @@
           <a:lstStyle/>
           <a:p>
             <a:pPr algn="ctr"/>
-            <a:endParaRPr lang="pl-PL"/>
-          </a:p>
-        </p:txBody>
-      </p:sp>
-      <p:sp>
-        <p:nvSpPr>
-          <p:cNvPr id="8" name="Rectangle: Single Corner Rounded 7">
-            <a:extLst>
-              <a:ext uri="{FF2B5EF4-FFF2-40B4-BE49-F238E27FC236}">
-                <a16:creationId xmlns:a16="http://schemas.microsoft.com/office/drawing/2014/main" id="{CC8B8E86-574C-EE6A-DE52-F7D77C359A73}"/>
+            <a:endParaRPr lang="pl-PL" dirty="0"/>
+          </a:p>
+        </p:txBody>
+      </p:sp>
+      <p:sp>
+        <p:nvSpPr>
+          <p:cNvPr id="6" name="Rectangle: Rounded Corners 5">
+            <a:extLst>
+              <a:ext uri="{FF2B5EF4-FFF2-40B4-BE49-F238E27FC236}">
+                <a16:creationId xmlns:a16="http://schemas.microsoft.com/office/drawing/2014/main" id="{1F70F699-1016-7509-B0CD-7FFA50749E8B}"/>
               </a:ext>
             </a:extLst>
           </p:cNvPr>
@@ -3468,128 +4722,26 @@
           <p:nvPr/>
         </p:nvSpPr>
         <p:spPr>
-          <a:xfrm flipH="1">
-            <a:off x="1203960" y="571500"/>
-            <a:ext cx="10988040" cy="6286500"/>
+          <a:xfrm flipV="1">
+            <a:off x="750438" y="510273"/>
+            <a:ext cx="11323649" cy="794582"/>
           </a:xfrm>
-          <a:custGeom>
+          <a:prstGeom prst="roundRect">
             <a:avLst/>
-            <a:gdLst>
-              <a:gd name="connsiteX0" fmla="*/ 0 w 11140440"/>
-              <a:gd name="connsiteY0" fmla="*/ 0 h 6149340"/>
-              <a:gd name="connsiteX1" fmla="*/ 10115530 w 11140440"/>
-              <a:gd name="connsiteY1" fmla="*/ 0 h 6149340"/>
-              <a:gd name="connsiteX2" fmla="*/ 11140440 w 11140440"/>
-              <a:gd name="connsiteY2" fmla="*/ 1024910 h 6149340"/>
-              <a:gd name="connsiteX3" fmla="*/ 11140440 w 11140440"/>
-              <a:gd name="connsiteY3" fmla="*/ 6149340 h 6149340"/>
-              <a:gd name="connsiteX4" fmla="*/ 0 w 11140440"/>
-              <a:gd name="connsiteY4" fmla="*/ 6149340 h 6149340"/>
-              <a:gd name="connsiteX5" fmla="*/ 0 w 11140440"/>
-              <a:gd name="connsiteY5" fmla="*/ 0 h 6149340"/>
-              <a:gd name="connsiteX0" fmla="*/ 0 w 11140440"/>
-              <a:gd name="connsiteY0" fmla="*/ 0 h 6149340"/>
-              <a:gd name="connsiteX1" fmla="*/ 10115530 w 11140440"/>
-              <a:gd name="connsiteY1" fmla="*/ 0 h 6149340"/>
-              <a:gd name="connsiteX2" fmla="*/ 11140440 w 11140440"/>
-              <a:gd name="connsiteY2" fmla="*/ 590570 h 6149340"/>
-              <a:gd name="connsiteX3" fmla="*/ 11140440 w 11140440"/>
-              <a:gd name="connsiteY3" fmla="*/ 6149340 h 6149340"/>
-              <a:gd name="connsiteX4" fmla="*/ 0 w 11140440"/>
-              <a:gd name="connsiteY4" fmla="*/ 6149340 h 6149340"/>
-              <a:gd name="connsiteX5" fmla="*/ 0 w 11140440"/>
-              <a:gd name="connsiteY5" fmla="*/ 0 h 6149340"/>
-              <a:gd name="connsiteX0" fmla="*/ 0 w 11140440"/>
-              <a:gd name="connsiteY0" fmla="*/ 0 h 6149340"/>
-              <a:gd name="connsiteX1" fmla="*/ 10534630 w 11140440"/>
-              <a:gd name="connsiteY1" fmla="*/ 0 h 6149340"/>
-              <a:gd name="connsiteX2" fmla="*/ 11140440 w 11140440"/>
-              <a:gd name="connsiteY2" fmla="*/ 590570 h 6149340"/>
-              <a:gd name="connsiteX3" fmla="*/ 11140440 w 11140440"/>
-              <a:gd name="connsiteY3" fmla="*/ 6149340 h 6149340"/>
-              <a:gd name="connsiteX4" fmla="*/ 0 w 11140440"/>
-              <a:gd name="connsiteY4" fmla="*/ 6149340 h 6149340"/>
-              <a:gd name="connsiteX5" fmla="*/ 0 w 11140440"/>
-              <a:gd name="connsiteY5" fmla="*/ 0 h 6149340"/>
-              <a:gd name="connsiteX0" fmla="*/ 0 w 11140440"/>
-              <a:gd name="connsiteY0" fmla="*/ 0 h 6149340"/>
-              <a:gd name="connsiteX1" fmla="*/ 10534630 w 11140440"/>
-              <a:gd name="connsiteY1" fmla="*/ 0 h 6149340"/>
-              <a:gd name="connsiteX2" fmla="*/ 11140440 w 11140440"/>
-              <a:gd name="connsiteY2" fmla="*/ 765830 h 6149340"/>
-              <a:gd name="connsiteX3" fmla="*/ 11140440 w 11140440"/>
-              <a:gd name="connsiteY3" fmla="*/ 6149340 h 6149340"/>
-              <a:gd name="connsiteX4" fmla="*/ 0 w 11140440"/>
-              <a:gd name="connsiteY4" fmla="*/ 6149340 h 6149340"/>
-              <a:gd name="connsiteX5" fmla="*/ 0 w 11140440"/>
-              <a:gd name="connsiteY5" fmla="*/ 0 h 6149340"/>
-              <a:gd name="connsiteX0" fmla="*/ 0 w 11140542"/>
-              <a:gd name="connsiteY0" fmla="*/ 0 h 6149340"/>
-              <a:gd name="connsiteX1" fmla="*/ 10595590 w 11140542"/>
-              <a:gd name="connsiteY1" fmla="*/ 0 h 6149340"/>
-              <a:gd name="connsiteX2" fmla="*/ 11140440 w 11140542"/>
-              <a:gd name="connsiteY2" fmla="*/ 765830 h 6149340"/>
-              <a:gd name="connsiteX3" fmla="*/ 11140440 w 11140542"/>
-              <a:gd name="connsiteY3" fmla="*/ 6149340 h 6149340"/>
-              <a:gd name="connsiteX4" fmla="*/ 0 w 11140542"/>
-              <a:gd name="connsiteY4" fmla="*/ 6149340 h 6149340"/>
-              <a:gd name="connsiteX5" fmla="*/ 0 w 11140542"/>
-              <a:gd name="connsiteY5" fmla="*/ 0 h 6149340"/>
-            </a:gdLst>
-            <a:ahLst/>
-            <a:cxnLst>
-              <a:cxn ang="0">
-                <a:pos x="connsiteX0" y="connsiteY0"/>
-              </a:cxn>
-              <a:cxn ang="0">
-                <a:pos x="connsiteX1" y="connsiteY1"/>
-              </a:cxn>
-              <a:cxn ang="0">
-                <a:pos x="connsiteX2" y="connsiteY2"/>
-              </a:cxn>
-              <a:cxn ang="0">
-                <a:pos x="connsiteX3" y="connsiteY3"/>
-              </a:cxn>
-              <a:cxn ang="0">
-                <a:pos x="connsiteX4" y="connsiteY4"/>
-              </a:cxn>
-              <a:cxn ang="0">
-                <a:pos x="connsiteX5" y="connsiteY5"/>
-              </a:cxn>
-            </a:cxnLst>
-            <a:rect l="l" t="t" r="r" b="b"/>
-            <a:pathLst>
-              <a:path w="11140542" h="6149340">
-                <a:moveTo>
-                  <a:pt x="0" y="0"/>
-                </a:moveTo>
-                <a:lnTo>
-                  <a:pt x="10595590" y="0"/>
-                </a:lnTo>
-                <a:cubicBezTo>
-                  <a:pt x="11161632" y="0"/>
-                  <a:pt x="11140440" y="199788"/>
-                  <a:pt x="11140440" y="765830"/>
-                </a:cubicBezTo>
-                <a:lnTo>
-                  <a:pt x="11140440" y="6149340"/>
-                </a:lnTo>
-                <a:lnTo>
-                  <a:pt x="0" y="6149340"/>
-                </a:lnTo>
-                <a:lnTo>
-                  <a:pt x="0" y="0"/>
-                </a:lnTo>
-                <a:close/>
-              </a:path>
-            </a:pathLst>
-          </a:custGeom>
+          </a:prstGeom>
           <a:solidFill>
-            <a:schemeClr val="bg2"/>
+            <a:schemeClr val="bg1"/>
           </a:solidFill>
           <a:ln>
             <a:noFill/>
           </a:ln>
+          <a:effectLst>
+            <a:outerShdw blurRad="50800" dist="38100" dir="2700000" algn="tl" rotWithShape="0">
+              <a:prstClr val="black">
+                <a:alpha val="40000"/>
+              </a:prstClr>
+            </a:outerShdw>
+          </a:effectLst>
         </p:spPr>
         <p:style>
           <a:lnRef idx="2">
@@ -3616,10 +4768,2486 @@
           </a:p>
         </p:txBody>
       </p:sp>
+      <p:cxnSp>
+        <p:nvCxnSpPr>
+          <p:cNvPr id="24" name="Straight Connector 23">
+            <a:extLst>
+              <a:ext uri="{FF2B5EF4-FFF2-40B4-BE49-F238E27FC236}">
+                <a16:creationId xmlns:a16="http://schemas.microsoft.com/office/drawing/2014/main" id="{7520CD8E-3F65-9C9D-73CC-21BE1B4FDFB6}"/>
+              </a:ext>
+            </a:extLst>
+          </p:cNvPr>
+          <p:cNvCxnSpPr>
+            <a:cxnSpLocks/>
+          </p:cNvCxnSpPr>
+          <p:nvPr/>
+        </p:nvCxnSpPr>
+        <p:spPr>
+          <a:xfrm>
+            <a:off x="1628566" y="1935271"/>
+            <a:ext cx="0" cy="3751545"/>
+          </a:xfrm>
+          <a:prstGeom prst="line">
+            <a:avLst/>
+          </a:prstGeom>
+          <a:ln w="19050">
+            <a:gradFill>
+              <a:gsLst>
+                <a:gs pos="0">
+                  <a:srgbClr val="002060"/>
+                </a:gs>
+                <a:gs pos="74000">
+                  <a:schemeClr val="accent1">
+                    <a:lumMod val="45000"/>
+                    <a:lumOff val="55000"/>
+                  </a:schemeClr>
+                </a:gs>
+                <a:gs pos="83000">
+                  <a:schemeClr val="accent1">
+                    <a:lumMod val="45000"/>
+                    <a:lumOff val="55000"/>
+                  </a:schemeClr>
+                </a:gs>
+                <a:gs pos="100000">
+                  <a:schemeClr val="accent1">
+                    <a:lumMod val="30000"/>
+                    <a:lumOff val="70000"/>
+                  </a:schemeClr>
+                </a:gs>
+              </a:gsLst>
+              <a:lin ang="5400000" scaled="1"/>
+            </a:gradFill>
+          </a:ln>
+        </p:spPr>
+        <p:style>
+          <a:lnRef idx="1">
+            <a:schemeClr val="accent1"/>
+          </a:lnRef>
+          <a:fillRef idx="0">
+            <a:schemeClr val="accent1"/>
+          </a:fillRef>
+          <a:effectRef idx="0">
+            <a:schemeClr val="accent1"/>
+          </a:effectRef>
+          <a:fontRef idx="minor">
+            <a:schemeClr val="tx1"/>
+          </a:fontRef>
+        </p:style>
+      </p:cxnSp>
+      <p:cxnSp>
+        <p:nvCxnSpPr>
+          <p:cNvPr id="25" name="Straight Connector 24">
+            <a:extLst>
+              <a:ext uri="{FF2B5EF4-FFF2-40B4-BE49-F238E27FC236}">
+                <a16:creationId xmlns:a16="http://schemas.microsoft.com/office/drawing/2014/main" id="{9EE7D8F9-6545-35E6-5F9B-C17F211C9A01}"/>
+              </a:ext>
+            </a:extLst>
+          </p:cNvPr>
+          <p:cNvCxnSpPr>
+            <a:cxnSpLocks/>
+          </p:cNvCxnSpPr>
+          <p:nvPr/>
+        </p:nvCxnSpPr>
+        <p:spPr>
+          <a:xfrm flipH="1">
+            <a:off x="444674" y="2243469"/>
+            <a:ext cx="1035409" cy="0"/>
+          </a:xfrm>
+          <a:prstGeom prst="line">
+            <a:avLst/>
+          </a:prstGeom>
+          <a:ln w="19050">
+            <a:gradFill>
+              <a:gsLst>
+                <a:gs pos="0">
+                  <a:srgbClr val="002060"/>
+                </a:gs>
+                <a:gs pos="74000">
+                  <a:schemeClr val="accent1">
+                    <a:lumMod val="45000"/>
+                    <a:lumOff val="55000"/>
+                  </a:schemeClr>
+                </a:gs>
+                <a:gs pos="83000">
+                  <a:schemeClr val="accent1">
+                    <a:lumMod val="45000"/>
+                    <a:lumOff val="55000"/>
+                  </a:schemeClr>
+                </a:gs>
+                <a:gs pos="100000">
+                  <a:schemeClr val="accent1">
+                    <a:lumMod val="30000"/>
+                    <a:lumOff val="70000"/>
+                  </a:schemeClr>
+                </a:gs>
+              </a:gsLst>
+              <a:lin ang="5400000" scaled="1"/>
+            </a:gradFill>
+          </a:ln>
+        </p:spPr>
+        <p:style>
+          <a:lnRef idx="1">
+            <a:schemeClr val="accent1"/>
+          </a:lnRef>
+          <a:fillRef idx="0">
+            <a:schemeClr val="accent1"/>
+          </a:fillRef>
+          <a:effectRef idx="0">
+            <a:schemeClr val="accent1"/>
+          </a:effectRef>
+          <a:fontRef idx="minor">
+            <a:schemeClr val="tx1"/>
+          </a:fontRef>
+        </p:style>
+      </p:cxnSp>
+      <p:sp>
+        <p:nvSpPr>
+          <p:cNvPr id="32" name="Rectangle: Rounded Corners 31">
+            <a:extLst>
+              <a:ext uri="{FF2B5EF4-FFF2-40B4-BE49-F238E27FC236}">
+                <a16:creationId xmlns:a16="http://schemas.microsoft.com/office/drawing/2014/main" id="{A50EA713-9FC7-550B-617A-EA0B535B07B4}"/>
+              </a:ext>
+            </a:extLst>
+          </p:cNvPr>
+          <p:cNvSpPr/>
+          <p:nvPr/>
+        </p:nvSpPr>
+        <p:spPr>
+          <a:xfrm flipV="1">
+            <a:off x="126124" y="6347727"/>
+            <a:ext cx="11865908" cy="437309"/>
+          </a:xfrm>
+          <a:prstGeom prst="roundRect">
+            <a:avLst/>
+          </a:prstGeom>
+          <a:solidFill>
+            <a:schemeClr val="bg1"/>
+          </a:solidFill>
+          <a:ln>
+            <a:noFill/>
+          </a:ln>
+          <a:effectLst>
+            <a:outerShdw blurRad="50800" dist="38100" dir="2700000" algn="tl" rotWithShape="0">
+              <a:prstClr val="black">
+                <a:alpha val="40000"/>
+              </a:prstClr>
+            </a:outerShdw>
+          </a:effectLst>
+        </p:spPr>
+        <p:style>
+          <a:lnRef idx="2">
+            <a:schemeClr val="accent1">
+              <a:shade val="15000"/>
+            </a:schemeClr>
+          </a:lnRef>
+          <a:fillRef idx="1">
+            <a:schemeClr val="accent1"/>
+          </a:fillRef>
+          <a:effectRef idx="0">
+            <a:schemeClr val="accent1"/>
+          </a:effectRef>
+          <a:fontRef idx="minor">
+            <a:schemeClr val="lt1"/>
+          </a:fontRef>
+        </p:style>
+        <p:txBody>
+          <a:bodyPr rtlCol="0" anchor="ctr"/>
+          <a:lstStyle/>
+          <a:p>
+            <a:pPr algn="ctr"/>
+            <a:endParaRPr lang="pl-PL" dirty="0"/>
+          </a:p>
+        </p:txBody>
+      </p:sp>
     </p:spTree>
     <p:extLst>
       <p:ext uri="{BB962C8B-B14F-4D97-AF65-F5344CB8AC3E}">
-        <p14:creationId xmlns:p14="http://schemas.microsoft.com/office/powerpoint/2010/main" val="2056000139"/>
+        <p14:creationId xmlns:p14="http://schemas.microsoft.com/office/powerpoint/2010/main" val="2326138842"/>
+      </p:ext>
+    </p:extLst>
+  </p:cSld>
+  <p:clrMapOvr>
+    <a:masterClrMapping/>
+  </p:clrMapOvr>
+</p:sld>
+</file>
+
+<file path=ppt/slides/slide2.xml><?xml version="1.0" encoding="utf-8"?>
+<p:sld xmlns:a="http://schemas.openxmlformats.org/drawingml/2006/main" xmlns:r="http://schemas.openxmlformats.org/officeDocument/2006/relationships" xmlns:p="http://schemas.openxmlformats.org/presentationml/2006/main">
+  <p:cSld>
+    <p:bg>
+      <p:bgPr>
+        <a:solidFill>
+          <a:srgbClr val="A0A7D8">
+            <a:alpha val="15000"/>
+          </a:srgbClr>
+        </a:solidFill>
+        <a:effectLst/>
+      </p:bgPr>
+    </p:bg>
+    <p:spTree>
+      <p:nvGrpSpPr>
+        <p:cNvPr id="1" name="">
+          <a:extLst>
+            <a:ext uri="{FF2B5EF4-FFF2-40B4-BE49-F238E27FC236}">
+              <a16:creationId xmlns:a16="http://schemas.microsoft.com/office/drawing/2014/main" id="{E28ECD85-341D-D54E-F0A4-5450B334658A}"/>
+            </a:ext>
+          </a:extLst>
+        </p:cNvPr>
+        <p:cNvGrpSpPr/>
+        <p:nvPr/>
+      </p:nvGrpSpPr>
+      <p:grpSpPr>
+        <a:xfrm>
+          <a:off x="0" y="0"/>
+          <a:ext cx="0" cy="0"/>
+          <a:chOff x="0" y="0"/>
+          <a:chExt cx="0" cy="0"/>
+        </a:xfrm>
+      </p:grpSpPr>
+      <p:sp>
+        <p:nvSpPr>
+          <p:cNvPr id="4" name="Rectangle: Rounded Corners 9">
+            <a:extLst>
+              <a:ext uri="{FF2B5EF4-FFF2-40B4-BE49-F238E27FC236}">
+                <a16:creationId xmlns:a16="http://schemas.microsoft.com/office/drawing/2014/main" id="{5E597F4F-DE47-C32F-7504-07FC6D0AFF72}"/>
+              </a:ext>
+            </a:extLst>
+          </p:cNvPr>
+          <p:cNvSpPr/>
+          <p:nvPr/>
+        </p:nvSpPr>
+        <p:spPr>
+          <a:xfrm flipV="1">
+            <a:off x="5166360" y="1502752"/>
+            <a:ext cx="6825672" cy="4702552"/>
+          </a:xfrm>
+          <a:custGeom>
+            <a:avLst/>
+            <a:gdLst>
+              <a:gd name="connsiteX0" fmla="*/ 0 w 6513534"/>
+              <a:gd name="connsiteY0" fmla="*/ 736963 h 4421690"/>
+              <a:gd name="connsiteX1" fmla="*/ 736963 w 6513534"/>
+              <a:gd name="connsiteY1" fmla="*/ 0 h 4421690"/>
+              <a:gd name="connsiteX2" fmla="*/ 5776571 w 6513534"/>
+              <a:gd name="connsiteY2" fmla="*/ 0 h 4421690"/>
+              <a:gd name="connsiteX3" fmla="*/ 6513534 w 6513534"/>
+              <a:gd name="connsiteY3" fmla="*/ 736963 h 4421690"/>
+              <a:gd name="connsiteX4" fmla="*/ 6513534 w 6513534"/>
+              <a:gd name="connsiteY4" fmla="*/ 3684727 h 4421690"/>
+              <a:gd name="connsiteX5" fmla="*/ 5776571 w 6513534"/>
+              <a:gd name="connsiteY5" fmla="*/ 4421690 h 4421690"/>
+              <a:gd name="connsiteX6" fmla="*/ 736963 w 6513534"/>
+              <a:gd name="connsiteY6" fmla="*/ 4421690 h 4421690"/>
+              <a:gd name="connsiteX7" fmla="*/ 0 w 6513534"/>
+              <a:gd name="connsiteY7" fmla="*/ 3684727 h 4421690"/>
+              <a:gd name="connsiteX8" fmla="*/ 0 w 6513534"/>
+              <a:gd name="connsiteY8" fmla="*/ 736963 h 4421690"/>
+              <a:gd name="connsiteX0" fmla="*/ 0 w 6513534"/>
+              <a:gd name="connsiteY0" fmla="*/ 736963 h 4434216"/>
+              <a:gd name="connsiteX1" fmla="*/ 736963 w 6513534"/>
+              <a:gd name="connsiteY1" fmla="*/ 0 h 4434216"/>
+              <a:gd name="connsiteX2" fmla="*/ 5776571 w 6513534"/>
+              <a:gd name="connsiteY2" fmla="*/ 0 h 4434216"/>
+              <a:gd name="connsiteX3" fmla="*/ 6513534 w 6513534"/>
+              <a:gd name="connsiteY3" fmla="*/ 736963 h 4434216"/>
+              <a:gd name="connsiteX4" fmla="*/ 6513534 w 6513534"/>
+              <a:gd name="connsiteY4" fmla="*/ 3684727 h 4434216"/>
+              <a:gd name="connsiteX5" fmla="*/ 5776571 w 6513534"/>
+              <a:gd name="connsiteY5" fmla="*/ 4421690 h 4434216"/>
+              <a:gd name="connsiteX6" fmla="*/ 498968 w 6513534"/>
+              <a:gd name="connsiteY6" fmla="*/ 4434216 h 4434216"/>
+              <a:gd name="connsiteX7" fmla="*/ 0 w 6513534"/>
+              <a:gd name="connsiteY7" fmla="*/ 3684727 h 4434216"/>
+              <a:gd name="connsiteX8" fmla="*/ 0 w 6513534"/>
+              <a:gd name="connsiteY8" fmla="*/ 736963 h 4434216"/>
+              <a:gd name="connsiteX0" fmla="*/ 0 w 6513534"/>
+              <a:gd name="connsiteY0" fmla="*/ 736963 h 4434216"/>
+              <a:gd name="connsiteX1" fmla="*/ 736963 w 6513534"/>
+              <a:gd name="connsiteY1" fmla="*/ 0 h 4434216"/>
+              <a:gd name="connsiteX2" fmla="*/ 5776571 w 6513534"/>
+              <a:gd name="connsiteY2" fmla="*/ 0 h 4434216"/>
+              <a:gd name="connsiteX3" fmla="*/ 6513534 w 6513534"/>
+              <a:gd name="connsiteY3" fmla="*/ 736963 h 4434216"/>
+              <a:gd name="connsiteX4" fmla="*/ 6513534 w 6513534"/>
+              <a:gd name="connsiteY4" fmla="*/ 3684727 h 4434216"/>
+              <a:gd name="connsiteX5" fmla="*/ 6108511 w 6513534"/>
+              <a:gd name="connsiteY5" fmla="*/ 4421690 h 4434216"/>
+              <a:gd name="connsiteX6" fmla="*/ 498968 w 6513534"/>
+              <a:gd name="connsiteY6" fmla="*/ 4434216 h 4434216"/>
+              <a:gd name="connsiteX7" fmla="*/ 0 w 6513534"/>
+              <a:gd name="connsiteY7" fmla="*/ 3684727 h 4434216"/>
+              <a:gd name="connsiteX8" fmla="*/ 0 w 6513534"/>
+              <a:gd name="connsiteY8" fmla="*/ 736963 h 4434216"/>
+              <a:gd name="connsiteX0" fmla="*/ 0 w 6513534"/>
+              <a:gd name="connsiteY0" fmla="*/ 736963 h 4434216"/>
+              <a:gd name="connsiteX1" fmla="*/ 736963 w 6513534"/>
+              <a:gd name="connsiteY1" fmla="*/ 0 h 4434216"/>
+              <a:gd name="connsiteX2" fmla="*/ 5776571 w 6513534"/>
+              <a:gd name="connsiteY2" fmla="*/ 0 h 4434216"/>
+              <a:gd name="connsiteX3" fmla="*/ 6507271 w 6513534"/>
+              <a:gd name="connsiteY3" fmla="*/ 473917 h 4434216"/>
+              <a:gd name="connsiteX4" fmla="*/ 6513534 w 6513534"/>
+              <a:gd name="connsiteY4" fmla="*/ 3684727 h 4434216"/>
+              <a:gd name="connsiteX5" fmla="*/ 6108511 w 6513534"/>
+              <a:gd name="connsiteY5" fmla="*/ 4421690 h 4434216"/>
+              <a:gd name="connsiteX6" fmla="*/ 498968 w 6513534"/>
+              <a:gd name="connsiteY6" fmla="*/ 4434216 h 4434216"/>
+              <a:gd name="connsiteX7" fmla="*/ 0 w 6513534"/>
+              <a:gd name="connsiteY7" fmla="*/ 3684727 h 4434216"/>
+              <a:gd name="connsiteX8" fmla="*/ 0 w 6513534"/>
+              <a:gd name="connsiteY8" fmla="*/ 736963 h 4434216"/>
+              <a:gd name="connsiteX0" fmla="*/ 0 w 6526060"/>
+              <a:gd name="connsiteY0" fmla="*/ 467654 h 4434216"/>
+              <a:gd name="connsiteX1" fmla="*/ 749489 w 6526060"/>
+              <a:gd name="connsiteY1" fmla="*/ 0 h 4434216"/>
+              <a:gd name="connsiteX2" fmla="*/ 5789097 w 6526060"/>
+              <a:gd name="connsiteY2" fmla="*/ 0 h 4434216"/>
+              <a:gd name="connsiteX3" fmla="*/ 6519797 w 6526060"/>
+              <a:gd name="connsiteY3" fmla="*/ 473917 h 4434216"/>
+              <a:gd name="connsiteX4" fmla="*/ 6526060 w 6526060"/>
+              <a:gd name="connsiteY4" fmla="*/ 3684727 h 4434216"/>
+              <a:gd name="connsiteX5" fmla="*/ 6121037 w 6526060"/>
+              <a:gd name="connsiteY5" fmla="*/ 4421690 h 4434216"/>
+              <a:gd name="connsiteX6" fmla="*/ 511494 w 6526060"/>
+              <a:gd name="connsiteY6" fmla="*/ 4434216 h 4434216"/>
+              <a:gd name="connsiteX7" fmla="*/ 12526 w 6526060"/>
+              <a:gd name="connsiteY7" fmla="*/ 3684727 h 4434216"/>
+              <a:gd name="connsiteX8" fmla="*/ 0 w 6526060"/>
+              <a:gd name="connsiteY8" fmla="*/ 467654 h 4434216"/>
+              <a:gd name="connsiteX0" fmla="*/ 0 w 6526060"/>
+              <a:gd name="connsiteY0" fmla="*/ 436338 h 4434216"/>
+              <a:gd name="connsiteX1" fmla="*/ 749489 w 6526060"/>
+              <a:gd name="connsiteY1" fmla="*/ 0 h 4434216"/>
+              <a:gd name="connsiteX2" fmla="*/ 5789097 w 6526060"/>
+              <a:gd name="connsiteY2" fmla="*/ 0 h 4434216"/>
+              <a:gd name="connsiteX3" fmla="*/ 6519797 w 6526060"/>
+              <a:gd name="connsiteY3" fmla="*/ 473917 h 4434216"/>
+              <a:gd name="connsiteX4" fmla="*/ 6526060 w 6526060"/>
+              <a:gd name="connsiteY4" fmla="*/ 3684727 h 4434216"/>
+              <a:gd name="connsiteX5" fmla="*/ 6121037 w 6526060"/>
+              <a:gd name="connsiteY5" fmla="*/ 4421690 h 4434216"/>
+              <a:gd name="connsiteX6" fmla="*/ 511494 w 6526060"/>
+              <a:gd name="connsiteY6" fmla="*/ 4434216 h 4434216"/>
+              <a:gd name="connsiteX7" fmla="*/ 12526 w 6526060"/>
+              <a:gd name="connsiteY7" fmla="*/ 3684727 h 4434216"/>
+              <a:gd name="connsiteX8" fmla="*/ 0 w 6526060"/>
+              <a:gd name="connsiteY8" fmla="*/ 436338 h 4434216"/>
+            </a:gdLst>
+            <a:ahLst/>
+            <a:cxnLst>
+              <a:cxn ang="0">
+                <a:pos x="connsiteX0" y="connsiteY0"/>
+              </a:cxn>
+              <a:cxn ang="0">
+                <a:pos x="connsiteX1" y="connsiteY1"/>
+              </a:cxn>
+              <a:cxn ang="0">
+                <a:pos x="connsiteX2" y="connsiteY2"/>
+              </a:cxn>
+              <a:cxn ang="0">
+                <a:pos x="connsiteX3" y="connsiteY3"/>
+              </a:cxn>
+              <a:cxn ang="0">
+                <a:pos x="connsiteX4" y="connsiteY4"/>
+              </a:cxn>
+              <a:cxn ang="0">
+                <a:pos x="connsiteX5" y="connsiteY5"/>
+              </a:cxn>
+              <a:cxn ang="0">
+                <a:pos x="connsiteX6" y="connsiteY6"/>
+              </a:cxn>
+              <a:cxn ang="0">
+                <a:pos x="connsiteX7" y="connsiteY7"/>
+              </a:cxn>
+              <a:cxn ang="0">
+                <a:pos x="connsiteX8" y="connsiteY8"/>
+              </a:cxn>
+            </a:cxnLst>
+            <a:rect l="l" t="t" r="r" b="b"/>
+            <a:pathLst>
+              <a:path w="6526060" h="4434216">
+                <a:moveTo>
+                  <a:pt x="0" y="436338"/>
+                </a:moveTo>
+                <a:cubicBezTo>
+                  <a:pt x="0" y="29325"/>
+                  <a:pt x="342476" y="0"/>
+                  <a:pt x="749489" y="0"/>
+                </a:cubicBezTo>
+                <a:lnTo>
+                  <a:pt x="5789097" y="0"/>
+                </a:lnTo>
+                <a:cubicBezTo>
+                  <a:pt x="6196110" y="0"/>
+                  <a:pt x="6519797" y="66904"/>
+                  <a:pt x="6519797" y="473917"/>
+                </a:cubicBezTo>
+                <a:cubicBezTo>
+                  <a:pt x="6521885" y="1544187"/>
+                  <a:pt x="6523972" y="2614457"/>
+                  <a:pt x="6526060" y="3684727"/>
+                </a:cubicBezTo>
+                <a:cubicBezTo>
+                  <a:pt x="6526060" y="4091740"/>
+                  <a:pt x="6528050" y="4421690"/>
+                  <a:pt x="6121037" y="4421690"/>
+                </a:cubicBezTo>
+                <a:lnTo>
+                  <a:pt x="511494" y="4434216"/>
+                </a:lnTo>
+                <a:cubicBezTo>
+                  <a:pt x="104481" y="4434216"/>
+                  <a:pt x="12526" y="4091740"/>
+                  <a:pt x="12526" y="3684727"/>
+                </a:cubicBezTo>
+                <a:cubicBezTo>
+                  <a:pt x="8351" y="2612369"/>
+                  <a:pt x="4175" y="1508696"/>
+                  <a:pt x="0" y="436338"/>
+                </a:cubicBezTo>
+                <a:close/>
+              </a:path>
+            </a:pathLst>
+          </a:custGeom>
+          <a:solidFill>
+            <a:schemeClr val="bg1"/>
+          </a:solidFill>
+          <a:ln>
+            <a:noFill/>
+          </a:ln>
+          <a:effectLst>
+            <a:outerShdw blurRad="50800" dist="38100" dir="2700000" algn="tl" rotWithShape="0">
+              <a:prstClr val="black">
+                <a:alpha val="40000"/>
+              </a:prstClr>
+            </a:outerShdw>
+          </a:effectLst>
+        </p:spPr>
+        <p:style>
+          <a:lnRef idx="2">
+            <a:schemeClr val="accent1">
+              <a:shade val="15000"/>
+            </a:schemeClr>
+          </a:lnRef>
+          <a:fillRef idx="1">
+            <a:schemeClr val="accent1"/>
+          </a:fillRef>
+          <a:effectRef idx="0">
+            <a:schemeClr val="accent1"/>
+          </a:effectRef>
+          <a:fontRef idx="minor">
+            <a:schemeClr val="lt1"/>
+          </a:fontRef>
+        </p:style>
+        <p:txBody>
+          <a:bodyPr rtlCol="0" anchor="ctr"/>
+          <a:lstStyle/>
+          <a:p>
+            <a:pPr algn="ctr"/>
+            <a:endParaRPr lang="pl-PL" dirty="0"/>
+          </a:p>
+        </p:txBody>
+      </p:sp>
+      <p:sp>
+        <p:nvSpPr>
+          <p:cNvPr id="5" name="Rectangle: Rounded Corners 9">
+            <a:extLst>
+              <a:ext uri="{FF2B5EF4-FFF2-40B4-BE49-F238E27FC236}">
+                <a16:creationId xmlns:a16="http://schemas.microsoft.com/office/drawing/2014/main" id="{016B8581-92BB-0B3C-8E4D-6935C5321B37}"/>
+              </a:ext>
+            </a:extLst>
+          </p:cNvPr>
+          <p:cNvSpPr/>
+          <p:nvPr/>
+        </p:nvSpPr>
+        <p:spPr>
+          <a:xfrm flipV="1">
+            <a:off x="182880" y="1502752"/>
+            <a:ext cx="4693920" cy="4702552"/>
+          </a:xfrm>
+          <a:custGeom>
+            <a:avLst/>
+            <a:gdLst>
+              <a:gd name="connsiteX0" fmla="*/ 0 w 6513534"/>
+              <a:gd name="connsiteY0" fmla="*/ 736963 h 4421690"/>
+              <a:gd name="connsiteX1" fmla="*/ 736963 w 6513534"/>
+              <a:gd name="connsiteY1" fmla="*/ 0 h 4421690"/>
+              <a:gd name="connsiteX2" fmla="*/ 5776571 w 6513534"/>
+              <a:gd name="connsiteY2" fmla="*/ 0 h 4421690"/>
+              <a:gd name="connsiteX3" fmla="*/ 6513534 w 6513534"/>
+              <a:gd name="connsiteY3" fmla="*/ 736963 h 4421690"/>
+              <a:gd name="connsiteX4" fmla="*/ 6513534 w 6513534"/>
+              <a:gd name="connsiteY4" fmla="*/ 3684727 h 4421690"/>
+              <a:gd name="connsiteX5" fmla="*/ 5776571 w 6513534"/>
+              <a:gd name="connsiteY5" fmla="*/ 4421690 h 4421690"/>
+              <a:gd name="connsiteX6" fmla="*/ 736963 w 6513534"/>
+              <a:gd name="connsiteY6" fmla="*/ 4421690 h 4421690"/>
+              <a:gd name="connsiteX7" fmla="*/ 0 w 6513534"/>
+              <a:gd name="connsiteY7" fmla="*/ 3684727 h 4421690"/>
+              <a:gd name="connsiteX8" fmla="*/ 0 w 6513534"/>
+              <a:gd name="connsiteY8" fmla="*/ 736963 h 4421690"/>
+              <a:gd name="connsiteX0" fmla="*/ 0 w 6513534"/>
+              <a:gd name="connsiteY0" fmla="*/ 736963 h 4434216"/>
+              <a:gd name="connsiteX1" fmla="*/ 736963 w 6513534"/>
+              <a:gd name="connsiteY1" fmla="*/ 0 h 4434216"/>
+              <a:gd name="connsiteX2" fmla="*/ 5776571 w 6513534"/>
+              <a:gd name="connsiteY2" fmla="*/ 0 h 4434216"/>
+              <a:gd name="connsiteX3" fmla="*/ 6513534 w 6513534"/>
+              <a:gd name="connsiteY3" fmla="*/ 736963 h 4434216"/>
+              <a:gd name="connsiteX4" fmla="*/ 6513534 w 6513534"/>
+              <a:gd name="connsiteY4" fmla="*/ 3684727 h 4434216"/>
+              <a:gd name="connsiteX5" fmla="*/ 5776571 w 6513534"/>
+              <a:gd name="connsiteY5" fmla="*/ 4421690 h 4434216"/>
+              <a:gd name="connsiteX6" fmla="*/ 498968 w 6513534"/>
+              <a:gd name="connsiteY6" fmla="*/ 4434216 h 4434216"/>
+              <a:gd name="connsiteX7" fmla="*/ 0 w 6513534"/>
+              <a:gd name="connsiteY7" fmla="*/ 3684727 h 4434216"/>
+              <a:gd name="connsiteX8" fmla="*/ 0 w 6513534"/>
+              <a:gd name="connsiteY8" fmla="*/ 736963 h 4434216"/>
+              <a:gd name="connsiteX0" fmla="*/ 0 w 6513534"/>
+              <a:gd name="connsiteY0" fmla="*/ 736963 h 4434216"/>
+              <a:gd name="connsiteX1" fmla="*/ 736963 w 6513534"/>
+              <a:gd name="connsiteY1" fmla="*/ 0 h 4434216"/>
+              <a:gd name="connsiteX2" fmla="*/ 5776571 w 6513534"/>
+              <a:gd name="connsiteY2" fmla="*/ 0 h 4434216"/>
+              <a:gd name="connsiteX3" fmla="*/ 6513534 w 6513534"/>
+              <a:gd name="connsiteY3" fmla="*/ 736963 h 4434216"/>
+              <a:gd name="connsiteX4" fmla="*/ 6513534 w 6513534"/>
+              <a:gd name="connsiteY4" fmla="*/ 3684727 h 4434216"/>
+              <a:gd name="connsiteX5" fmla="*/ 6108511 w 6513534"/>
+              <a:gd name="connsiteY5" fmla="*/ 4421690 h 4434216"/>
+              <a:gd name="connsiteX6" fmla="*/ 498968 w 6513534"/>
+              <a:gd name="connsiteY6" fmla="*/ 4434216 h 4434216"/>
+              <a:gd name="connsiteX7" fmla="*/ 0 w 6513534"/>
+              <a:gd name="connsiteY7" fmla="*/ 3684727 h 4434216"/>
+              <a:gd name="connsiteX8" fmla="*/ 0 w 6513534"/>
+              <a:gd name="connsiteY8" fmla="*/ 736963 h 4434216"/>
+              <a:gd name="connsiteX0" fmla="*/ 0 w 6513534"/>
+              <a:gd name="connsiteY0" fmla="*/ 736963 h 4434216"/>
+              <a:gd name="connsiteX1" fmla="*/ 736963 w 6513534"/>
+              <a:gd name="connsiteY1" fmla="*/ 0 h 4434216"/>
+              <a:gd name="connsiteX2" fmla="*/ 5776571 w 6513534"/>
+              <a:gd name="connsiteY2" fmla="*/ 0 h 4434216"/>
+              <a:gd name="connsiteX3" fmla="*/ 6507271 w 6513534"/>
+              <a:gd name="connsiteY3" fmla="*/ 473917 h 4434216"/>
+              <a:gd name="connsiteX4" fmla="*/ 6513534 w 6513534"/>
+              <a:gd name="connsiteY4" fmla="*/ 3684727 h 4434216"/>
+              <a:gd name="connsiteX5" fmla="*/ 6108511 w 6513534"/>
+              <a:gd name="connsiteY5" fmla="*/ 4421690 h 4434216"/>
+              <a:gd name="connsiteX6" fmla="*/ 498968 w 6513534"/>
+              <a:gd name="connsiteY6" fmla="*/ 4434216 h 4434216"/>
+              <a:gd name="connsiteX7" fmla="*/ 0 w 6513534"/>
+              <a:gd name="connsiteY7" fmla="*/ 3684727 h 4434216"/>
+              <a:gd name="connsiteX8" fmla="*/ 0 w 6513534"/>
+              <a:gd name="connsiteY8" fmla="*/ 736963 h 4434216"/>
+              <a:gd name="connsiteX0" fmla="*/ 0 w 6526060"/>
+              <a:gd name="connsiteY0" fmla="*/ 467654 h 4434216"/>
+              <a:gd name="connsiteX1" fmla="*/ 749489 w 6526060"/>
+              <a:gd name="connsiteY1" fmla="*/ 0 h 4434216"/>
+              <a:gd name="connsiteX2" fmla="*/ 5789097 w 6526060"/>
+              <a:gd name="connsiteY2" fmla="*/ 0 h 4434216"/>
+              <a:gd name="connsiteX3" fmla="*/ 6519797 w 6526060"/>
+              <a:gd name="connsiteY3" fmla="*/ 473917 h 4434216"/>
+              <a:gd name="connsiteX4" fmla="*/ 6526060 w 6526060"/>
+              <a:gd name="connsiteY4" fmla="*/ 3684727 h 4434216"/>
+              <a:gd name="connsiteX5" fmla="*/ 6121037 w 6526060"/>
+              <a:gd name="connsiteY5" fmla="*/ 4421690 h 4434216"/>
+              <a:gd name="connsiteX6" fmla="*/ 511494 w 6526060"/>
+              <a:gd name="connsiteY6" fmla="*/ 4434216 h 4434216"/>
+              <a:gd name="connsiteX7" fmla="*/ 12526 w 6526060"/>
+              <a:gd name="connsiteY7" fmla="*/ 3684727 h 4434216"/>
+              <a:gd name="connsiteX8" fmla="*/ 0 w 6526060"/>
+              <a:gd name="connsiteY8" fmla="*/ 467654 h 4434216"/>
+              <a:gd name="connsiteX0" fmla="*/ 0 w 6526060"/>
+              <a:gd name="connsiteY0" fmla="*/ 436338 h 4434216"/>
+              <a:gd name="connsiteX1" fmla="*/ 749489 w 6526060"/>
+              <a:gd name="connsiteY1" fmla="*/ 0 h 4434216"/>
+              <a:gd name="connsiteX2" fmla="*/ 5789097 w 6526060"/>
+              <a:gd name="connsiteY2" fmla="*/ 0 h 4434216"/>
+              <a:gd name="connsiteX3" fmla="*/ 6519797 w 6526060"/>
+              <a:gd name="connsiteY3" fmla="*/ 473917 h 4434216"/>
+              <a:gd name="connsiteX4" fmla="*/ 6526060 w 6526060"/>
+              <a:gd name="connsiteY4" fmla="*/ 3684727 h 4434216"/>
+              <a:gd name="connsiteX5" fmla="*/ 6121037 w 6526060"/>
+              <a:gd name="connsiteY5" fmla="*/ 4421690 h 4434216"/>
+              <a:gd name="connsiteX6" fmla="*/ 511494 w 6526060"/>
+              <a:gd name="connsiteY6" fmla="*/ 4434216 h 4434216"/>
+              <a:gd name="connsiteX7" fmla="*/ 12526 w 6526060"/>
+              <a:gd name="connsiteY7" fmla="*/ 3684727 h 4434216"/>
+              <a:gd name="connsiteX8" fmla="*/ 0 w 6526060"/>
+              <a:gd name="connsiteY8" fmla="*/ 436338 h 4434216"/>
+            </a:gdLst>
+            <a:ahLst/>
+            <a:cxnLst>
+              <a:cxn ang="0">
+                <a:pos x="connsiteX0" y="connsiteY0"/>
+              </a:cxn>
+              <a:cxn ang="0">
+                <a:pos x="connsiteX1" y="connsiteY1"/>
+              </a:cxn>
+              <a:cxn ang="0">
+                <a:pos x="connsiteX2" y="connsiteY2"/>
+              </a:cxn>
+              <a:cxn ang="0">
+                <a:pos x="connsiteX3" y="connsiteY3"/>
+              </a:cxn>
+              <a:cxn ang="0">
+                <a:pos x="connsiteX4" y="connsiteY4"/>
+              </a:cxn>
+              <a:cxn ang="0">
+                <a:pos x="connsiteX5" y="connsiteY5"/>
+              </a:cxn>
+              <a:cxn ang="0">
+                <a:pos x="connsiteX6" y="connsiteY6"/>
+              </a:cxn>
+              <a:cxn ang="0">
+                <a:pos x="connsiteX7" y="connsiteY7"/>
+              </a:cxn>
+              <a:cxn ang="0">
+                <a:pos x="connsiteX8" y="connsiteY8"/>
+              </a:cxn>
+            </a:cxnLst>
+            <a:rect l="l" t="t" r="r" b="b"/>
+            <a:pathLst>
+              <a:path w="6526060" h="4434216">
+                <a:moveTo>
+                  <a:pt x="0" y="436338"/>
+                </a:moveTo>
+                <a:cubicBezTo>
+                  <a:pt x="0" y="29325"/>
+                  <a:pt x="342476" y="0"/>
+                  <a:pt x="749489" y="0"/>
+                </a:cubicBezTo>
+                <a:lnTo>
+                  <a:pt x="5789097" y="0"/>
+                </a:lnTo>
+                <a:cubicBezTo>
+                  <a:pt x="6196110" y="0"/>
+                  <a:pt x="6519797" y="66904"/>
+                  <a:pt x="6519797" y="473917"/>
+                </a:cubicBezTo>
+                <a:cubicBezTo>
+                  <a:pt x="6521885" y="1544187"/>
+                  <a:pt x="6523972" y="2614457"/>
+                  <a:pt x="6526060" y="3684727"/>
+                </a:cubicBezTo>
+                <a:cubicBezTo>
+                  <a:pt x="6526060" y="4091740"/>
+                  <a:pt x="6528050" y="4421690"/>
+                  <a:pt x="6121037" y="4421690"/>
+                </a:cubicBezTo>
+                <a:lnTo>
+                  <a:pt x="511494" y="4434216"/>
+                </a:lnTo>
+                <a:cubicBezTo>
+                  <a:pt x="104481" y="4434216"/>
+                  <a:pt x="12526" y="4091740"/>
+                  <a:pt x="12526" y="3684727"/>
+                </a:cubicBezTo>
+                <a:cubicBezTo>
+                  <a:pt x="8351" y="2612369"/>
+                  <a:pt x="4175" y="1508696"/>
+                  <a:pt x="0" y="436338"/>
+                </a:cubicBezTo>
+                <a:close/>
+              </a:path>
+            </a:pathLst>
+          </a:custGeom>
+          <a:solidFill>
+            <a:schemeClr val="bg1"/>
+          </a:solidFill>
+          <a:ln>
+            <a:noFill/>
+          </a:ln>
+          <a:effectLst>
+            <a:outerShdw blurRad="50800" dist="38100" dir="2700000" algn="tl" rotWithShape="0">
+              <a:prstClr val="black">
+                <a:alpha val="40000"/>
+              </a:prstClr>
+            </a:outerShdw>
+          </a:effectLst>
+        </p:spPr>
+        <p:style>
+          <a:lnRef idx="2">
+            <a:schemeClr val="accent1">
+              <a:shade val="15000"/>
+            </a:schemeClr>
+          </a:lnRef>
+          <a:fillRef idx="1">
+            <a:schemeClr val="accent1"/>
+          </a:fillRef>
+          <a:effectRef idx="0">
+            <a:schemeClr val="accent1"/>
+          </a:effectRef>
+          <a:fontRef idx="minor">
+            <a:schemeClr val="lt1"/>
+          </a:fontRef>
+        </p:style>
+        <p:txBody>
+          <a:bodyPr rtlCol="0" anchor="ctr"/>
+          <a:lstStyle/>
+          <a:p>
+            <a:pPr algn="ctr"/>
+            <a:endParaRPr lang="pl-PL" dirty="0"/>
+          </a:p>
+        </p:txBody>
+      </p:sp>
+      <p:sp>
+        <p:nvSpPr>
+          <p:cNvPr id="6" name="Rectangle: Rounded Corners 5">
+            <a:extLst>
+              <a:ext uri="{FF2B5EF4-FFF2-40B4-BE49-F238E27FC236}">
+                <a16:creationId xmlns:a16="http://schemas.microsoft.com/office/drawing/2014/main" id="{337F7393-978A-21E8-1AC6-64B8E8990097}"/>
+              </a:ext>
+            </a:extLst>
+          </p:cNvPr>
+          <p:cNvSpPr/>
+          <p:nvPr/>
+        </p:nvSpPr>
+        <p:spPr>
+          <a:xfrm flipV="1">
+            <a:off x="750438" y="510273"/>
+            <a:ext cx="11323649" cy="794582"/>
+          </a:xfrm>
+          <a:prstGeom prst="roundRect">
+            <a:avLst/>
+          </a:prstGeom>
+          <a:solidFill>
+            <a:schemeClr val="bg1"/>
+          </a:solidFill>
+          <a:ln>
+            <a:noFill/>
+          </a:ln>
+          <a:effectLst>
+            <a:outerShdw blurRad="50800" dist="38100" dir="2700000" algn="tl" rotWithShape="0">
+              <a:prstClr val="black">
+                <a:alpha val="40000"/>
+              </a:prstClr>
+            </a:outerShdw>
+          </a:effectLst>
+        </p:spPr>
+        <p:style>
+          <a:lnRef idx="2">
+            <a:schemeClr val="accent1">
+              <a:shade val="15000"/>
+            </a:schemeClr>
+          </a:lnRef>
+          <a:fillRef idx="1">
+            <a:schemeClr val="accent1"/>
+          </a:fillRef>
+          <a:effectRef idx="0">
+            <a:schemeClr val="accent1"/>
+          </a:effectRef>
+          <a:fontRef idx="minor">
+            <a:schemeClr val="lt1"/>
+          </a:fontRef>
+        </p:style>
+        <p:txBody>
+          <a:bodyPr rtlCol="0" anchor="ctr"/>
+          <a:lstStyle/>
+          <a:p>
+            <a:pPr algn="ctr"/>
+            <a:endParaRPr lang="pl-PL" dirty="0"/>
+          </a:p>
+        </p:txBody>
+      </p:sp>
+      <p:sp>
+        <p:nvSpPr>
+          <p:cNvPr id="32" name="Rectangle: Rounded Corners 31">
+            <a:extLst>
+              <a:ext uri="{FF2B5EF4-FFF2-40B4-BE49-F238E27FC236}">
+                <a16:creationId xmlns:a16="http://schemas.microsoft.com/office/drawing/2014/main" id="{2DF32DC3-A8A5-DA6A-DEBE-EF1D1FF34FAA}"/>
+              </a:ext>
+            </a:extLst>
+          </p:cNvPr>
+          <p:cNvSpPr/>
+          <p:nvPr/>
+        </p:nvSpPr>
+        <p:spPr>
+          <a:xfrm flipV="1">
+            <a:off x="126124" y="6347726"/>
+            <a:ext cx="11865908" cy="437309"/>
+          </a:xfrm>
+          <a:prstGeom prst="roundRect">
+            <a:avLst/>
+          </a:prstGeom>
+          <a:solidFill>
+            <a:schemeClr val="bg1"/>
+          </a:solidFill>
+          <a:ln>
+            <a:noFill/>
+          </a:ln>
+          <a:effectLst>
+            <a:outerShdw blurRad="50800" dist="38100" dir="2700000" algn="tl" rotWithShape="0">
+              <a:prstClr val="black">
+                <a:alpha val="40000"/>
+              </a:prstClr>
+            </a:outerShdw>
+          </a:effectLst>
+        </p:spPr>
+        <p:style>
+          <a:lnRef idx="2">
+            <a:schemeClr val="accent1">
+              <a:shade val="15000"/>
+            </a:schemeClr>
+          </a:lnRef>
+          <a:fillRef idx="1">
+            <a:schemeClr val="accent1"/>
+          </a:fillRef>
+          <a:effectRef idx="0">
+            <a:schemeClr val="accent1"/>
+          </a:effectRef>
+          <a:fontRef idx="minor">
+            <a:schemeClr val="lt1"/>
+          </a:fontRef>
+        </p:style>
+        <p:txBody>
+          <a:bodyPr rtlCol="0" anchor="ctr"/>
+          <a:lstStyle/>
+          <a:p>
+            <a:pPr algn="ctr"/>
+            <a:endParaRPr lang="pl-PL" dirty="0"/>
+          </a:p>
+        </p:txBody>
+      </p:sp>
+    </p:spTree>
+    <p:extLst>
+      <p:ext uri="{BB962C8B-B14F-4D97-AF65-F5344CB8AC3E}">
+        <p14:creationId xmlns:p14="http://schemas.microsoft.com/office/powerpoint/2010/main" val="416689885"/>
+      </p:ext>
+    </p:extLst>
+  </p:cSld>
+  <p:clrMapOvr>
+    <a:masterClrMapping/>
+  </p:clrMapOvr>
+</p:sld>
+</file>
+
+<file path=ppt/slides/slide3.xml><?xml version="1.0" encoding="utf-8"?>
+<p:sld xmlns:a="http://schemas.openxmlformats.org/drawingml/2006/main" xmlns:r="http://schemas.openxmlformats.org/officeDocument/2006/relationships" xmlns:p="http://schemas.openxmlformats.org/presentationml/2006/main">
+  <p:cSld>
+    <p:bg>
+      <p:bgPr>
+        <a:solidFill>
+          <a:srgbClr val="A0A7D8">
+            <a:alpha val="15000"/>
+          </a:srgbClr>
+        </a:solidFill>
+        <a:effectLst/>
+      </p:bgPr>
+    </p:bg>
+    <p:spTree>
+      <p:nvGrpSpPr>
+        <p:cNvPr id="1" name="">
+          <a:extLst>
+            <a:ext uri="{FF2B5EF4-FFF2-40B4-BE49-F238E27FC236}">
+              <a16:creationId xmlns:a16="http://schemas.microsoft.com/office/drawing/2014/main" id="{00C0D51D-F8B7-6264-933B-80D0F840A107}"/>
+            </a:ext>
+          </a:extLst>
+        </p:cNvPr>
+        <p:cNvGrpSpPr/>
+        <p:nvPr/>
+      </p:nvGrpSpPr>
+      <p:grpSpPr>
+        <a:xfrm>
+          <a:off x="0" y="0"/>
+          <a:ext cx="0" cy="0"/>
+          <a:chOff x="0" y="0"/>
+          <a:chExt cx="0" cy="0"/>
+        </a:xfrm>
+      </p:grpSpPr>
+      <p:sp>
+        <p:nvSpPr>
+          <p:cNvPr id="4" name="Rectangle: Rounded Corners 9">
+            <a:extLst>
+              <a:ext uri="{FF2B5EF4-FFF2-40B4-BE49-F238E27FC236}">
+                <a16:creationId xmlns:a16="http://schemas.microsoft.com/office/drawing/2014/main" id="{1E48F559-8D20-DDFF-D8A9-EF84C8985A47}"/>
+              </a:ext>
+            </a:extLst>
+          </p:cNvPr>
+          <p:cNvSpPr/>
+          <p:nvPr/>
+        </p:nvSpPr>
+        <p:spPr>
+          <a:xfrm flipV="1">
+            <a:off x="5821680" y="1361617"/>
+            <a:ext cx="6057900" cy="4986103"/>
+          </a:xfrm>
+          <a:custGeom>
+            <a:avLst/>
+            <a:gdLst>
+              <a:gd name="connsiteX0" fmla="*/ 0 w 6513534"/>
+              <a:gd name="connsiteY0" fmla="*/ 736963 h 4421690"/>
+              <a:gd name="connsiteX1" fmla="*/ 736963 w 6513534"/>
+              <a:gd name="connsiteY1" fmla="*/ 0 h 4421690"/>
+              <a:gd name="connsiteX2" fmla="*/ 5776571 w 6513534"/>
+              <a:gd name="connsiteY2" fmla="*/ 0 h 4421690"/>
+              <a:gd name="connsiteX3" fmla="*/ 6513534 w 6513534"/>
+              <a:gd name="connsiteY3" fmla="*/ 736963 h 4421690"/>
+              <a:gd name="connsiteX4" fmla="*/ 6513534 w 6513534"/>
+              <a:gd name="connsiteY4" fmla="*/ 3684727 h 4421690"/>
+              <a:gd name="connsiteX5" fmla="*/ 5776571 w 6513534"/>
+              <a:gd name="connsiteY5" fmla="*/ 4421690 h 4421690"/>
+              <a:gd name="connsiteX6" fmla="*/ 736963 w 6513534"/>
+              <a:gd name="connsiteY6" fmla="*/ 4421690 h 4421690"/>
+              <a:gd name="connsiteX7" fmla="*/ 0 w 6513534"/>
+              <a:gd name="connsiteY7" fmla="*/ 3684727 h 4421690"/>
+              <a:gd name="connsiteX8" fmla="*/ 0 w 6513534"/>
+              <a:gd name="connsiteY8" fmla="*/ 736963 h 4421690"/>
+              <a:gd name="connsiteX0" fmla="*/ 0 w 6513534"/>
+              <a:gd name="connsiteY0" fmla="*/ 736963 h 4434216"/>
+              <a:gd name="connsiteX1" fmla="*/ 736963 w 6513534"/>
+              <a:gd name="connsiteY1" fmla="*/ 0 h 4434216"/>
+              <a:gd name="connsiteX2" fmla="*/ 5776571 w 6513534"/>
+              <a:gd name="connsiteY2" fmla="*/ 0 h 4434216"/>
+              <a:gd name="connsiteX3" fmla="*/ 6513534 w 6513534"/>
+              <a:gd name="connsiteY3" fmla="*/ 736963 h 4434216"/>
+              <a:gd name="connsiteX4" fmla="*/ 6513534 w 6513534"/>
+              <a:gd name="connsiteY4" fmla="*/ 3684727 h 4434216"/>
+              <a:gd name="connsiteX5" fmla="*/ 5776571 w 6513534"/>
+              <a:gd name="connsiteY5" fmla="*/ 4421690 h 4434216"/>
+              <a:gd name="connsiteX6" fmla="*/ 498968 w 6513534"/>
+              <a:gd name="connsiteY6" fmla="*/ 4434216 h 4434216"/>
+              <a:gd name="connsiteX7" fmla="*/ 0 w 6513534"/>
+              <a:gd name="connsiteY7" fmla="*/ 3684727 h 4434216"/>
+              <a:gd name="connsiteX8" fmla="*/ 0 w 6513534"/>
+              <a:gd name="connsiteY8" fmla="*/ 736963 h 4434216"/>
+              <a:gd name="connsiteX0" fmla="*/ 0 w 6513534"/>
+              <a:gd name="connsiteY0" fmla="*/ 736963 h 4434216"/>
+              <a:gd name="connsiteX1" fmla="*/ 736963 w 6513534"/>
+              <a:gd name="connsiteY1" fmla="*/ 0 h 4434216"/>
+              <a:gd name="connsiteX2" fmla="*/ 5776571 w 6513534"/>
+              <a:gd name="connsiteY2" fmla="*/ 0 h 4434216"/>
+              <a:gd name="connsiteX3" fmla="*/ 6513534 w 6513534"/>
+              <a:gd name="connsiteY3" fmla="*/ 736963 h 4434216"/>
+              <a:gd name="connsiteX4" fmla="*/ 6513534 w 6513534"/>
+              <a:gd name="connsiteY4" fmla="*/ 3684727 h 4434216"/>
+              <a:gd name="connsiteX5" fmla="*/ 6108511 w 6513534"/>
+              <a:gd name="connsiteY5" fmla="*/ 4421690 h 4434216"/>
+              <a:gd name="connsiteX6" fmla="*/ 498968 w 6513534"/>
+              <a:gd name="connsiteY6" fmla="*/ 4434216 h 4434216"/>
+              <a:gd name="connsiteX7" fmla="*/ 0 w 6513534"/>
+              <a:gd name="connsiteY7" fmla="*/ 3684727 h 4434216"/>
+              <a:gd name="connsiteX8" fmla="*/ 0 w 6513534"/>
+              <a:gd name="connsiteY8" fmla="*/ 736963 h 4434216"/>
+              <a:gd name="connsiteX0" fmla="*/ 0 w 6513534"/>
+              <a:gd name="connsiteY0" fmla="*/ 736963 h 4434216"/>
+              <a:gd name="connsiteX1" fmla="*/ 736963 w 6513534"/>
+              <a:gd name="connsiteY1" fmla="*/ 0 h 4434216"/>
+              <a:gd name="connsiteX2" fmla="*/ 5776571 w 6513534"/>
+              <a:gd name="connsiteY2" fmla="*/ 0 h 4434216"/>
+              <a:gd name="connsiteX3" fmla="*/ 6507271 w 6513534"/>
+              <a:gd name="connsiteY3" fmla="*/ 473917 h 4434216"/>
+              <a:gd name="connsiteX4" fmla="*/ 6513534 w 6513534"/>
+              <a:gd name="connsiteY4" fmla="*/ 3684727 h 4434216"/>
+              <a:gd name="connsiteX5" fmla="*/ 6108511 w 6513534"/>
+              <a:gd name="connsiteY5" fmla="*/ 4421690 h 4434216"/>
+              <a:gd name="connsiteX6" fmla="*/ 498968 w 6513534"/>
+              <a:gd name="connsiteY6" fmla="*/ 4434216 h 4434216"/>
+              <a:gd name="connsiteX7" fmla="*/ 0 w 6513534"/>
+              <a:gd name="connsiteY7" fmla="*/ 3684727 h 4434216"/>
+              <a:gd name="connsiteX8" fmla="*/ 0 w 6513534"/>
+              <a:gd name="connsiteY8" fmla="*/ 736963 h 4434216"/>
+              <a:gd name="connsiteX0" fmla="*/ 0 w 6526060"/>
+              <a:gd name="connsiteY0" fmla="*/ 467654 h 4434216"/>
+              <a:gd name="connsiteX1" fmla="*/ 749489 w 6526060"/>
+              <a:gd name="connsiteY1" fmla="*/ 0 h 4434216"/>
+              <a:gd name="connsiteX2" fmla="*/ 5789097 w 6526060"/>
+              <a:gd name="connsiteY2" fmla="*/ 0 h 4434216"/>
+              <a:gd name="connsiteX3" fmla="*/ 6519797 w 6526060"/>
+              <a:gd name="connsiteY3" fmla="*/ 473917 h 4434216"/>
+              <a:gd name="connsiteX4" fmla="*/ 6526060 w 6526060"/>
+              <a:gd name="connsiteY4" fmla="*/ 3684727 h 4434216"/>
+              <a:gd name="connsiteX5" fmla="*/ 6121037 w 6526060"/>
+              <a:gd name="connsiteY5" fmla="*/ 4421690 h 4434216"/>
+              <a:gd name="connsiteX6" fmla="*/ 511494 w 6526060"/>
+              <a:gd name="connsiteY6" fmla="*/ 4434216 h 4434216"/>
+              <a:gd name="connsiteX7" fmla="*/ 12526 w 6526060"/>
+              <a:gd name="connsiteY7" fmla="*/ 3684727 h 4434216"/>
+              <a:gd name="connsiteX8" fmla="*/ 0 w 6526060"/>
+              <a:gd name="connsiteY8" fmla="*/ 467654 h 4434216"/>
+              <a:gd name="connsiteX0" fmla="*/ 0 w 6526060"/>
+              <a:gd name="connsiteY0" fmla="*/ 436338 h 4434216"/>
+              <a:gd name="connsiteX1" fmla="*/ 749489 w 6526060"/>
+              <a:gd name="connsiteY1" fmla="*/ 0 h 4434216"/>
+              <a:gd name="connsiteX2" fmla="*/ 5789097 w 6526060"/>
+              <a:gd name="connsiteY2" fmla="*/ 0 h 4434216"/>
+              <a:gd name="connsiteX3" fmla="*/ 6519797 w 6526060"/>
+              <a:gd name="connsiteY3" fmla="*/ 473917 h 4434216"/>
+              <a:gd name="connsiteX4" fmla="*/ 6526060 w 6526060"/>
+              <a:gd name="connsiteY4" fmla="*/ 3684727 h 4434216"/>
+              <a:gd name="connsiteX5" fmla="*/ 6121037 w 6526060"/>
+              <a:gd name="connsiteY5" fmla="*/ 4421690 h 4434216"/>
+              <a:gd name="connsiteX6" fmla="*/ 511494 w 6526060"/>
+              <a:gd name="connsiteY6" fmla="*/ 4434216 h 4434216"/>
+              <a:gd name="connsiteX7" fmla="*/ 12526 w 6526060"/>
+              <a:gd name="connsiteY7" fmla="*/ 3684727 h 4434216"/>
+              <a:gd name="connsiteX8" fmla="*/ 0 w 6526060"/>
+              <a:gd name="connsiteY8" fmla="*/ 436338 h 4434216"/>
+            </a:gdLst>
+            <a:ahLst/>
+            <a:cxnLst>
+              <a:cxn ang="0">
+                <a:pos x="connsiteX0" y="connsiteY0"/>
+              </a:cxn>
+              <a:cxn ang="0">
+                <a:pos x="connsiteX1" y="connsiteY1"/>
+              </a:cxn>
+              <a:cxn ang="0">
+                <a:pos x="connsiteX2" y="connsiteY2"/>
+              </a:cxn>
+              <a:cxn ang="0">
+                <a:pos x="connsiteX3" y="connsiteY3"/>
+              </a:cxn>
+              <a:cxn ang="0">
+                <a:pos x="connsiteX4" y="connsiteY4"/>
+              </a:cxn>
+              <a:cxn ang="0">
+                <a:pos x="connsiteX5" y="connsiteY5"/>
+              </a:cxn>
+              <a:cxn ang="0">
+                <a:pos x="connsiteX6" y="connsiteY6"/>
+              </a:cxn>
+              <a:cxn ang="0">
+                <a:pos x="connsiteX7" y="connsiteY7"/>
+              </a:cxn>
+              <a:cxn ang="0">
+                <a:pos x="connsiteX8" y="connsiteY8"/>
+              </a:cxn>
+            </a:cxnLst>
+            <a:rect l="l" t="t" r="r" b="b"/>
+            <a:pathLst>
+              <a:path w="6526060" h="4434216">
+                <a:moveTo>
+                  <a:pt x="0" y="436338"/>
+                </a:moveTo>
+                <a:cubicBezTo>
+                  <a:pt x="0" y="29325"/>
+                  <a:pt x="342476" y="0"/>
+                  <a:pt x="749489" y="0"/>
+                </a:cubicBezTo>
+                <a:lnTo>
+                  <a:pt x="5789097" y="0"/>
+                </a:lnTo>
+                <a:cubicBezTo>
+                  <a:pt x="6196110" y="0"/>
+                  <a:pt x="6519797" y="66904"/>
+                  <a:pt x="6519797" y="473917"/>
+                </a:cubicBezTo>
+                <a:cubicBezTo>
+                  <a:pt x="6521885" y="1544187"/>
+                  <a:pt x="6523972" y="2614457"/>
+                  <a:pt x="6526060" y="3684727"/>
+                </a:cubicBezTo>
+                <a:cubicBezTo>
+                  <a:pt x="6526060" y="4091740"/>
+                  <a:pt x="6528050" y="4421690"/>
+                  <a:pt x="6121037" y="4421690"/>
+                </a:cubicBezTo>
+                <a:lnTo>
+                  <a:pt x="511494" y="4434216"/>
+                </a:lnTo>
+                <a:cubicBezTo>
+                  <a:pt x="104481" y="4434216"/>
+                  <a:pt x="12526" y="4091740"/>
+                  <a:pt x="12526" y="3684727"/>
+                </a:cubicBezTo>
+                <a:cubicBezTo>
+                  <a:pt x="8351" y="2612369"/>
+                  <a:pt x="4175" y="1508696"/>
+                  <a:pt x="0" y="436338"/>
+                </a:cubicBezTo>
+                <a:close/>
+              </a:path>
+            </a:pathLst>
+          </a:custGeom>
+          <a:solidFill>
+            <a:schemeClr val="bg1"/>
+          </a:solidFill>
+          <a:ln>
+            <a:noFill/>
+          </a:ln>
+          <a:effectLst>
+            <a:outerShdw blurRad="50800" dist="38100" dir="2700000" algn="tl" rotWithShape="0">
+              <a:prstClr val="black">
+                <a:alpha val="40000"/>
+              </a:prstClr>
+            </a:outerShdw>
+          </a:effectLst>
+        </p:spPr>
+        <p:style>
+          <a:lnRef idx="2">
+            <a:schemeClr val="accent1">
+              <a:shade val="15000"/>
+            </a:schemeClr>
+          </a:lnRef>
+          <a:fillRef idx="1">
+            <a:schemeClr val="accent1"/>
+          </a:fillRef>
+          <a:effectRef idx="0">
+            <a:schemeClr val="accent1"/>
+          </a:effectRef>
+          <a:fontRef idx="minor">
+            <a:schemeClr val="lt1"/>
+          </a:fontRef>
+        </p:style>
+        <p:txBody>
+          <a:bodyPr rtlCol="0" anchor="ctr"/>
+          <a:lstStyle/>
+          <a:p>
+            <a:pPr algn="ctr"/>
+            <a:endParaRPr lang="pl-PL" dirty="0"/>
+          </a:p>
+        </p:txBody>
+      </p:sp>
+      <p:sp>
+        <p:nvSpPr>
+          <p:cNvPr id="5" name="Rectangle: Rounded Corners 9">
+            <a:extLst>
+              <a:ext uri="{FF2B5EF4-FFF2-40B4-BE49-F238E27FC236}">
+                <a16:creationId xmlns:a16="http://schemas.microsoft.com/office/drawing/2014/main" id="{96BC70BE-27F9-597C-97BA-5016461B790C}"/>
+              </a:ext>
+            </a:extLst>
+          </p:cNvPr>
+          <p:cNvSpPr/>
+          <p:nvPr/>
+        </p:nvSpPr>
+        <p:spPr>
+          <a:xfrm flipV="1">
+            <a:off x="270904" y="1361621"/>
+            <a:ext cx="5238356" cy="4986099"/>
+          </a:xfrm>
+          <a:custGeom>
+            <a:avLst/>
+            <a:gdLst>
+              <a:gd name="connsiteX0" fmla="*/ 0 w 6513534"/>
+              <a:gd name="connsiteY0" fmla="*/ 736963 h 4421690"/>
+              <a:gd name="connsiteX1" fmla="*/ 736963 w 6513534"/>
+              <a:gd name="connsiteY1" fmla="*/ 0 h 4421690"/>
+              <a:gd name="connsiteX2" fmla="*/ 5776571 w 6513534"/>
+              <a:gd name="connsiteY2" fmla="*/ 0 h 4421690"/>
+              <a:gd name="connsiteX3" fmla="*/ 6513534 w 6513534"/>
+              <a:gd name="connsiteY3" fmla="*/ 736963 h 4421690"/>
+              <a:gd name="connsiteX4" fmla="*/ 6513534 w 6513534"/>
+              <a:gd name="connsiteY4" fmla="*/ 3684727 h 4421690"/>
+              <a:gd name="connsiteX5" fmla="*/ 5776571 w 6513534"/>
+              <a:gd name="connsiteY5" fmla="*/ 4421690 h 4421690"/>
+              <a:gd name="connsiteX6" fmla="*/ 736963 w 6513534"/>
+              <a:gd name="connsiteY6" fmla="*/ 4421690 h 4421690"/>
+              <a:gd name="connsiteX7" fmla="*/ 0 w 6513534"/>
+              <a:gd name="connsiteY7" fmla="*/ 3684727 h 4421690"/>
+              <a:gd name="connsiteX8" fmla="*/ 0 w 6513534"/>
+              <a:gd name="connsiteY8" fmla="*/ 736963 h 4421690"/>
+              <a:gd name="connsiteX0" fmla="*/ 0 w 6513534"/>
+              <a:gd name="connsiteY0" fmla="*/ 736963 h 4434216"/>
+              <a:gd name="connsiteX1" fmla="*/ 736963 w 6513534"/>
+              <a:gd name="connsiteY1" fmla="*/ 0 h 4434216"/>
+              <a:gd name="connsiteX2" fmla="*/ 5776571 w 6513534"/>
+              <a:gd name="connsiteY2" fmla="*/ 0 h 4434216"/>
+              <a:gd name="connsiteX3" fmla="*/ 6513534 w 6513534"/>
+              <a:gd name="connsiteY3" fmla="*/ 736963 h 4434216"/>
+              <a:gd name="connsiteX4" fmla="*/ 6513534 w 6513534"/>
+              <a:gd name="connsiteY4" fmla="*/ 3684727 h 4434216"/>
+              <a:gd name="connsiteX5" fmla="*/ 5776571 w 6513534"/>
+              <a:gd name="connsiteY5" fmla="*/ 4421690 h 4434216"/>
+              <a:gd name="connsiteX6" fmla="*/ 498968 w 6513534"/>
+              <a:gd name="connsiteY6" fmla="*/ 4434216 h 4434216"/>
+              <a:gd name="connsiteX7" fmla="*/ 0 w 6513534"/>
+              <a:gd name="connsiteY7" fmla="*/ 3684727 h 4434216"/>
+              <a:gd name="connsiteX8" fmla="*/ 0 w 6513534"/>
+              <a:gd name="connsiteY8" fmla="*/ 736963 h 4434216"/>
+              <a:gd name="connsiteX0" fmla="*/ 0 w 6513534"/>
+              <a:gd name="connsiteY0" fmla="*/ 736963 h 4434216"/>
+              <a:gd name="connsiteX1" fmla="*/ 736963 w 6513534"/>
+              <a:gd name="connsiteY1" fmla="*/ 0 h 4434216"/>
+              <a:gd name="connsiteX2" fmla="*/ 5776571 w 6513534"/>
+              <a:gd name="connsiteY2" fmla="*/ 0 h 4434216"/>
+              <a:gd name="connsiteX3" fmla="*/ 6513534 w 6513534"/>
+              <a:gd name="connsiteY3" fmla="*/ 736963 h 4434216"/>
+              <a:gd name="connsiteX4" fmla="*/ 6513534 w 6513534"/>
+              <a:gd name="connsiteY4" fmla="*/ 3684727 h 4434216"/>
+              <a:gd name="connsiteX5" fmla="*/ 6108511 w 6513534"/>
+              <a:gd name="connsiteY5" fmla="*/ 4421690 h 4434216"/>
+              <a:gd name="connsiteX6" fmla="*/ 498968 w 6513534"/>
+              <a:gd name="connsiteY6" fmla="*/ 4434216 h 4434216"/>
+              <a:gd name="connsiteX7" fmla="*/ 0 w 6513534"/>
+              <a:gd name="connsiteY7" fmla="*/ 3684727 h 4434216"/>
+              <a:gd name="connsiteX8" fmla="*/ 0 w 6513534"/>
+              <a:gd name="connsiteY8" fmla="*/ 736963 h 4434216"/>
+              <a:gd name="connsiteX0" fmla="*/ 0 w 6513534"/>
+              <a:gd name="connsiteY0" fmla="*/ 736963 h 4434216"/>
+              <a:gd name="connsiteX1" fmla="*/ 736963 w 6513534"/>
+              <a:gd name="connsiteY1" fmla="*/ 0 h 4434216"/>
+              <a:gd name="connsiteX2" fmla="*/ 5776571 w 6513534"/>
+              <a:gd name="connsiteY2" fmla="*/ 0 h 4434216"/>
+              <a:gd name="connsiteX3" fmla="*/ 6507271 w 6513534"/>
+              <a:gd name="connsiteY3" fmla="*/ 473917 h 4434216"/>
+              <a:gd name="connsiteX4" fmla="*/ 6513534 w 6513534"/>
+              <a:gd name="connsiteY4" fmla="*/ 3684727 h 4434216"/>
+              <a:gd name="connsiteX5" fmla="*/ 6108511 w 6513534"/>
+              <a:gd name="connsiteY5" fmla="*/ 4421690 h 4434216"/>
+              <a:gd name="connsiteX6" fmla="*/ 498968 w 6513534"/>
+              <a:gd name="connsiteY6" fmla="*/ 4434216 h 4434216"/>
+              <a:gd name="connsiteX7" fmla="*/ 0 w 6513534"/>
+              <a:gd name="connsiteY7" fmla="*/ 3684727 h 4434216"/>
+              <a:gd name="connsiteX8" fmla="*/ 0 w 6513534"/>
+              <a:gd name="connsiteY8" fmla="*/ 736963 h 4434216"/>
+              <a:gd name="connsiteX0" fmla="*/ 0 w 6526060"/>
+              <a:gd name="connsiteY0" fmla="*/ 467654 h 4434216"/>
+              <a:gd name="connsiteX1" fmla="*/ 749489 w 6526060"/>
+              <a:gd name="connsiteY1" fmla="*/ 0 h 4434216"/>
+              <a:gd name="connsiteX2" fmla="*/ 5789097 w 6526060"/>
+              <a:gd name="connsiteY2" fmla="*/ 0 h 4434216"/>
+              <a:gd name="connsiteX3" fmla="*/ 6519797 w 6526060"/>
+              <a:gd name="connsiteY3" fmla="*/ 473917 h 4434216"/>
+              <a:gd name="connsiteX4" fmla="*/ 6526060 w 6526060"/>
+              <a:gd name="connsiteY4" fmla="*/ 3684727 h 4434216"/>
+              <a:gd name="connsiteX5" fmla="*/ 6121037 w 6526060"/>
+              <a:gd name="connsiteY5" fmla="*/ 4421690 h 4434216"/>
+              <a:gd name="connsiteX6" fmla="*/ 511494 w 6526060"/>
+              <a:gd name="connsiteY6" fmla="*/ 4434216 h 4434216"/>
+              <a:gd name="connsiteX7" fmla="*/ 12526 w 6526060"/>
+              <a:gd name="connsiteY7" fmla="*/ 3684727 h 4434216"/>
+              <a:gd name="connsiteX8" fmla="*/ 0 w 6526060"/>
+              <a:gd name="connsiteY8" fmla="*/ 467654 h 4434216"/>
+              <a:gd name="connsiteX0" fmla="*/ 0 w 6526060"/>
+              <a:gd name="connsiteY0" fmla="*/ 436338 h 4434216"/>
+              <a:gd name="connsiteX1" fmla="*/ 749489 w 6526060"/>
+              <a:gd name="connsiteY1" fmla="*/ 0 h 4434216"/>
+              <a:gd name="connsiteX2" fmla="*/ 5789097 w 6526060"/>
+              <a:gd name="connsiteY2" fmla="*/ 0 h 4434216"/>
+              <a:gd name="connsiteX3" fmla="*/ 6519797 w 6526060"/>
+              <a:gd name="connsiteY3" fmla="*/ 473917 h 4434216"/>
+              <a:gd name="connsiteX4" fmla="*/ 6526060 w 6526060"/>
+              <a:gd name="connsiteY4" fmla="*/ 3684727 h 4434216"/>
+              <a:gd name="connsiteX5" fmla="*/ 6121037 w 6526060"/>
+              <a:gd name="connsiteY5" fmla="*/ 4421690 h 4434216"/>
+              <a:gd name="connsiteX6" fmla="*/ 511494 w 6526060"/>
+              <a:gd name="connsiteY6" fmla="*/ 4434216 h 4434216"/>
+              <a:gd name="connsiteX7" fmla="*/ 12526 w 6526060"/>
+              <a:gd name="connsiteY7" fmla="*/ 3684727 h 4434216"/>
+              <a:gd name="connsiteX8" fmla="*/ 0 w 6526060"/>
+              <a:gd name="connsiteY8" fmla="*/ 436338 h 4434216"/>
+            </a:gdLst>
+            <a:ahLst/>
+            <a:cxnLst>
+              <a:cxn ang="0">
+                <a:pos x="connsiteX0" y="connsiteY0"/>
+              </a:cxn>
+              <a:cxn ang="0">
+                <a:pos x="connsiteX1" y="connsiteY1"/>
+              </a:cxn>
+              <a:cxn ang="0">
+                <a:pos x="connsiteX2" y="connsiteY2"/>
+              </a:cxn>
+              <a:cxn ang="0">
+                <a:pos x="connsiteX3" y="connsiteY3"/>
+              </a:cxn>
+              <a:cxn ang="0">
+                <a:pos x="connsiteX4" y="connsiteY4"/>
+              </a:cxn>
+              <a:cxn ang="0">
+                <a:pos x="connsiteX5" y="connsiteY5"/>
+              </a:cxn>
+              <a:cxn ang="0">
+                <a:pos x="connsiteX6" y="connsiteY6"/>
+              </a:cxn>
+              <a:cxn ang="0">
+                <a:pos x="connsiteX7" y="connsiteY7"/>
+              </a:cxn>
+              <a:cxn ang="0">
+                <a:pos x="connsiteX8" y="connsiteY8"/>
+              </a:cxn>
+            </a:cxnLst>
+            <a:rect l="l" t="t" r="r" b="b"/>
+            <a:pathLst>
+              <a:path w="6526060" h="4434216">
+                <a:moveTo>
+                  <a:pt x="0" y="436338"/>
+                </a:moveTo>
+                <a:cubicBezTo>
+                  <a:pt x="0" y="29325"/>
+                  <a:pt x="342476" y="0"/>
+                  <a:pt x="749489" y="0"/>
+                </a:cubicBezTo>
+                <a:lnTo>
+                  <a:pt x="5789097" y="0"/>
+                </a:lnTo>
+                <a:cubicBezTo>
+                  <a:pt x="6196110" y="0"/>
+                  <a:pt x="6519797" y="66904"/>
+                  <a:pt x="6519797" y="473917"/>
+                </a:cubicBezTo>
+                <a:cubicBezTo>
+                  <a:pt x="6521885" y="1544187"/>
+                  <a:pt x="6523972" y="2614457"/>
+                  <a:pt x="6526060" y="3684727"/>
+                </a:cubicBezTo>
+                <a:cubicBezTo>
+                  <a:pt x="6526060" y="4091740"/>
+                  <a:pt x="6528050" y="4421690"/>
+                  <a:pt x="6121037" y="4421690"/>
+                </a:cubicBezTo>
+                <a:lnTo>
+                  <a:pt x="511494" y="4434216"/>
+                </a:lnTo>
+                <a:cubicBezTo>
+                  <a:pt x="104481" y="4434216"/>
+                  <a:pt x="12526" y="4091740"/>
+                  <a:pt x="12526" y="3684727"/>
+                </a:cubicBezTo>
+                <a:cubicBezTo>
+                  <a:pt x="8351" y="2612369"/>
+                  <a:pt x="4175" y="1508696"/>
+                  <a:pt x="0" y="436338"/>
+                </a:cubicBezTo>
+                <a:close/>
+              </a:path>
+            </a:pathLst>
+          </a:custGeom>
+          <a:solidFill>
+            <a:schemeClr val="bg1"/>
+          </a:solidFill>
+          <a:ln>
+            <a:noFill/>
+          </a:ln>
+          <a:effectLst>
+            <a:outerShdw blurRad="50800" dist="38100" dir="2700000" algn="tl" rotWithShape="0">
+              <a:prstClr val="black">
+                <a:alpha val="40000"/>
+              </a:prstClr>
+            </a:outerShdw>
+          </a:effectLst>
+        </p:spPr>
+        <p:style>
+          <a:lnRef idx="2">
+            <a:schemeClr val="accent1">
+              <a:shade val="15000"/>
+            </a:schemeClr>
+          </a:lnRef>
+          <a:fillRef idx="1">
+            <a:schemeClr val="accent1"/>
+          </a:fillRef>
+          <a:effectRef idx="0">
+            <a:schemeClr val="accent1"/>
+          </a:effectRef>
+          <a:fontRef idx="minor">
+            <a:schemeClr val="lt1"/>
+          </a:fontRef>
+        </p:style>
+        <p:txBody>
+          <a:bodyPr rtlCol="0" anchor="ctr"/>
+          <a:lstStyle/>
+          <a:p>
+            <a:pPr algn="ctr"/>
+            <a:endParaRPr lang="pl-PL" dirty="0"/>
+          </a:p>
+        </p:txBody>
+      </p:sp>
+      <p:sp>
+        <p:nvSpPr>
+          <p:cNvPr id="6" name="Rectangle: Rounded Corners 5">
+            <a:extLst>
+              <a:ext uri="{FF2B5EF4-FFF2-40B4-BE49-F238E27FC236}">
+                <a16:creationId xmlns:a16="http://schemas.microsoft.com/office/drawing/2014/main" id="{57EFCB12-7185-E68D-2795-60CF9289C49E}"/>
+              </a:ext>
+            </a:extLst>
+          </p:cNvPr>
+          <p:cNvSpPr/>
+          <p:nvPr/>
+        </p:nvSpPr>
+        <p:spPr>
+          <a:xfrm flipV="1">
+            <a:off x="937259" y="548640"/>
+            <a:ext cx="10995661" cy="670560"/>
+          </a:xfrm>
+          <a:prstGeom prst="roundRect">
+            <a:avLst/>
+          </a:prstGeom>
+          <a:solidFill>
+            <a:schemeClr val="bg1"/>
+          </a:solidFill>
+          <a:ln>
+            <a:noFill/>
+          </a:ln>
+          <a:effectLst>
+            <a:outerShdw blurRad="50800" dist="38100" dir="2700000" algn="tl" rotWithShape="0">
+              <a:prstClr val="black">
+                <a:alpha val="40000"/>
+              </a:prstClr>
+            </a:outerShdw>
+          </a:effectLst>
+        </p:spPr>
+        <p:style>
+          <a:lnRef idx="2">
+            <a:schemeClr val="accent1">
+              <a:shade val="15000"/>
+            </a:schemeClr>
+          </a:lnRef>
+          <a:fillRef idx="1">
+            <a:schemeClr val="accent1"/>
+          </a:fillRef>
+          <a:effectRef idx="0">
+            <a:schemeClr val="accent1"/>
+          </a:effectRef>
+          <a:fontRef idx="minor">
+            <a:schemeClr val="lt1"/>
+          </a:fontRef>
+        </p:style>
+        <p:txBody>
+          <a:bodyPr rtlCol="0" anchor="ctr"/>
+          <a:lstStyle/>
+          <a:p>
+            <a:pPr algn="ctr"/>
+            <a:endParaRPr lang="pl-PL" dirty="0"/>
+          </a:p>
+        </p:txBody>
+      </p:sp>
+      <p:sp>
+        <p:nvSpPr>
+          <p:cNvPr id="32" name="Rectangle: Rounded Corners 31">
+            <a:extLst>
+              <a:ext uri="{FF2B5EF4-FFF2-40B4-BE49-F238E27FC236}">
+                <a16:creationId xmlns:a16="http://schemas.microsoft.com/office/drawing/2014/main" id="{FB7C06EE-017C-8DB9-D2EF-EA56B5FB1D7B}"/>
+              </a:ext>
+            </a:extLst>
+          </p:cNvPr>
+          <p:cNvSpPr/>
+          <p:nvPr/>
+        </p:nvSpPr>
+        <p:spPr>
+          <a:xfrm flipV="1">
+            <a:off x="126124" y="6431279"/>
+            <a:ext cx="11865908" cy="353753"/>
+          </a:xfrm>
+          <a:prstGeom prst="roundRect">
+            <a:avLst/>
+          </a:prstGeom>
+          <a:solidFill>
+            <a:schemeClr val="bg1"/>
+          </a:solidFill>
+          <a:ln>
+            <a:noFill/>
+          </a:ln>
+          <a:effectLst>
+            <a:outerShdw blurRad="50800" dist="38100" dir="2700000" algn="tl" rotWithShape="0">
+              <a:prstClr val="black">
+                <a:alpha val="40000"/>
+              </a:prstClr>
+            </a:outerShdw>
+          </a:effectLst>
+        </p:spPr>
+        <p:style>
+          <a:lnRef idx="2">
+            <a:schemeClr val="accent1">
+              <a:shade val="15000"/>
+            </a:schemeClr>
+          </a:lnRef>
+          <a:fillRef idx="1">
+            <a:schemeClr val="accent1"/>
+          </a:fillRef>
+          <a:effectRef idx="0">
+            <a:schemeClr val="accent1"/>
+          </a:effectRef>
+          <a:fontRef idx="minor">
+            <a:schemeClr val="lt1"/>
+          </a:fontRef>
+        </p:style>
+        <p:txBody>
+          <a:bodyPr rtlCol="0" anchor="ctr"/>
+          <a:lstStyle/>
+          <a:p>
+            <a:pPr algn="ctr"/>
+            <a:endParaRPr lang="pl-PL" dirty="0"/>
+          </a:p>
+        </p:txBody>
+      </p:sp>
+    </p:spTree>
+    <p:extLst>
+      <p:ext uri="{BB962C8B-B14F-4D97-AF65-F5344CB8AC3E}">
+        <p14:creationId xmlns:p14="http://schemas.microsoft.com/office/powerpoint/2010/main" val="3534461136"/>
+      </p:ext>
+    </p:extLst>
+  </p:cSld>
+  <p:clrMapOvr>
+    <a:masterClrMapping/>
+  </p:clrMapOvr>
+</p:sld>
+</file>
+
+<file path=ppt/slides/slide4.xml><?xml version="1.0" encoding="utf-8"?>
+<p:sld xmlns:a="http://schemas.openxmlformats.org/drawingml/2006/main" xmlns:r="http://schemas.openxmlformats.org/officeDocument/2006/relationships" xmlns:p="http://schemas.openxmlformats.org/presentationml/2006/main">
+  <p:cSld>
+    <p:bg>
+      <p:bgPr>
+        <a:solidFill>
+          <a:srgbClr val="A0A7D8">
+            <a:alpha val="15000"/>
+          </a:srgbClr>
+        </a:solidFill>
+        <a:effectLst/>
+      </p:bgPr>
+    </p:bg>
+    <p:spTree>
+      <p:nvGrpSpPr>
+        <p:cNvPr id="1" name="">
+          <a:extLst>
+            <a:ext uri="{FF2B5EF4-FFF2-40B4-BE49-F238E27FC236}">
+              <a16:creationId xmlns:a16="http://schemas.microsoft.com/office/drawing/2014/main" id="{133DFF4D-6A35-3A61-71E2-9172F00FA2C3}"/>
+            </a:ext>
+          </a:extLst>
+        </p:cNvPr>
+        <p:cNvGrpSpPr/>
+        <p:nvPr/>
+      </p:nvGrpSpPr>
+      <p:grpSpPr>
+        <a:xfrm>
+          <a:off x="0" y="0"/>
+          <a:ext cx="0" cy="0"/>
+          <a:chOff x="0" y="0"/>
+          <a:chExt cx="0" cy="0"/>
+        </a:xfrm>
+      </p:grpSpPr>
+      <p:sp>
+        <p:nvSpPr>
+          <p:cNvPr id="4" name="Rectangle: Rounded Corners 9">
+            <a:extLst>
+              <a:ext uri="{FF2B5EF4-FFF2-40B4-BE49-F238E27FC236}">
+                <a16:creationId xmlns:a16="http://schemas.microsoft.com/office/drawing/2014/main" id="{7881E943-B1F5-5804-7307-C5585A6C9C41}"/>
+              </a:ext>
+            </a:extLst>
+          </p:cNvPr>
+          <p:cNvSpPr/>
+          <p:nvPr/>
+        </p:nvSpPr>
+        <p:spPr>
+          <a:xfrm flipV="1">
+            <a:off x="6146800" y="1466849"/>
+            <a:ext cx="5774296" cy="4880870"/>
+          </a:xfrm>
+          <a:custGeom>
+            <a:avLst/>
+            <a:gdLst>
+              <a:gd name="connsiteX0" fmla="*/ 0 w 6513534"/>
+              <a:gd name="connsiteY0" fmla="*/ 736963 h 4421690"/>
+              <a:gd name="connsiteX1" fmla="*/ 736963 w 6513534"/>
+              <a:gd name="connsiteY1" fmla="*/ 0 h 4421690"/>
+              <a:gd name="connsiteX2" fmla="*/ 5776571 w 6513534"/>
+              <a:gd name="connsiteY2" fmla="*/ 0 h 4421690"/>
+              <a:gd name="connsiteX3" fmla="*/ 6513534 w 6513534"/>
+              <a:gd name="connsiteY3" fmla="*/ 736963 h 4421690"/>
+              <a:gd name="connsiteX4" fmla="*/ 6513534 w 6513534"/>
+              <a:gd name="connsiteY4" fmla="*/ 3684727 h 4421690"/>
+              <a:gd name="connsiteX5" fmla="*/ 5776571 w 6513534"/>
+              <a:gd name="connsiteY5" fmla="*/ 4421690 h 4421690"/>
+              <a:gd name="connsiteX6" fmla="*/ 736963 w 6513534"/>
+              <a:gd name="connsiteY6" fmla="*/ 4421690 h 4421690"/>
+              <a:gd name="connsiteX7" fmla="*/ 0 w 6513534"/>
+              <a:gd name="connsiteY7" fmla="*/ 3684727 h 4421690"/>
+              <a:gd name="connsiteX8" fmla="*/ 0 w 6513534"/>
+              <a:gd name="connsiteY8" fmla="*/ 736963 h 4421690"/>
+              <a:gd name="connsiteX0" fmla="*/ 0 w 6513534"/>
+              <a:gd name="connsiteY0" fmla="*/ 736963 h 4434216"/>
+              <a:gd name="connsiteX1" fmla="*/ 736963 w 6513534"/>
+              <a:gd name="connsiteY1" fmla="*/ 0 h 4434216"/>
+              <a:gd name="connsiteX2" fmla="*/ 5776571 w 6513534"/>
+              <a:gd name="connsiteY2" fmla="*/ 0 h 4434216"/>
+              <a:gd name="connsiteX3" fmla="*/ 6513534 w 6513534"/>
+              <a:gd name="connsiteY3" fmla="*/ 736963 h 4434216"/>
+              <a:gd name="connsiteX4" fmla="*/ 6513534 w 6513534"/>
+              <a:gd name="connsiteY4" fmla="*/ 3684727 h 4434216"/>
+              <a:gd name="connsiteX5" fmla="*/ 5776571 w 6513534"/>
+              <a:gd name="connsiteY5" fmla="*/ 4421690 h 4434216"/>
+              <a:gd name="connsiteX6" fmla="*/ 498968 w 6513534"/>
+              <a:gd name="connsiteY6" fmla="*/ 4434216 h 4434216"/>
+              <a:gd name="connsiteX7" fmla="*/ 0 w 6513534"/>
+              <a:gd name="connsiteY7" fmla="*/ 3684727 h 4434216"/>
+              <a:gd name="connsiteX8" fmla="*/ 0 w 6513534"/>
+              <a:gd name="connsiteY8" fmla="*/ 736963 h 4434216"/>
+              <a:gd name="connsiteX0" fmla="*/ 0 w 6513534"/>
+              <a:gd name="connsiteY0" fmla="*/ 736963 h 4434216"/>
+              <a:gd name="connsiteX1" fmla="*/ 736963 w 6513534"/>
+              <a:gd name="connsiteY1" fmla="*/ 0 h 4434216"/>
+              <a:gd name="connsiteX2" fmla="*/ 5776571 w 6513534"/>
+              <a:gd name="connsiteY2" fmla="*/ 0 h 4434216"/>
+              <a:gd name="connsiteX3" fmla="*/ 6513534 w 6513534"/>
+              <a:gd name="connsiteY3" fmla="*/ 736963 h 4434216"/>
+              <a:gd name="connsiteX4" fmla="*/ 6513534 w 6513534"/>
+              <a:gd name="connsiteY4" fmla="*/ 3684727 h 4434216"/>
+              <a:gd name="connsiteX5" fmla="*/ 6108511 w 6513534"/>
+              <a:gd name="connsiteY5" fmla="*/ 4421690 h 4434216"/>
+              <a:gd name="connsiteX6" fmla="*/ 498968 w 6513534"/>
+              <a:gd name="connsiteY6" fmla="*/ 4434216 h 4434216"/>
+              <a:gd name="connsiteX7" fmla="*/ 0 w 6513534"/>
+              <a:gd name="connsiteY7" fmla="*/ 3684727 h 4434216"/>
+              <a:gd name="connsiteX8" fmla="*/ 0 w 6513534"/>
+              <a:gd name="connsiteY8" fmla="*/ 736963 h 4434216"/>
+              <a:gd name="connsiteX0" fmla="*/ 0 w 6513534"/>
+              <a:gd name="connsiteY0" fmla="*/ 736963 h 4434216"/>
+              <a:gd name="connsiteX1" fmla="*/ 736963 w 6513534"/>
+              <a:gd name="connsiteY1" fmla="*/ 0 h 4434216"/>
+              <a:gd name="connsiteX2" fmla="*/ 5776571 w 6513534"/>
+              <a:gd name="connsiteY2" fmla="*/ 0 h 4434216"/>
+              <a:gd name="connsiteX3" fmla="*/ 6507271 w 6513534"/>
+              <a:gd name="connsiteY3" fmla="*/ 473917 h 4434216"/>
+              <a:gd name="connsiteX4" fmla="*/ 6513534 w 6513534"/>
+              <a:gd name="connsiteY4" fmla="*/ 3684727 h 4434216"/>
+              <a:gd name="connsiteX5" fmla="*/ 6108511 w 6513534"/>
+              <a:gd name="connsiteY5" fmla="*/ 4421690 h 4434216"/>
+              <a:gd name="connsiteX6" fmla="*/ 498968 w 6513534"/>
+              <a:gd name="connsiteY6" fmla="*/ 4434216 h 4434216"/>
+              <a:gd name="connsiteX7" fmla="*/ 0 w 6513534"/>
+              <a:gd name="connsiteY7" fmla="*/ 3684727 h 4434216"/>
+              <a:gd name="connsiteX8" fmla="*/ 0 w 6513534"/>
+              <a:gd name="connsiteY8" fmla="*/ 736963 h 4434216"/>
+              <a:gd name="connsiteX0" fmla="*/ 0 w 6526060"/>
+              <a:gd name="connsiteY0" fmla="*/ 467654 h 4434216"/>
+              <a:gd name="connsiteX1" fmla="*/ 749489 w 6526060"/>
+              <a:gd name="connsiteY1" fmla="*/ 0 h 4434216"/>
+              <a:gd name="connsiteX2" fmla="*/ 5789097 w 6526060"/>
+              <a:gd name="connsiteY2" fmla="*/ 0 h 4434216"/>
+              <a:gd name="connsiteX3" fmla="*/ 6519797 w 6526060"/>
+              <a:gd name="connsiteY3" fmla="*/ 473917 h 4434216"/>
+              <a:gd name="connsiteX4" fmla="*/ 6526060 w 6526060"/>
+              <a:gd name="connsiteY4" fmla="*/ 3684727 h 4434216"/>
+              <a:gd name="connsiteX5" fmla="*/ 6121037 w 6526060"/>
+              <a:gd name="connsiteY5" fmla="*/ 4421690 h 4434216"/>
+              <a:gd name="connsiteX6" fmla="*/ 511494 w 6526060"/>
+              <a:gd name="connsiteY6" fmla="*/ 4434216 h 4434216"/>
+              <a:gd name="connsiteX7" fmla="*/ 12526 w 6526060"/>
+              <a:gd name="connsiteY7" fmla="*/ 3684727 h 4434216"/>
+              <a:gd name="connsiteX8" fmla="*/ 0 w 6526060"/>
+              <a:gd name="connsiteY8" fmla="*/ 467654 h 4434216"/>
+              <a:gd name="connsiteX0" fmla="*/ 0 w 6526060"/>
+              <a:gd name="connsiteY0" fmla="*/ 436338 h 4434216"/>
+              <a:gd name="connsiteX1" fmla="*/ 749489 w 6526060"/>
+              <a:gd name="connsiteY1" fmla="*/ 0 h 4434216"/>
+              <a:gd name="connsiteX2" fmla="*/ 5789097 w 6526060"/>
+              <a:gd name="connsiteY2" fmla="*/ 0 h 4434216"/>
+              <a:gd name="connsiteX3" fmla="*/ 6519797 w 6526060"/>
+              <a:gd name="connsiteY3" fmla="*/ 473917 h 4434216"/>
+              <a:gd name="connsiteX4" fmla="*/ 6526060 w 6526060"/>
+              <a:gd name="connsiteY4" fmla="*/ 3684727 h 4434216"/>
+              <a:gd name="connsiteX5" fmla="*/ 6121037 w 6526060"/>
+              <a:gd name="connsiteY5" fmla="*/ 4421690 h 4434216"/>
+              <a:gd name="connsiteX6" fmla="*/ 511494 w 6526060"/>
+              <a:gd name="connsiteY6" fmla="*/ 4434216 h 4434216"/>
+              <a:gd name="connsiteX7" fmla="*/ 12526 w 6526060"/>
+              <a:gd name="connsiteY7" fmla="*/ 3684727 h 4434216"/>
+              <a:gd name="connsiteX8" fmla="*/ 0 w 6526060"/>
+              <a:gd name="connsiteY8" fmla="*/ 436338 h 4434216"/>
+            </a:gdLst>
+            <a:ahLst/>
+            <a:cxnLst>
+              <a:cxn ang="0">
+                <a:pos x="connsiteX0" y="connsiteY0"/>
+              </a:cxn>
+              <a:cxn ang="0">
+                <a:pos x="connsiteX1" y="connsiteY1"/>
+              </a:cxn>
+              <a:cxn ang="0">
+                <a:pos x="connsiteX2" y="connsiteY2"/>
+              </a:cxn>
+              <a:cxn ang="0">
+                <a:pos x="connsiteX3" y="connsiteY3"/>
+              </a:cxn>
+              <a:cxn ang="0">
+                <a:pos x="connsiteX4" y="connsiteY4"/>
+              </a:cxn>
+              <a:cxn ang="0">
+                <a:pos x="connsiteX5" y="connsiteY5"/>
+              </a:cxn>
+              <a:cxn ang="0">
+                <a:pos x="connsiteX6" y="connsiteY6"/>
+              </a:cxn>
+              <a:cxn ang="0">
+                <a:pos x="connsiteX7" y="connsiteY7"/>
+              </a:cxn>
+              <a:cxn ang="0">
+                <a:pos x="connsiteX8" y="connsiteY8"/>
+              </a:cxn>
+            </a:cxnLst>
+            <a:rect l="l" t="t" r="r" b="b"/>
+            <a:pathLst>
+              <a:path w="6526060" h="4434216">
+                <a:moveTo>
+                  <a:pt x="0" y="436338"/>
+                </a:moveTo>
+                <a:cubicBezTo>
+                  <a:pt x="0" y="29325"/>
+                  <a:pt x="342476" y="0"/>
+                  <a:pt x="749489" y="0"/>
+                </a:cubicBezTo>
+                <a:lnTo>
+                  <a:pt x="5789097" y="0"/>
+                </a:lnTo>
+                <a:cubicBezTo>
+                  <a:pt x="6196110" y="0"/>
+                  <a:pt x="6519797" y="66904"/>
+                  <a:pt x="6519797" y="473917"/>
+                </a:cubicBezTo>
+                <a:cubicBezTo>
+                  <a:pt x="6521885" y="1544187"/>
+                  <a:pt x="6523972" y="2614457"/>
+                  <a:pt x="6526060" y="3684727"/>
+                </a:cubicBezTo>
+                <a:cubicBezTo>
+                  <a:pt x="6526060" y="4091740"/>
+                  <a:pt x="6528050" y="4421690"/>
+                  <a:pt x="6121037" y="4421690"/>
+                </a:cubicBezTo>
+                <a:lnTo>
+                  <a:pt x="511494" y="4434216"/>
+                </a:lnTo>
+                <a:cubicBezTo>
+                  <a:pt x="104481" y="4434216"/>
+                  <a:pt x="12526" y="4091740"/>
+                  <a:pt x="12526" y="3684727"/>
+                </a:cubicBezTo>
+                <a:cubicBezTo>
+                  <a:pt x="8351" y="2612369"/>
+                  <a:pt x="4175" y="1508696"/>
+                  <a:pt x="0" y="436338"/>
+                </a:cubicBezTo>
+                <a:close/>
+              </a:path>
+            </a:pathLst>
+          </a:custGeom>
+          <a:solidFill>
+            <a:schemeClr val="bg1"/>
+          </a:solidFill>
+          <a:ln>
+            <a:noFill/>
+          </a:ln>
+          <a:effectLst>
+            <a:outerShdw blurRad="50800" dist="38100" dir="2700000" algn="tl" rotWithShape="0">
+              <a:prstClr val="black">
+                <a:alpha val="40000"/>
+              </a:prstClr>
+            </a:outerShdw>
+          </a:effectLst>
+        </p:spPr>
+        <p:style>
+          <a:lnRef idx="2">
+            <a:schemeClr val="accent1">
+              <a:shade val="15000"/>
+            </a:schemeClr>
+          </a:lnRef>
+          <a:fillRef idx="1">
+            <a:schemeClr val="accent1"/>
+          </a:fillRef>
+          <a:effectRef idx="0">
+            <a:schemeClr val="accent1"/>
+          </a:effectRef>
+          <a:fontRef idx="minor">
+            <a:schemeClr val="lt1"/>
+          </a:fontRef>
+        </p:style>
+        <p:txBody>
+          <a:bodyPr rtlCol="0" anchor="ctr"/>
+          <a:lstStyle/>
+          <a:p>
+            <a:pPr algn="ctr"/>
+            <a:endParaRPr lang="pl-PL" dirty="0"/>
+          </a:p>
+        </p:txBody>
+      </p:sp>
+      <p:sp>
+        <p:nvSpPr>
+          <p:cNvPr id="5" name="Rectangle: Rounded Corners 9">
+            <a:extLst>
+              <a:ext uri="{FF2B5EF4-FFF2-40B4-BE49-F238E27FC236}">
+                <a16:creationId xmlns:a16="http://schemas.microsoft.com/office/drawing/2014/main" id="{F61468FF-623C-2F61-3D28-33A2E3CB97B2}"/>
+              </a:ext>
+            </a:extLst>
+          </p:cNvPr>
+          <p:cNvSpPr/>
+          <p:nvPr/>
+        </p:nvSpPr>
+        <p:spPr>
+          <a:xfrm flipV="1">
+            <a:off x="270904" y="1466847"/>
+            <a:ext cx="5608456" cy="4880872"/>
+          </a:xfrm>
+          <a:custGeom>
+            <a:avLst/>
+            <a:gdLst>
+              <a:gd name="connsiteX0" fmla="*/ 0 w 6513534"/>
+              <a:gd name="connsiteY0" fmla="*/ 736963 h 4421690"/>
+              <a:gd name="connsiteX1" fmla="*/ 736963 w 6513534"/>
+              <a:gd name="connsiteY1" fmla="*/ 0 h 4421690"/>
+              <a:gd name="connsiteX2" fmla="*/ 5776571 w 6513534"/>
+              <a:gd name="connsiteY2" fmla="*/ 0 h 4421690"/>
+              <a:gd name="connsiteX3" fmla="*/ 6513534 w 6513534"/>
+              <a:gd name="connsiteY3" fmla="*/ 736963 h 4421690"/>
+              <a:gd name="connsiteX4" fmla="*/ 6513534 w 6513534"/>
+              <a:gd name="connsiteY4" fmla="*/ 3684727 h 4421690"/>
+              <a:gd name="connsiteX5" fmla="*/ 5776571 w 6513534"/>
+              <a:gd name="connsiteY5" fmla="*/ 4421690 h 4421690"/>
+              <a:gd name="connsiteX6" fmla="*/ 736963 w 6513534"/>
+              <a:gd name="connsiteY6" fmla="*/ 4421690 h 4421690"/>
+              <a:gd name="connsiteX7" fmla="*/ 0 w 6513534"/>
+              <a:gd name="connsiteY7" fmla="*/ 3684727 h 4421690"/>
+              <a:gd name="connsiteX8" fmla="*/ 0 w 6513534"/>
+              <a:gd name="connsiteY8" fmla="*/ 736963 h 4421690"/>
+              <a:gd name="connsiteX0" fmla="*/ 0 w 6513534"/>
+              <a:gd name="connsiteY0" fmla="*/ 736963 h 4434216"/>
+              <a:gd name="connsiteX1" fmla="*/ 736963 w 6513534"/>
+              <a:gd name="connsiteY1" fmla="*/ 0 h 4434216"/>
+              <a:gd name="connsiteX2" fmla="*/ 5776571 w 6513534"/>
+              <a:gd name="connsiteY2" fmla="*/ 0 h 4434216"/>
+              <a:gd name="connsiteX3" fmla="*/ 6513534 w 6513534"/>
+              <a:gd name="connsiteY3" fmla="*/ 736963 h 4434216"/>
+              <a:gd name="connsiteX4" fmla="*/ 6513534 w 6513534"/>
+              <a:gd name="connsiteY4" fmla="*/ 3684727 h 4434216"/>
+              <a:gd name="connsiteX5" fmla="*/ 5776571 w 6513534"/>
+              <a:gd name="connsiteY5" fmla="*/ 4421690 h 4434216"/>
+              <a:gd name="connsiteX6" fmla="*/ 498968 w 6513534"/>
+              <a:gd name="connsiteY6" fmla="*/ 4434216 h 4434216"/>
+              <a:gd name="connsiteX7" fmla="*/ 0 w 6513534"/>
+              <a:gd name="connsiteY7" fmla="*/ 3684727 h 4434216"/>
+              <a:gd name="connsiteX8" fmla="*/ 0 w 6513534"/>
+              <a:gd name="connsiteY8" fmla="*/ 736963 h 4434216"/>
+              <a:gd name="connsiteX0" fmla="*/ 0 w 6513534"/>
+              <a:gd name="connsiteY0" fmla="*/ 736963 h 4434216"/>
+              <a:gd name="connsiteX1" fmla="*/ 736963 w 6513534"/>
+              <a:gd name="connsiteY1" fmla="*/ 0 h 4434216"/>
+              <a:gd name="connsiteX2" fmla="*/ 5776571 w 6513534"/>
+              <a:gd name="connsiteY2" fmla="*/ 0 h 4434216"/>
+              <a:gd name="connsiteX3" fmla="*/ 6513534 w 6513534"/>
+              <a:gd name="connsiteY3" fmla="*/ 736963 h 4434216"/>
+              <a:gd name="connsiteX4" fmla="*/ 6513534 w 6513534"/>
+              <a:gd name="connsiteY4" fmla="*/ 3684727 h 4434216"/>
+              <a:gd name="connsiteX5" fmla="*/ 6108511 w 6513534"/>
+              <a:gd name="connsiteY5" fmla="*/ 4421690 h 4434216"/>
+              <a:gd name="connsiteX6" fmla="*/ 498968 w 6513534"/>
+              <a:gd name="connsiteY6" fmla="*/ 4434216 h 4434216"/>
+              <a:gd name="connsiteX7" fmla="*/ 0 w 6513534"/>
+              <a:gd name="connsiteY7" fmla="*/ 3684727 h 4434216"/>
+              <a:gd name="connsiteX8" fmla="*/ 0 w 6513534"/>
+              <a:gd name="connsiteY8" fmla="*/ 736963 h 4434216"/>
+              <a:gd name="connsiteX0" fmla="*/ 0 w 6513534"/>
+              <a:gd name="connsiteY0" fmla="*/ 736963 h 4434216"/>
+              <a:gd name="connsiteX1" fmla="*/ 736963 w 6513534"/>
+              <a:gd name="connsiteY1" fmla="*/ 0 h 4434216"/>
+              <a:gd name="connsiteX2" fmla="*/ 5776571 w 6513534"/>
+              <a:gd name="connsiteY2" fmla="*/ 0 h 4434216"/>
+              <a:gd name="connsiteX3" fmla="*/ 6507271 w 6513534"/>
+              <a:gd name="connsiteY3" fmla="*/ 473917 h 4434216"/>
+              <a:gd name="connsiteX4" fmla="*/ 6513534 w 6513534"/>
+              <a:gd name="connsiteY4" fmla="*/ 3684727 h 4434216"/>
+              <a:gd name="connsiteX5" fmla="*/ 6108511 w 6513534"/>
+              <a:gd name="connsiteY5" fmla="*/ 4421690 h 4434216"/>
+              <a:gd name="connsiteX6" fmla="*/ 498968 w 6513534"/>
+              <a:gd name="connsiteY6" fmla="*/ 4434216 h 4434216"/>
+              <a:gd name="connsiteX7" fmla="*/ 0 w 6513534"/>
+              <a:gd name="connsiteY7" fmla="*/ 3684727 h 4434216"/>
+              <a:gd name="connsiteX8" fmla="*/ 0 w 6513534"/>
+              <a:gd name="connsiteY8" fmla="*/ 736963 h 4434216"/>
+              <a:gd name="connsiteX0" fmla="*/ 0 w 6526060"/>
+              <a:gd name="connsiteY0" fmla="*/ 467654 h 4434216"/>
+              <a:gd name="connsiteX1" fmla="*/ 749489 w 6526060"/>
+              <a:gd name="connsiteY1" fmla="*/ 0 h 4434216"/>
+              <a:gd name="connsiteX2" fmla="*/ 5789097 w 6526060"/>
+              <a:gd name="connsiteY2" fmla="*/ 0 h 4434216"/>
+              <a:gd name="connsiteX3" fmla="*/ 6519797 w 6526060"/>
+              <a:gd name="connsiteY3" fmla="*/ 473917 h 4434216"/>
+              <a:gd name="connsiteX4" fmla="*/ 6526060 w 6526060"/>
+              <a:gd name="connsiteY4" fmla="*/ 3684727 h 4434216"/>
+              <a:gd name="connsiteX5" fmla="*/ 6121037 w 6526060"/>
+              <a:gd name="connsiteY5" fmla="*/ 4421690 h 4434216"/>
+              <a:gd name="connsiteX6" fmla="*/ 511494 w 6526060"/>
+              <a:gd name="connsiteY6" fmla="*/ 4434216 h 4434216"/>
+              <a:gd name="connsiteX7" fmla="*/ 12526 w 6526060"/>
+              <a:gd name="connsiteY7" fmla="*/ 3684727 h 4434216"/>
+              <a:gd name="connsiteX8" fmla="*/ 0 w 6526060"/>
+              <a:gd name="connsiteY8" fmla="*/ 467654 h 4434216"/>
+              <a:gd name="connsiteX0" fmla="*/ 0 w 6526060"/>
+              <a:gd name="connsiteY0" fmla="*/ 436338 h 4434216"/>
+              <a:gd name="connsiteX1" fmla="*/ 749489 w 6526060"/>
+              <a:gd name="connsiteY1" fmla="*/ 0 h 4434216"/>
+              <a:gd name="connsiteX2" fmla="*/ 5789097 w 6526060"/>
+              <a:gd name="connsiteY2" fmla="*/ 0 h 4434216"/>
+              <a:gd name="connsiteX3" fmla="*/ 6519797 w 6526060"/>
+              <a:gd name="connsiteY3" fmla="*/ 473917 h 4434216"/>
+              <a:gd name="connsiteX4" fmla="*/ 6526060 w 6526060"/>
+              <a:gd name="connsiteY4" fmla="*/ 3684727 h 4434216"/>
+              <a:gd name="connsiteX5" fmla="*/ 6121037 w 6526060"/>
+              <a:gd name="connsiteY5" fmla="*/ 4421690 h 4434216"/>
+              <a:gd name="connsiteX6" fmla="*/ 511494 w 6526060"/>
+              <a:gd name="connsiteY6" fmla="*/ 4434216 h 4434216"/>
+              <a:gd name="connsiteX7" fmla="*/ 12526 w 6526060"/>
+              <a:gd name="connsiteY7" fmla="*/ 3684727 h 4434216"/>
+              <a:gd name="connsiteX8" fmla="*/ 0 w 6526060"/>
+              <a:gd name="connsiteY8" fmla="*/ 436338 h 4434216"/>
+            </a:gdLst>
+            <a:ahLst/>
+            <a:cxnLst>
+              <a:cxn ang="0">
+                <a:pos x="connsiteX0" y="connsiteY0"/>
+              </a:cxn>
+              <a:cxn ang="0">
+                <a:pos x="connsiteX1" y="connsiteY1"/>
+              </a:cxn>
+              <a:cxn ang="0">
+                <a:pos x="connsiteX2" y="connsiteY2"/>
+              </a:cxn>
+              <a:cxn ang="0">
+                <a:pos x="connsiteX3" y="connsiteY3"/>
+              </a:cxn>
+              <a:cxn ang="0">
+                <a:pos x="connsiteX4" y="connsiteY4"/>
+              </a:cxn>
+              <a:cxn ang="0">
+                <a:pos x="connsiteX5" y="connsiteY5"/>
+              </a:cxn>
+              <a:cxn ang="0">
+                <a:pos x="connsiteX6" y="connsiteY6"/>
+              </a:cxn>
+              <a:cxn ang="0">
+                <a:pos x="connsiteX7" y="connsiteY7"/>
+              </a:cxn>
+              <a:cxn ang="0">
+                <a:pos x="connsiteX8" y="connsiteY8"/>
+              </a:cxn>
+            </a:cxnLst>
+            <a:rect l="l" t="t" r="r" b="b"/>
+            <a:pathLst>
+              <a:path w="6526060" h="4434216">
+                <a:moveTo>
+                  <a:pt x="0" y="436338"/>
+                </a:moveTo>
+                <a:cubicBezTo>
+                  <a:pt x="0" y="29325"/>
+                  <a:pt x="342476" y="0"/>
+                  <a:pt x="749489" y="0"/>
+                </a:cubicBezTo>
+                <a:lnTo>
+                  <a:pt x="5789097" y="0"/>
+                </a:lnTo>
+                <a:cubicBezTo>
+                  <a:pt x="6196110" y="0"/>
+                  <a:pt x="6519797" y="66904"/>
+                  <a:pt x="6519797" y="473917"/>
+                </a:cubicBezTo>
+                <a:cubicBezTo>
+                  <a:pt x="6521885" y="1544187"/>
+                  <a:pt x="6523972" y="2614457"/>
+                  <a:pt x="6526060" y="3684727"/>
+                </a:cubicBezTo>
+                <a:cubicBezTo>
+                  <a:pt x="6526060" y="4091740"/>
+                  <a:pt x="6528050" y="4421690"/>
+                  <a:pt x="6121037" y="4421690"/>
+                </a:cubicBezTo>
+                <a:lnTo>
+                  <a:pt x="511494" y="4434216"/>
+                </a:lnTo>
+                <a:cubicBezTo>
+                  <a:pt x="104481" y="4434216"/>
+                  <a:pt x="12526" y="4091740"/>
+                  <a:pt x="12526" y="3684727"/>
+                </a:cubicBezTo>
+                <a:cubicBezTo>
+                  <a:pt x="8351" y="2612369"/>
+                  <a:pt x="4175" y="1508696"/>
+                  <a:pt x="0" y="436338"/>
+                </a:cubicBezTo>
+                <a:close/>
+              </a:path>
+            </a:pathLst>
+          </a:custGeom>
+          <a:solidFill>
+            <a:schemeClr val="bg1"/>
+          </a:solidFill>
+          <a:ln>
+            <a:noFill/>
+          </a:ln>
+          <a:effectLst>
+            <a:outerShdw blurRad="50800" dist="38100" dir="2700000" algn="tl" rotWithShape="0">
+              <a:prstClr val="black">
+                <a:alpha val="40000"/>
+              </a:prstClr>
+            </a:outerShdw>
+          </a:effectLst>
+        </p:spPr>
+        <p:style>
+          <a:lnRef idx="2">
+            <a:schemeClr val="accent1">
+              <a:shade val="15000"/>
+            </a:schemeClr>
+          </a:lnRef>
+          <a:fillRef idx="1">
+            <a:schemeClr val="accent1"/>
+          </a:fillRef>
+          <a:effectRef idx="0">
+            <a:schemeClr val="accent1"/>
+          </a:effectRef>
+          <a:fontRef idx="minor">
+            <a:schemeClr val="lt1"/>
+          </a:fontRef>
+        </p:style>
+        <p:txBody>
+          <a:bodyPr rtlCol="0" anchor="ctr"/>
+          <a:lstStyle/>
+          <a:p>
+            <a:pPr algn="ctr"/>
+            <a:endParaRPr lang="pl-PL" dirty="0"/>
+          </a:p>
+        </p:txBody>
+      </p:sp>
+      <p:sp>
+        <p:nvSpPr>
+          <p:cNvPr id="6" name="Rectangle: Rounded Corners 5">
+            <a:extLst>
+              <a:ext uri="{FF2B5EF4-FFF2-40B4-BE49-F238E27FC236}">
+                <a16:creationId xmlns:a16="http://schemas.microsoft.com/office/drawing/2014/main" id="{01A02AC3-F332-E8D1-8C8D-3647343BEAC5}"/>
+              </a:ext>
+            </a:extLst>
+          </p:cNvPr>
+          <p:cNvSpPr/>
+          <p:nvPr/>
+        </p:nvSpPr>
+        <p:spPr>
+          <a:xfrm flipV="1">
+            <a:off x="882651" y="564057"/>
+            <a:ext cx="11168380" cy="724591"/>
+          </a:xfrm>
+          <a:prstGeom prst="roundRect">
+            <a:avLst/>
+          </a:prstGeom>
+          <a:solidFill>
+            <a:schemeClr val="bg1"/>
+          </a:solidFill>
+          <a:ln>
+            <a:noFill/>
+          </a:ln>
+          <a:effectLst>
+            <a:outerShdw blurRad="50800" dist="38100" dir="2700000" algn="tl" rotWithShape="0">
+              <a:prstClr val="black">
+                <a:alpha val="40000"/>
+              </a:prstClr>
+            </a:outerShdw>
+          </a:effectLst>
+        </p:spPr>
+        <p:style>
+          <a:lnRef idx="2">
+            <a:schemeClr val="accent1">
+              <a:shade val="15000"/>
+            </a:schemeClr>
+          </a:lnRef>
+          <a:fillRef idx="1">
+            <a:schemeClr val="accent1"/>
+          </a:fillRef>
+          <a:effectRef idx="0">
+            <a:schemeClr val="accent1"/>
+          </a:effectRef>
+          <a:fontRef idx="minor">
+            <a:schemeClr val="lt1"/>
+          </a:fontRef>
+        </p:style>
+        <p:txBody>
+          <a:bodyPr rtlCol="0" anchor="ctr"/>
+          <a:lstStyle/>
+          <a:p>
+            <a:pPr algn="ctr"/>
+            <a:endParaRPr lang="pl-PL" dirty="0"/>
+          </a:p>
+        </p:txBody>
+      </p:sp>
+      <p:sp>
+        <p:nvSpPr>
+          <p:cNvPr id="32" name="Rectangle: Rounded Corners 31">
+            <a:extLst>
+              <a:ext uri="{FF2B5EF4-FFF2-40B4-BE49-F238E27FC236}">
+                <a16:creationId xmlns:a16="http://schemas.microsoft.com/office/drawing/2014/main" id="{280E6818-937E-29C6-1BCE-5A2290B68E28}"/>
+              </a:ext>
+            </a:extLst>
+          </p:cNvPr>
+          <p:cNvSpPr/>
+          <p:nvPr/>
+        </p:nvSpPr>
+        <p:spPr>
+          <a:xfrm flipV="1">
+            <a:off x="126124" y="6431279"/>
+            <a:ext cx="11865908" cy="353753"/>
+          </a:xfrm>
+          <a:prstGeom prst="roundRect">
+            <a:avLst/>
+          </a:prstGeom>
+          <a:solidFill>
+            <a:schemeClr val="bg1"/>
+          </a:solidFill>
+          <a:ln>
+            <a:noFill/>
+          </a:ln>
+          <a:effectLst>
+            <a:outerShdw blurRad="50800" dist="38100" dir="2700000" algn="tl" rotWithShape="0">
+              <a:prstClr val="black">
+                <a:alpha val="40000"/>
+              </a:prstClr>
+            </a:outerShdw>
+          </a:effectLst>
+        </p:spPr>
+        <p:style>
+          <a:lnRef idx="2">
+            <a:schemeClr val="accent1">
+              <a:shade val="15000"/>
+            </a:schemeClr>
+          </a:lnRef>
+          <a:fillRef idx="1">
+            <a:schemeClr val="accent1"/>
+          </a:fillRef>
+          <a:effectRef idx="0">
+            <a:schemeClr val="accent1"/>
+          </a:effectRef>
+          <a:fontRef idx="minor">
+            <a:schemeClr val="lt1"/>
+          </a:fontRef>
+        </p:style>
+        <p:txBody>
+          <a:bodyPr rtlCol="0" anchor="ctr"/>
+          <a:lstStyle/>
+          <a:p>
+            <a:pPr algn="ctr"/>
+            <a:endParaRPr lang="pl-PL" dirty="0"/>
+          </a:p>
+        </p:txBody>
+      </p:sp>
+    </p:spTree>
+    <p:extLst>
+      <p:ext uri="{BB962C8B-B14F-4D97-AF65-F5344CB8AC3E}">
+        <p14:creationId xmlns:p14="http://schemas.microsoft.com/office/powerpoint/2010/main" val="2456703839"/>
+      </p:ext>
+    </p:extLst>
+  </p:cSld>
+  <p:clrMapOvr>
+    <a:masterClrMapping/>
+  </p:clrMapOvr>
+</p:sld>
+</file>
+
+<file path=ppt/slides/slide5.xml><?xml version="1.0" encoding="utf-8"?>
+<p:sld xmlns:a="http://schemas.openxmlformats.org/drawingml/2006/main" xmlns:r="http://schemas.openxmlformats.org/officeDocument/2006/relationships" xmlns:p="http://schemas.openxmlformats.org/presentationml/2006/main">
+  <p:cSld>
+    <p:bg>
+      <p:bgPr>
+        <a:solidFill>
+          <a:srgbClr val="A0A7D8">
+            <a:alpha val="15000"/>
+          </a:srgbClr>
+        </a:solidFill>
+        <a:effectLst/>
+      </p:bgPr>
+    </p:bg>
+    <p:spTree>
+      <p:nvGrpSpPr>
+        <p:cNvPr id="1" name="">
+          <a:extLst>
+            <a:ext uri="{FF2B5EF4-FFF2-40B4-BE49-F238E27FC236}">
+              <a16:creationId xmlns:a16="http://schemas.microsoft.com/office/drawing/2014/main" id="{614C3728-6705-680A-9FB9-1D0586271C69}"/>
+            </a:ext>
+          </a:extLst>
+        </p:cNvPr>
+        <p:cNvGrpSpPr/>
+        <p:nvPr/>
+      </p:nvGrpSpPr>
+      <p:grpSpPr>
+        <a:xfrm>
+          <a:off x="0" y="0"/>
+          <a:ext cx="0" cy="0"/>
+          <a:chOff x="0" y="0"/>
+          <a:chExt cx="0" cy="0"/>
+        </a:xfrm>
+      </p:grpSpPr>
+      <p:sp>
+        <p:nvSpPr>
+          <p:cNvPr id="7" name="Rectangle: Rounded Corners 6">
+            <a:extLst>
+              <a:ext uri="{FF2B5EF4-FFF2-40B4-BE49-F238E27FC236}">
+                <a16:creationId xmlns:a16="http://schemas.microsoft.com/office/drawing/2014/main" id="{67EEFAC3-0642-9B7A-7EFC-69B9521F4FBF}"/>
+              </a:ext>
+            </a:extLst>
+          </p:cNvPr>
+          <p:cNvSpPr/>
+          <p:nvPr/>
+        </p:nvSpPr>
+        <p:spPr>
+          <a:xfrm flipV="1">
+            <a:off x="2226905" y="725535"/>
+            <a:ext cx="7738189" cy="696687"/>
+          </a:xfrm>
+          <a:prstGeom prst="roundRect">
+            <a:avLst/>
+          </a:prstGeom>
+          <a:solidFill>
+            <a:schemeClr val="bg1"/>
+          </a:solidFill>
+          <a:ln>
+            <a:noFill/>
+          </a:ln>
+          <a:effectLst>
+            <a:outerShdw blurRad="50800" dist="38100" dir="2700000" algn="tl" rotWithShape="0">
+              <a:prstClr val="black">
+                <a:alpha val="40000"/>
+              </a:prstClr>
+            </a:outerShdw>
+          </a:effectLst>
+        </p:spPr>
+        <p:style>
+          <a:lnRef idx="2">
+            <a:schemeClr val="accent1">
+              <a:shade val="15000"/>
+            </a:schemeClr>
+          </a:lnRef>
+          <a:fillRef idx="1">
+            <a:schemeClr val="accent1"/>
+          </a:fillRef>
+          <a:effectRef idx="0">
+            <a:schemeClr val="accent1"/>
+          </a:effectRef>
+          <a:fontRef idx="minor">
+            <a:schemeClr val="lt1"/>
+          </a:fontRef>
+        </p:style>
+        <p:txBody>
+          <a:bodyPr rtlCol="0" anchor="ctr"/>
+          <a:lstStyle/>
+          <a:p>
+            <a:pPr algn="ctr"/>
+            <a:endParaRPr lang="pl-PL" dirty="0"/>
+          </a:p>
+        </p:txBody>
+      </p:sp>
+      <p:sp>
+        <p:nvSpPr>
+          <p:cNvPr id="8" name="Rectangle: Rounded Corners 7">
+            <a:extLst>
+              <a:ext uri="{FF2B5EF4-FFF2-40B4-BE49-F238E27FC236}">
+                <a16:creationId xmlns:a16="http://schemas.microsoft.com/office/drawing/2014/main" id="{8BA61791-DDAA-ABBB-402B-7508782933E5}"/>
+              </a:ext>
+            </a:extLst>
+          </p:cNvPr>
+          <p:cNvSpPr/>
+          <p:nvPr/>
+        </p:nvSpPr>
+        <p:spPr>
+          <a:xfrm flipV="1">
+            <a:off x="1175659" y="1654628"/>
+            <a:ext cx="9610530" cy="4987908"/>
+          </a:xfrm>
+          <a:custGeom>
+            <a:avLst/>
+            <a:gdLst>
+              <a:gd name="connsiteX0" fmla="*/ 0 w 9209315"/>
+              <a:gd name="connsiteY0" fmla="*/ 894552 h 5367205"/>
+              <a:gd name="connsiteX1" fmla="*/ 894552 w 9209315"/>
+              <a:gd name="connsiteY1" fmla="*/ 0 h 5367205"/>
+              <a:gd name="connsiteX2" fmla="*/ 8314763 w 9209315"/>
+              <a:gd name="connsiteY2" fmla="*/ 0 h 5367205"/>
+              <a:gd name="connsiteX3" fmla="*/ 9209315 w 9209315"/>
+              <a:gd name="connsiteY3" fmla="*/ 894552 h 5367205"/>
+              <a:gd name="connsiteX4" fmla="*/ 9209315 w 9209315"/>
+              <a:gd name="connsiteY4" fmla="*/ 4472653 h 5367205"/>
+              <a:gd name="connsiteX5" fmla="*/ 8314763 w 9209315"/>
+              <a:gd name="connsiteY5" fmla="*/ 5367205 h 5367205"/>
+              <a:gd name="connsiteX6" fmla="*/ 894552 w 9209315"/>
+              <a:gd name="connsiteY6" fmla="*/ 5367205 h 5367205"/>
+              <a:gd name="connsiteX7" fmla="*/ 0 w 9209315"/>
+              <a:gd name="connsiteY7" fmla="*/ 4472653 h 5367205"/>
+              <a:gd name="connsiteX8" fmla="*/ 0 w 9209315"/>
+              <a:gd name="connsiteY8" fmla="*/ 894552 h 5367205"/>
+              <a:gd name="connsiteX0" fmla="*/ 1583 w 9210898"/>
+              <a:gd name="connsiteY0" fmla="*/ 899705 h 5372358"/>
+              <a:gd name="connsiteX1" fmla="*/ 896135 w 9210898"/>
+              <a:gd name="connsiteY1" fmla="*/ 5153 h 5372358"/>
+              <a:gd name="connsiteX2" fmla="*/ 8316346 w 9210898"/>
+              <a:gd name="connsiteY2" fmla="*/ 5153 h 5372358"/>
+              <a:gd name="connsiteX3" fmla="*/ 9210898 w 9210898"/>
+              <a:gd name="connsiteY3" fmla="*/ 899705 h 5372358"/>
+              <a:gd name="connsiteX4" fmla="*/ 9210898 w 9210898"/>
+              <a:gd name="connsiteY4" fmla="*/ 4477806 h 5372358"/>
+              <a:gd name="connsiteX5" fmla="*/ 8316346 w 9210898"/>
+              <a:gd name="connsiteY5" fmla="*/ 5372358 h 5372358"/>
+              <a:gd name="connsiteX6" fmla="*/ 896135 w 9210898"/>
+              <a:gd name="connsiteY6" fmla="*/ 5372358 h 5372358"/>
+              <a:gd name="connsiteX7" fmla="*/ 1583 w 9210898"/>
+              <a:gd name="connsiteY7" fmla="*/ 4477806 h 5372358"/>
+              <a:gd name="connsiteX8" fmla="*/ 1583 w 9210898"/>
+              <a:gd name="connsiteY8" fmla="*/ 899705 h 5372358"/>
+              <a:gd name="connsiteX0" fmla="*/ 31102 w 9240417"/>
+              <a:gd name="connsiteY0" fmla="*/ 899705 h 5375295"/>
+              <a:gd name="connsiteX1" fmla="*/ 925654 w 9240417"/>
+              <a:gd name="connsiteY1" fmla="*/ 5153 h 5375295"/>
+              <a:gd name="connsiteX2" fmla="*/ 8345865 w 9240417"/>
+              <a:gd name="connsiteY2" fmla="*/ 5153 h 5375295"/>
+              <a:gd name="connsiteX3" fmla="*/ 9240417 w 9240417"/>
+              <a:gd name="connsiteY3" fmla="*/ 899705 h 5375295"/>
+              <a:gd name="connsiteX4" fmla="*/ 9240417 w 9240417"/>
+              <a:gd name="connsiteY4" fmla="*/ 4477806 h 5375295"/>
+              <a:gd name="connsiteX5" fmla="*/ 8345865 w 9240417"/>
+              <a:gd name="connsiteY5" fmla="*/ 5372358 h 5375295"/>
+              <a:gd name="connsiteX6" fmla="*/ 925654 w 9240417"/>
+              <a:gd name="connsiteY6" fmla="*/ 5372358 h 5375295"/>
+              <a:gd name="connsiteX7" fmla="*/ 0 w 9240417"/>
+              <a:gd name="connsiteY7" fmla="*/ 4944337 h 5375295"/>
+              <a:gd name="connsiteX8" fmla="*/ 31102 w 9240417"/>
+              <a:gd name="connsiteY8" fmla="*/ 899705 h 5375295"/>
+              <a:gd name="connsiteX0" fmla="*/ 31102 w 9240417"/>
+              <a:gd name="connsiteY0" fmla="*/ 899705 h 5375295"/>
+              <a:gd name="connsiteX1" fmla="*/ 925654 w 9240417"/>
+              <a:gd name="connsiteY1" fmla="*/ 5153 h 5375295"/>
+              <a:gd name="connsiteX2" fmla="*/ 8345865 w 9240417"/>
+              <a:gd name="connsiteY2" fmla="*/ 5153 h 5375295"/>
+              <a:gd name="connsiteX3" fmla="*/ 9240417 w 9240417"/>
+              <a:gd name="connsiteY3" fmla="*/ 899705 h 5375295"/>
+              <a:gd name="connsiteX4" fmla="*/ 9234197 w 9240417"/>
+              <a:gd name="connsiteY4" fmla="*/ 4919455 h 5375295"/>
+              <a:gd name="connsiteX5" fmla="*/ 8345865 w 9240417"/>
+              <a:gd name="connsiteY5" fmla="*/ 5372358 h 5375295"/>
+              <a:gd name="connsiteX6" fmla="*/ 925654 w 9240417"/>
+              <a:gd name="connsiteY6" fmla="*/ 5372358 h 5375295"/>
+              <a:gd name="connsiteX7" fmla="*/ 0 w 9240417"/>
+              <a:gd name="connsiteY7" fmla="*/ 4944337 h 5375295"/>
+              <a:gd name="connsiteX8" fmla="*/ 31102 w 9240417"/>
+              <a:gd name="connsiteY8" fmla="*/ 899705 h 5375295"/>
+              <a:gd name="connsiteX0" fmla="*/ 31102 w 9234795"/>
+              <a:gd name="connsiteY0" fmla="*/ 899705 h 5375295"/>
+              <a:gd name="connsiteX1" fmla="*/ 925654 w 9234795"/>
+              <a:gd name="connsiteY1" fmla="*/ 5153 h 5375295"/>
+              <a:gd name="connsiteX2" fmla="*/ 8345865 w 9234795"/>
+              <a:gd name="connsiteY2" fmla="*/ 5153 h 5375295"/>
+              <a:gd name="connsiteX3" fmla="*/ 9234196 w 9234795"/>
+              <a:gd name="connsiteY3" fmla="*/ 451836 h 5375295"/>
+              <a:gd name="connsiteX4" fmla="*/ 9234197 w 9234795"/>
+              <a:gd name="connsiteY4" fmla="*/ 4919455 h 5375295"/>
+              <a:gd name="connsiteX5" fmla="*/ 8345865 w 9234795"/>
+              <a:gd name="connsiteY5" fmla="*/ 5372358 h 5375295"/>
+              <a:gd name="connsiteX6" fmla="*/ 925654 w 9234795"/>
+              <a:gd name="connsiteY6" fmla="*/ 5372358 h 5375295"/>
+              <a:gd name="connsiteX7" fmla="*/ 0 w 9234795"/>
+              <a:gd name="connsiteY7" fmla="*/ 4944337 h 5375295"/>
+              <a:gd name="connsiteX8" fmla="*/ 31102 w 9234795"/>
+              <a:gd name="connsiteY8" fmla="*/ 899705 h 5375295"/>
+            </a:gdLst>
+            <a:ahLst/>
+            <a:cxnLst>
+              <a:cxn ang="0">
+                <a:pos x="connsiteX0" y="connsiteY0"/>
+              </a:cxn>
+              <a:cxn ang="0">
+                <a:pos x="connsiteX1" y="connsiteY1"/>
+              </a:cxn>
+              <a:cxn ang="0">
+                <a:pos x="connsiteX2" y="connsiteY2"/>
+              </a:cxn>
+              <a:cxn ang="0">
+                <a:pos x="connsiteX3" y="connsiteY3"/>
+              </a:cxn>
+              <a:cxn ang="0">
+                <a:pos x="connsiteX4" y="connsiteY4"/>
+              </a:cxn>
+              <a:cxn ang="0">
+                <a:pos x="connsiteX5" y="connsiteY5"/>
+              </a:cxn>
+              <a:cxn ang="0">
+                <a:pos x="connsiteX6" y="connsiteY6"/>
+              </a:cxn>
+              <a:cxn ang="0">
+                <a:pos x="connsiteX7" y="connsiteY7"/>
+              </a:cxn>
+              <a:cxn ang="0">
+                <a:pos x="connsiteX8" y="connsiteY8"/>
+              </a:cxn>
+            </a:cxnLst>
+            <a:rect l="l" t="t" r="r" b="b"/>
+            <a:pathLst>
+              <a:path w="9234795" h="5375295">
+                <a:moveTo>
+                  <a:pt x="31102" y="899705"/>
+                </a:moveTo>
+                <a:cubicBezTo>
+                  <a:pt x="0" y="-123077"/>
+                  <a:pt x="431607" y="5153"/>
+                  <a:pt x="925654" y="5153"/>
+                </a:cubicBezTo>
+                <a:lnTo>
+                  <a:pt x="8345865" y="5153"/>
+                </a:lnTo>
+                <a:cubicBezTo>
+                  <a:pt x="8839912" y="5153"/>
+                  <a:pt x="9234196" y="-42211"/>
+                  <a:pt x="9234196" y="451836"/>
+                </a:cubicBezTo>
+                <a:cubicBezTo>
+                  <a:pt x="9232123" y="1791753"/>
+                  <a:pt x="9236270" y="3579538"/>
+                  <a:pt x="9234197" y="4919455"/>
+                </a:cubicBezTo>
+                <a:cubicBezTo>
+                  <a:pt x="9234197" y="5413502"/>
+                  <a:pt x="8839912" y="5372358"/>
+                  <a:pt x="8345865" y="5372358"/>
+                </a:cubicBezTo>
+                <a:lnTo>
+                  <a:pt x="925654" y="5372358"/>
+                </a:lnTo>
+                <a:cubicBezTo>
+                  <a:pt x="431607" y="5372358"/>
+                  <a:pt x="0" y="5438384"/>
+                  <a:pt x="0" y="4944337"/>
+                </a:cubicBezTo>
+                <a:lnTo>
+                  <a:pt x="31102" y="899705"/>
+                </a:lnTo>
+                <a:close/>
+              </a:path>
+            </a:pathLst>
+          </a:custGeom>
+          <a:solidFill>
+            <a:schemeClr val="bg1"/>
+          </a:solidFill>
+          <a:ln>
+            <a:noFill/>
+          </a:ln>
+          <a:effectLst>
+            <a:outerShdw blurRad="50800" dist="38100" dir="2700000" algn="tl" rotWithShape="0">
+              <a:prstClr val="black">
+                <a:alpha val="40000"/>
+              </a:prstClr>
+            </a:outerShdw>
+          </a:effectLst>
+        </p:spPr>
+        <p:style>
+          <a:lnRef idx="2">
+            <a:schemeClr val="accent1">
+              <a:shade val="15000"/>
+            </a:schemeClr>
+          </a:lnRef>
+          <a:fillRef idx="1">
+            <a:schemeClr val="accent1"/>
+          </a:fillRef>
+          <a:effectRef idx="0">
+            <a:schemeClr val="accent1"/>
+          </a:effectRef>
+          <a:fontRef idx="minor">
+            <a:schemeClr val="lt1"/>
+          </a:fontRef>
+        </p:style>
+        <p:txBody>
+          <a:bodyPr rtlCol="0" anchor="ctr"/>
+          <a:lstStyle/>
+          <a:p>
+            <a:pPr algn="ctr"/>
+            <a:endParaRPr lang="pl-PL" dirty="0"/>
+          </a:p>
+        </p:txBody>
+      </p:sp>
+    </p:spTree>
+    <p:extLst>
+      <p:ext uri="{BB962C8B-B14F-4D97-AF65-F5344CB8AC3E}">
+        <p14:creationId xmlns:p14="http://schemas.microsoft.com/office/powerpoint/2010/main" val="3729916357"/>
       </p:ext>
     </p:extLst>
   </p:cSld>
@@ -3922,4 +7550,299 @@
     </a:ext>
   </a:extLst>
 </a:theme>
+</file>
+
+<file path=ppt/theme/theme2.xml><?xml version="1.0" encoding="utf-8"?>
+<a:theme xmlns:a="http://schemas.openxmlformats.org/drawingml/2006/main" name="Office Theme">
+  <a:themeElements>
+    <a:clrScheme name="Office">
+      <a:dk1>
+        <a:sysClr val="windowText" lastClr="000000"/>
+      </a:dk1>
+      <a:lt1>
+        <a:sysClr val="window" lastClr="FFFFFF"/>
+      </a:lt1>
+      <a:dk2>
+        <a:srgbClr val="44546A"/>
+      </a:dk2>
+      <a:lt2>
+        <a:srgbClr val="E7E6E6"/>
+      </a:lt2>
+      <a:accent1>
+        <a:srgbClr val="4472C4"/>
+      </a:accent1>
+      <a:accent2>
+        <a:srgbClr val="ED7D31"/>
+      </a:accent2>
+      <a:accent3>
+        <a:srgbClr val="A5A5A5"/>
+      </a:accent3>
+      <a:accent4>
+        <a:srgbClr val="FFC000"/>
+      </a:accent4>
+      <a:accent5>
+        <a:srgbClr val="5B9BD5"/>
+      </a:accent5>
+      <a:accent6>
+        <a:srgbClr val="70AD47"/>
+      </a:accent6>
+      <a:hlink>
+        <a:srgbClr val="0563C1"/>
+      </a:hlink>
+      <a:folHlink>
+        <a:srgbClr val="954F72"/>
+      </a:folHlink>
+    </a:clrScheme>
+    <a:fontScheme name="Office">
+      <a:majorFont>
+        <a:latin typeface="Calibri Light" panose="020F0302020204030204"/>
+        <a:ea typeface=""/>
+        <a:cs typeface=""/>
+        <a:font script="Jpan" typeface="游ゴシック Light"/>
+        <a:font script="Hang" typeface="맑은 고딕"/>
+        <a:font script="Hans" typeface="等线 Light"/>
+        <a:font script="Hant" typeface="新細明體"/>
+        <a:font script="Arab" typeface="Times New Roman"/>
+        <a:font script="Hebr" typeface="Times New Roman"/>
+        <a:font script="Thai" typeface="Angsana New"/>
+        <a:font script="Ethi" typeface="Nyala"/>
+        <a:font script="Beng" typeface="Vrinda"/>
+        <a:font script="Gujr" typeface="Shruti"/>
+        <a:font script="Khmr" typeface="MoolBoran"/>
+        <a:font script="Knda" typeface="Tunga"/>
+        <a:font script="Guru" typeface="Raavi"/>
+        <a:font script="Cans" typeface="Euphemia"/>
+        <a:font script="Cher" typeface="Plantagenet Cherokee"/>
+        <a:font script="Yiii" typeface="Microsoft Yi Baiti"/>
+        <a:font script="Tibt" typeface="Microsoft Himalaya"/>
+        <a:font script="Thaa" typeface="MV Boli"/>
+        <a:font script="Deva" typeface="Mangal"/>
+        <a:font script="Telu" typeface="Gautami"/>
+        <a:font script="Taml" typeface="Latha"/>
+        <a:font script="Syrc" typeface="Estrangelo Edessa"/>
+        <a:font script="Orya" typeface="Kalinga"/>
+        <a:font script="Mlym" typeface="Kartika"/>
+        <a:font script="Laoo" typeface="DokChampa"/>
+        <a:font script="Sinh" typeface="Iskoola Pota"/>
+        <a:font script="Mong" typeface="Mongolian Baiti"/>
+        <a:font script="Viet" typeface="Times New Roman"/>
+        <a:font script="Uigh" typeface="Microsoft Uighur"/>
+        <a:font script="Geor" typeface="Sylfaen"/>
+        <a:font script="Armn" typeface="Arial"/>
+        <a:font script="Bugi" typeface="Leelawadee UI"/>
+        <a:font script="Bopo" typeface="Microsoft JhengHei"/>
+        <a:font script="Java" typeface="Javanese Text"/>
+        <a:font script="Lisu" typeface="Segoe UI"/>
+        <a:font script="Mymr" typeface="Myanmar Text"/>
+        <a:font script="Nkoo" typeface="Ebrima"/>
+        <a:font script="Olck" typeface="Nirmala UI"/>
+        <a:font script="Osma" typeface="Ebrima"/>
+        <a:font script="Phag" typeface="Phagspa"/>
+        <a:font script="Syrn" typeface="Estrangelo Edessa"/>
+        <a:font script="Syrj" typeface="Estrangelo Edessa"/>
+        <a:font script="Syre" typeface="Estrangelo Edessa"/>
+        <a:font script="Sora" typeface="Nirmala UI"/>
+        <a:font script="Tale" typeface="Microsoft Tai Le"/>
+        <a:font script="Talu" typeface="Microsoft New Tai Lue"/>
+        <a:font script="Tfng" typeface="Ebrima"/>
+      </a:majorFont>
+      <a:minorFont>
+        <a:latin typeface="Calibri" panose="020F0502020204030204"/>
+        <a:ea typeface=""/>
+        <a:cs typeface=""/>
+        <a:font script="Jpan" typeface="游ゴシック"/>
+        <a:font script="Hang" typeface="맑은 고딕"/>
+        <a:font script="Hans" typeface="等线"/>
+        <a:font script="Hant" typeface="新細明體"/>
+        <a:font script="Arab" typeface="Arial"/>
+        <a:font script="Hebr" typeface="Arial"/>
+        <a:font script="Thai" typeface="Cordia New"/>
+        <a:font script="Ethi" typeface="Nyala"/>
+        <a:font script="Beng" typeface="Vrinda"/>
+        <a:font script="Gujr" typeface="Shruti"/>
+        <a:font script="Khmr" typeface="DaunPenh"/>
+        <a:font script="Knda" typeface="Tunga"/>
+        <a:font script="Guru" typeface="Raavi"/>
+        <a:font script="Cans" typeface="Euphemia"/>
+        <a:font script="Cher" typeface="Plantagenet Cherokee"/>
+        <a:font script="Yiii" typeface="Microsoft Yi Baiti"/>
+        <a:font script="Tibt" typeface="Microsoft Himalaya"/>
+        <a:font script="Thaa" typeface="MV Boli"/>
+        <a:font script="Deva" typeface="Mangal"/>
+        <a:font script="Telu" typeface="Gautami"/>
+        <a:font script="Taml" typeface="Latha"/>
+        <a:font script="Syrc" typeface="Estrangelo Edessa"/>
+        <a:font script="Orya" typeface="Kalinga"/>
+        <a:font script="Mlym" typeface="Kartika"/>
+        <a:font script="Laoo" typeface="DokChampa"/>
+        <a:font script="Sinh" typeface="Iskoola Pota"/>
+        <a:font script="Mong" typeface="Mongolian Baiti"/>
+        <a:font script="Viet" typeface="Arial"/>
+        <a:font script="Uigh" typeface="Microsoft Uighur"/>
+        <a:font script="Geor" typeface="Sylfaen"/>
+        <a:font script="Armn" typeface="Arial"/>
+        <a:font script="Bugi" typeface="Leelawadee UI"/>
+        <a:font script="Bopo" typeface="Microsoft JhengHei"/>
+        <a:font script="Java" typeface="Javanese Text"/>
+        <a:font script="Lisu" typeface="Segoe UI"/>
+        <a:font script="Mymr" typeface="Myanmar Text"/>
+        <a:font script="Nkoo" typeface="Ebrima"/>
+        <a:font script="Olck" typeface="Nirmala UI"/>
+        <a:font script="Osma" typeface="Ebrima"/>
+        <a:font script="Phag" typeface="Phagspa"/>
+        <a:font script="Syrn" typeface="Estrangelo Edessa"/>
+        <a:font script="Syrj" typeface="Estrangelo Edessa"/>
+        <a:font script="Syre" typeface="Estrangelo Edessa"/>
+        <a:font script="Sora" typeface="Nirmala UI"/>
+        <a:font script="Tale" typeface="Microsoft Tai Le"/>
+        <a:font script="Talu" typeface="Microsoft New Tai Lue"/>
+        <a:font script="Tfng" typeface="Ebrima"/>
+      </a:minorFont>
+    </a:fontScheme>
+    <a:fmtScheme name="Office">
+      <a:fillStyleLst>
+        <a:solidFill>
+          <a:schemeClr val="phClr"/>
+        </a:solidFill>
+        <a:gradFill rotWithShape="1">
+          <a:gsLst>
+            <a:gs pos="0">
+              <a:schemeClr val="phClr">
+                <a:lumMod val="110000"/>
+                <a:satMod val="105000"/>
+                <a:tint val="67000"/>
+              </a:schemeClr>
+            </a:gs>
+            <a:gs pos="50000">
+              <a:schemeClr val="phClr">
+                <a:lumMod val="105000"/>
+                <a:satMod val="103000"/>
+                <a:tint val="73000"/>
+              </a:schemeClr>
+            </a:gs>
+            <a:gs pos="100000">
+              <a:schemeClr val="phClr">
+                <a:lumMod val="105000"/>
+                <a:satMod val="109000"/>
+                <a:tint val="81000"/>
+              </a:schemeClr>
+            </a:gs>
+          </a:gsLst>
+          <a:lin ang="5400000" scaled="0"/>
+        </a:gradFill>
+        <a:gradFill rotWithShape="1">
+          <a:gsLst>
+            <a:gs pos="0">
+              <a:schemeClr val="phClr">
+                <a:satMod val="103000"/>
+                <a:lumMod val="102000"/>
+                <a:tint val="94000"/>
+              </a:schemeClr>
+            </a:gs>
+            <a:gs pos="50000">
+              <a:schemeClr val="phClr">
+                <a:satMod val="110000"/>
+                <a:lumMod val="100000"/>
+                <a:shade val="100000"/>
+              </a:schemeClr>
+            </a:gs>
+            <a:gs pos="100000">
+              <a:schemeClr val="phClr">
+                <a:lumMod val="99000"/>
+                <a:satMod val="120000"/>
+                <a:shade val="78000"/>
+              </a:schemeClr>
+            </a:gs>
+          </a:gsLst>
+          <a:lin ang="5400000" scaled="0"/>
+        </a:gradFill>
+      </a:fillStyleLst>
+      <a:lnStyleLst>
+        <a:ln w="6350" cap="flat" cmpd="sng" algn="ctr">
+          <a:solidFill>
+            <a:schemeClr val="phClr"/>
+          </a:solidFill>
+          <a:prstDash val="solid"/>
+          <a:miter lim="800000"/>
+        </a:ln>
+        <a:ln w="12700" cap="flat" cmpd="sng" algn="ctr">
+          <a:solidFill>
+            <a:schemeClr val="phClr"/>
+          </a:solidFill>
+          <a:prstDash val="solid"/>
+          <a:miter lim="800000"/>
+        </a:ln>
+        <a:ln w="19050" cap="flat" cmpd="sng" algn="ctr">
+          <a:solidFill>
+            <a:schemeClr val="phClr"/>
+          </a:solidFill>
+          <a:prstDash val="solid"/>
+          <a:miter lim="800000"/>
+        </a:ln>
+      </a:lnStyleLst>
+      <a:effectStyleLst>
+        <a:effectStyle>
+          <a:effectLst/>
+        </a:effectStyle>
+        <a:effectStyle>
+          <a:effectLst/>
+        </a:effectStyle>
+        <a:effectStyle>
+          <a:effectLst>
+            <a:outerShdw blurRad="57150" dist="19050" dir="5400000" algn="ctr" rotWithShape="0">
+              <a:srgbClr val="000000">
+                <a:alpha val="63000"/>
+              </a:srgbClr>
+            </a:outerShdw>
+          </a:effectLst>
+        </a:effectStyle>
+      </a:effectStyleLst>
+      <a:bgFillStyleLst>
+        <a:solidFill>
+          <a:schemeClr val="phClr"/>
+        </a:solidFill>
+        <a:solidFill>
+          <a:schemeClr val="phClr">
+            <a:tint val="95000"/>
+            <a:satMod val="170000"/>
+          </a:schemeClr>
+        </a:solidFill>
+        <a:gradFill rotWithShape="1">
+          <a:gsLst>
+            <a:gs pos="0">
+              <a:schemeClr val="phClr">
+                <a:tint val="93000"/>
+                <a:satMod val="150000"/>
+                <a:shade val="98000"/>
+                <a:lumMod val="102000"/>
+              </a:schemeClr>
+            </a:gs>
+            <a:gs pos="50000">
+              <a:schemeClr val="phClr">
+                <a:tint val="98000"/>
+                <a:satMod val="130000"/>
+                <a:shade val="90000"/>
+                <a:lumMod val="103000"/>
+              </a:schemeClr>
+            </a:gs>
+            <a:gs pos="100000">
+              <a:schemeClr val="phClr">
+                <a:shade val="63000"/>
+                <a:satMod val="120000"/>
+              </a:schemeClr>
+            </a:gs>
+          </a:gsLst>
+          <a:lin ang="5400000" scaled="0"/>
+        </a:gradFill>
+      </a:bgFillStyleLst>
+    </a:fmtScheme>
+  </a:themeElements>
+  <a:objectDefaults/>
+  <a:extraClrSchemeLst/>
+  <a:extLst>
+    <a:ext uri="{05A4C25C-085E-4340-85A3-A5531E510DB2}">
+      <thm15:themeFamily xmlns:thm15="http://schemas.microsoft.com/office/thememl/2012/main" name="Office Theme" id="{62F939B6-93AF-4DB8-9C6B-D6C7DFDC589F}" vid="{4A3C46E8-61CC-4603-A589-7422A47A8E4A}"/>
+    </a:ext>
+  </a:extLst>
+</a:theme>
 </file>
</xml_diff>